<commit_message>
Hồ sơ năng lực BLT: bổ sung ảnh đội ngũ và trạm xử lý nước Huế
Thay ảnh tập thể đội thi công ở trang nhân sự, thêm ảnh chỉ huy công trình
Huế (19/09), ảnh hệ màng UF và bồn hóa chất ở trang bơm & xử lý nước.

Co-Authored-By: Claude Opus 5.5 <noreply@anthropic.com>
Claude-Session: https://claude.ai/code/session_01SkwAuDP5YjDrv41kDvnzWb
</commit_message>
<xml_diff>
--- a/ho-so-nang-luc-BLT/HO_SO_NANG_LUC_BLT.pptx
+++ b/ho-so-nang-luc-BLT/HO_SO_NANG_LUC_BLT.pptx
@@ -132,14 +132,14 @@
   <p:extLst>
     <p:ext uri="{521415D9-36F7-43E2-AB2F-B90AF26B5E84}">
       <p14:sectionLst xmlns:p14="http://schemas.microsoft.com/office/powerpoint/2010/main">
-        <p14:section name="Mở đầu" id="{26c2cbe2-5435-2784-9045-37cc22e1cf70}">
+        <p14:section name="Mở đầu" id="{520515a1-b3d7-0381-950e-16aab9da672d}">
           <p14:sldIdLst>
             <p14:sldId id="256"/>
             <p14:sldId id="257"/>
             <p14:sldId id="258"/>
           </p14:sldIdLst>
         </p14:section>
-        <p14:section name="01 Tổng quan" id="{e35e47d5-44fc-2747-424a-152f5324c86c}">
+        <p14:section name="01 Tổng quan" id="{b2cd6b12-3929-265b-c98f-31629d2fb868}">
           <p14:sldIdLst>
             <p14:sldId id="259"/>
             <p14:sldId id="260"/>
@@ -148,39 +148,39 @@
             <p14:sldId id="263"/>
           </p14:sldIdLst>
         </p14:section>
-        <p14:section name="02 Điện nước công trình" id="{0b63af51-de95-6c5e-9ad5-5348f2f52c55}">
+        <p14:section name="02 Điện nước công trình" id="{e274f42b-5430-f19a-bb4d-c73d70c01f49}">
           <p14:sldIdLst>
             <p14:sldId id="264"/>
             <p14:sldId id="265"/>
             <p14:sldId id="266"/>
           </p14:sldIdLst>
         </p14:section>
-        <p14:section name="03 Hút sương dầu nhà xưởng" id="{21b66b15-28d0-1664-80fb-891364fc1551}">
+        <p14:section name="03 Hút sương dầu nhà xưởng" id="{7045e8b1-0b3b-89ca-35a4-3265bdd5d3aa}">
           <p14:sldIdLst>
             <p14:sldId id="267"/>
             <p14:sldId id="268"/>
             <p14:sldId id="269"/>
           </p14:sldIdLst>
         </p14:section>
-        <p14:section name="04 Bơm &amp; xử lý nước" id="{e263b8d2-e9c6-8ffa-2148-1470568bc915}">
+        <p14:section name="04 Bơm &amp; xử lý nước" id="{ef75f51d-509d-738f-12a4-e350022ed294}">
           <p14:sldIdLst>
             <p14:sldId id="270"/>
           </p14:sldIdLst>
         </p14:section>
-        <p14:section name="05 Quản trị dự án" id="{b9603bc3-fb41-8c6f-2ec6-23293c7e8c8e}">
+        <p14:section name="05 Quản trị dự án" id="{929e1f16-04b8-a96f-ae2b-56e605932ee7}">
           <p14:sldIdLst>
             <p14:sldId id="271"/>
             <p14:sldId id="272"/>
             <p14:sldId id="273"/>
           </p14:sldIdLst>
         </p14:section>
-        <p14:section name="06 Nguồn lực" id="{e2c384e7-8963-b867-74ca-342c9e025354}">
+        <p14:section name="06 Nguồn lực" id="{f981e69c-bc4b-40f3-0d24-20bf1965aa93}">
           <p14:sldIdLst>
             <p14:sldId id="274"/>
             <p14:sldId id="275"/>
           </p14:sldIdLst>
         </p14:section>
-        <p14:section name="07 Công trình tiêu biểu" id="{0bdc39f4-9c2e-c93c-e635-e04c4759787d}">
+        <p14:section name="07 Công trình tiêu biểu" id="{8ef74281-28dc-f782-8548-071d3cd20635}">
           <p14:sldIdLst>
             <p14:sldId id="276"/>
             <p14:sldId id="277"/>
@@ -188,7 +188,7 @@
             <p14:sldId id="279"/>
           </p14:sldIdLst>
         </p14:section>
-        <p14:section name="08 Cam kết &amp; liên hệ" id="{82a961f7-7350-0d98-8f46-9af212f541a7}">
+        <p14:section name="08 Cam kết &amp; liên hệ" id="{74f006b4-3b18-c029-d79d-5f421863241c}">
           <p14:sldIdLst>
             <p14:sldId id="280"/>
             <p14:sldId id="281"/>
@@ -8604,7 +8604,7 @@
         <p:spPr>
           <a:xfrm>
             <a:off x="502920" y="5760720"/>
-            <a:ext cx="3140964" cy="2743200"/>
+            <a:ext cx="3140964" cy="2651760"/>
           </a:xfrm>
           <a:prstGeom prst="rect">
             <a:avLst/>
@@ -8773,11 +8773,11 @@
         <p:spPr>
           <a:xfrm>
             <a:off x="3918204" y="5760720"/>
-            <a:ext cx="3140964" cy="2743200"/>
+            <a:ext cx="3140964" cy="2606040"/>
           </a:xfrm>
           <a:prstGeom prst="roundRect">
             <a:avLst>
-              <a:gd name="adj" fmla="val 2667"/>
+              <a:gd name="adj" fmla="val 2807"/>
             </a:avLst>
           </a:prstGeom>
           <a:solidFill>
@@ -8887,7 +8887,7 @@
       </p:sp>
       <p:pic>
         <p:nvPicPr>
-          <p:cNvPr id="11" name="photo img48.jpg" descr="Ảnh hiện trường BLT">    </p:cNvPr>
+          <p:cNvPr id="11" name="photo img61.jpg" descr="Ảnh hiện trường BLT">    </p:cNvPr>
           <p:cNvPicPr>
             <a:picLocks noChangeAspect="1"/>
           </p:cNvPicPr>
@@ -8901,8 +8901,8 @@
         </p:blipFill>
         <p:spPr>
           <a:xfrm>
-            <a:off x="502920" y="8732520"/>
-            <a:ext cx="2063496" cy="1051560"/>
+            <a:off x="502920" y="8641080"/>
+            <a:ext cx="2063496" cy="1188720"/>
           </a:xfrm>
           <a:prstGeom prst="rect">
             <a:avLst/>
@@ -8911,7 +8911,7 @@
       </p:pic>
       <p:pic>
         <p:nvPicPr>
-          <p:cNvPr id="12" name="photo img16.jpg" descr="Ảnh hiện trường BLT">    </p:cNvPr>
+          <p:cNvPr id="12" name="photo img60.jpg" descr="Ảnh hiện trường BLT">    </p:cNvPr>
           <p:cNvPicPr>
             <a:picLocks noChangeAspect="1"/>
           </p:cNvPicPr>
@@ -8925,8 +8925,8 @@
         </p:blipFill>
         <p:spPr>
           <a:xfrm>
-            <a:off x="2749296" y="8732520"/>
-            <a:ext cx="2063496" cy="1051560"/>
+            <a:off x="2749296" y="8641080"/>
+            <a:ext cx="2063496" cy="1188720"/>
           </a:xfrm>
           <a:prstGeom prst="rect">
             <a:avLst/>
@@ -8949,8 +8949,8 @@
         </p:blipFill>
         <p:spPr>
           <a:xfrm>
-            <a:off x="4995672" y="8732520"/>
-            <a:ext cx="2063496" cy="1051560"/>
+            <a:off x="4995672" y="8641080"/>
+            <a:ext cx="2063496" cy="1188720"/>
           </a:xfrm>
           <a:prstGeom prst="rect">
             <a:avLst/>
@@ -14357,7 +14357,7 @@
       </p:sp>
       <p:pic>
         <p:nvPicPr>
-          <p:cNvPr id="5" name="photo img35.jpg" descr="Đội ngũ kỹ thuật BLT – xã Hưng Nguyên, Nghệ An (04/10/2026)">    </p:cNvPr>
+          <p:cNvPr id="5" name="photo img57.jpg" descr="Đội thi công BLT tại trạm xử lý nước – Thành phố Huế (17/09/2026)">    </p:cNvPr>
           <p:cNvPicPr>
             <a:picLocks noChangeAspect="1"/>
           </p:cNvPicPr>
@@ -14411,7 +14411,7 @@
                   <a:schemeClr val="accent3"/>
                 </a:solidFill>
               </a:rPr>
-              <a:t>Đội ngũ kỹ thuật BLT – xã Hưng Nguyên, Nghệ An (04/10/2026)</a:t>
+              <a:t>Đội thi công BLT tại trạm xử lý nước – Thành phố Huế (17/09/2026)</a:t>
             </a:r>
             <a:endParaRPr lang="en-US" sz="800" dirty="0"/>
           </a:p>
@@ -23360,7 +23360,7 @@
       </p:sp>
       <p:pic>
         <p:nvPicPr>
-          <p:cNvPr id="13" name="photo img46.jpg" descr="Tập kết thiết bị trong nhà xưởng">    </p:cNvPr>
+          <p:cNvPr id="13" name="photo img56.jpg" descr="Chỉ huy và đội thi công tại trạm (19/09/2026)">    </p:cNvPr>
           <p:cNvPicPr>
             <a:picLocks noChangeAspect="1"/>
           </p:cNvPicPr>
@@ -23414,7 +23414,7 @@
                   <a:schemeClr val="accent3"/>
                 </a:solidFill>
               </a:rPr>
-              <a:t>Tập kết thiết bị trong nhà xưởng</a:t>
+              <a:t>Chỉ huy và đội thi công tại trạm (19/09/2026)</a:t>
             </a:r>
             <a:endParaRPr lang="en-US" sz="800" dirty="0"/>
           </a:p>

</xml_diff>

<commit_message>
Hồ sơ năng lực BLT: cập nhật đội ngũ 50 người
Đổi số nhân sự trên trang giới thiệu, thư ngỏ và trang cơ cấu nhân sự.

Co-Authored-By: Claude Opus 5.5 <noreply@anthropic.com>
Claude-Session: https://claude.ai/code/session_01SkwAuDP5YjDrv41kDvnzWb
</commit_message>
<xml_diff>
--- a/ho-so-nang-luc-BLT/HO_SO_NANG_LUC_BLT.pptx
+++ b/ho-so-nang-luc-BLT/HO_SO_NANG_LUC_BLT.pptx
@@ -132,14 +132,14 @@
   <p:extLst>
     <p:ext uri="{521415D9-36F7-43E2-AB2F-B90AF26B5E84}">
       <p14:sectionLst xmlns:p14="http://schemas.microsoft.com/office/powerpoint/2010/main">
-        <p14:section name="Mở đầu" id="{40b33bb2-b6d9-e86a-0ad3-5191760a0fc4}">
+        <p14:section name="Mở đầu" id="{2ec8ac14-cd5b-1cf6-96d5-baa4130c9a40}">
           <p14:sldIdLst>
             <p14:sldId id="256"/>
             <p14:sldId id="257"/>
             <p14:sldId id="258"/>
           </p14:sldIdLst>
         </p14:section>
-        <p14:section name="01 Tổng quan" id="{410dacaa-1005-0b01-06e4-b954eda0a175}">
+        <p14:section name="01 Tổng quan" id="{a9abe568-a6f5-5364-a6ae-d792b97546b9}">
           <p14:sldIdLst>
             <p14:sldId id="259"/>
             <p14:sldId id="260"/>
@@ -148,39 +148,39 @@
             <p14:sldId id="263"/>
           </p14:sldIdLst>
         </p14:section>
-        <p14:section name="02 Điện nước công trình" id="{9e76d6bf-a0ef-9e47-2ab5-0177308bd443}">
+        <p14:section name="02 Điện nước công trình" id="{66584b92-fd91-1a86-5927-ddd2a464c842}">
           <p14:sldIdLst>
             <p14:sldId id="264"/>
             <p14:sldId id="265"/>
             <p14:sldId id="266"/>
           </p14:sldIdLst>
         </p14:section>
-        <p14:section name="03 Hút sương dầu nhà xưởng" id="{a92a3d47-b56a-9f87-eeeb-0e000621313c}">
+        <p14:section name="03 Hút sương dầu nhà xưởng" id="{2dd76863-574d-d2d5-0410-d47ca529832e}">
           <p14:sldIdLst>
             <p14:sldId id="267"/>
             <p14:sldId id="268"/>
             <p14:sldId id="269"/>
           </p14:sldIdLst>
         </p14:section>
-        <p14:section name="04 Bơm &amp; xử lý nước" id="{0ed2a60e-5a51-bfb5-2ff4-ff62fefeee1a}">
+        <p14:section name="04 Bơm &amp; xử lý nước" id="{3239c8a7-1416-305b-2bc5-e2b06065fb82}">
           <p14:sldIdLst>
             <p14:sldId id="270"/>
           </p14:sldIdLst>
         </p14:section>
-        <p14:section name="05 Quản trị dự án" id="{f9200934-b2ac-d757-e198-0ebb601adfe6}">
+        <p14:section name="05 Quản trị dự án" id="{b2df1781-af03-e34c-749c-8a17c35e14ca}">
           <p14:sldIdLst>
             <p14:sldId id="271"/>
             <p14:sldId id="272"/>
             <p14:sldId id="273"/>
           </p14:sldIdLst>
         </p14:section>
-        <p14:section name="06 Nguồn lực" id="{37878bd4-bdef-a2bc-b9b6-422516f8ef52}">
+        <p14:section name="06 Nguồn lực" id="{4d54e0ed-3836-55df-d266-c496a339a5f3}">
           <p14:sldIdLst>
             <p14:sldId id="274"/>
             <p14:sldId id="275"/>
           </p14:sldIdLst>
         </p14:section>
-        <p14:section name="07 Công trình tiêu biểu" id="{404a7f33-a4d1-85f7-9684-94e897b8f9d3}">
+        <p14:section name="07 Công trình tiêu biểu" id="{a0cf37b7-1fc9-6446-e1ff-1ec7d6432dd9}">
           <p14:sldIdLst>
             <p14:sldId id="276"/>
             <p14:sldId id="277"/>
@@ -188,7 +188,7 @@
             <p14:sldId id="279"/>
           </p14:sldIdLst>
         </p14:section>
-        <p14:section name="08 Cam kết &amp; liên hệ" id="{0a70edd3-066b-dbcb-e066-ddd5a2854b1e}">
+        <p14:section name="08 Cam kết &amp; liên hệ" id="{ee14ec3e-3f4f-88af-a773-a6c799bd40ac}">
           <p14:sldIdLst>
             <p14:sldId id="280"/>
             <p14:sldId id="281"/>
@@ -15481,7 +15481,7 @@
                   <a:schemeClr val="tx1"/>
                 </a:solidFill>
               </a:rPr>
-              <a:t>Lực lượng thi công 15+ người, huy động linh hoạt theo quy mô và tiến độ từng công trình</a:t>
+              <a:t>Đội ngũ 50 người gồm cán bộ kỹ thuật, chỉ huy công trường và công nhân lành nghề, huy động linh hoạt theo tiến độ</a:t>
             </a:r>
             <a:endParaRPr lang="en-US" sz="950" dirty="0"/>
           </a:p>
@@ -28027,7 +28027,7 @@
                   <a:schemeClr val="tx1"/>
                 </a:solidFill>
               </a:rPr>
-              <a:t>BLT là đơn vị thi công chuyên sâu về hệ thống kỹ thuật công trình: điện, cấp thoát nước, đường ống công nghệ, hệ thống hút sương dầu – lọc khí cho nhà xưởng và hệ thống bơm – xử lý nước. Đội ngũ của chúng tôi đang trực tiếp thi công tại nhiều công trình ở Nghệ An, Ninh Bình và Thành phố Huế, từ công trình nhiều tầng đến nhà xưởng sản xuất đang vận hành.</a:t>
+              <a:t>BLT là đơn vị thi công chuyên sâu về hệ thống kỹ thuật công trình: điện, cấp thoát nước, đường ống công nghệ, hệ thống hút sương dầu – lọc khí cho nhà xưởng và hệ thống bơm – xử lý nước. Đội ngũ 50 người của chúng tôi đang trực tiếp thi công tại nhiều công trình ở Nghệ An, Ninh Bình và Thành phố Huế, từ công trình nhiều tầng đến nhà xưởng sản xuất đang vận hành.</a:t>
             </a:r>
             <a:endParaRPr lang="en-US" sz="1150" dirty="0"/>
           </a:p>
@@ -28788,7 +28788,7 @@
                 <a:ea typeface="Arial" pitchFamily="34" charset="-122"/>
                 <a:cs typeface="Arial" pitchFamily="34" charset="-120"/>
               </a:rPr>
-              <a:t>15+</a:t>
+              <a:t>50</a:t>
             </a:r>
             <a:endParaRPr lang="en-US" sz="3000" dirty="0"/>
           </a:p>
@@ -28824,7 +28824,7 @@
                   <a:schemeClr val="bg1"/>
                 </a:solidFill>
               </a:rPr>
-              <a:t>NHÂN SỰ THI CÔNG</a:t>
+              <a:t>NHÂN SỰ</a:t>
             </a:r>
             <a:endParaRPr lang="en-US" sz="850" dirty="0"/>
           </a:p>
@@ -28860,7 +28860,7 @@
                   <a:schemeClr val="accent4"/>
                 </a:solidFill>
               </a:rPr>
-              <a:t>huy động linh hoạt theo tiến độ</a:t>
+              <a:t>kỹ thuật, chỉ huy và công nhân thi công</a:t>
             </a:r>
             <a:endParaRPr lang="en-US" sz="800" dirty="0"/>
           </a:p>

</xml_diff>

<commit_message>
Hồ sơ năng lực BLT: bìa ghép ảnh đội ngũ công nhân
Thay ảnh bìa bằng bố cục ghép ảnh tập thể đội thi công tại các công trình,
thêm nhãn Đội ngũ 50 nhân sự, chuyển logo xuống dải tiêu đề.

Co-Authored-By: Claude Opus 5.5 <noreply@anthropic.com>
Claude-Session: https://claude.ai/code/session_01SkwAuDP5YjDrv41kDvnzWb
</commit_message>
<xml_diff>
--- a/ho-so-nang-luc-BLT/HO_SO_NANG_LUC_BLT.pptx
+++ b/ho-so-nang-luc-BLT/HO_SO_NANG_LUC_BLT.pptx
@@ -132,14 +132,14 @@
   <p:extLst>
     <p:ext uri="{521415D9-36F7-43E2-AB2F-B90AF26B5E84}">
       <p14:sectionLst xmlns:p14="http://schemas.microsoft.com/office/powerpoint/2010/main">
-        <p14:section name="Mở đầu" id="{2ec8ac14-cd5b-1cf6-96d5-baa4130c9a40}">
+        <p14:section name="Mở đầu" id="{55715496-9de9-e922-bdf8-e0140192ff91}">
           <p14:sldIdLst>
             <p14:sldId id="256"/>
             <p14:sldId id="257"/>
             <p14:sldId id="258"/>
           </p14:sldIdLst>
         </p14:section>
-        <p14:section name="01 Tổng quan" id="{a9abe568-a6f5-5364-a6ae-d792b97546b9}">
+        <p14:section name="01 Tổng quan" id="{17fca54e-8d1d-380a-b214-b40fe5da3ae4}">
           <p14:sldIdLst>
             <p14:sldId id="259"/>
             <p14:sldId id="260"/>
@@ -148,39 +148,39 @@
             <p14:sldId id="263"/>
           </p14:sldIdLst>
         </p14:section>
-        <p14:section name="02 Điện nước công trình" id="{66584b92-fd91-1a86-5927-ddd2a464c842}">
+        <p14:section name="02 Điện nước công trình" id="{92e6f1a4-c17d-7018-feb0-1258c2413746}">
           <p14:sldIdLst>
             <p14:sldId id="264"/>
             <p14:sldId id="265"/>
             <p14:sldId id="266"/>
           </p14:sldIdLst>
         </p14:section>
-        <p14:section name="03 Hút sương dầu nhà xưởng" id="{2dd76863-574d-d2d5-0410-d47ca529832e}">
+        <p14:section name="03 Hút sương dầu nhà xưởng" id="{33c11192-cb4c-2084-34a2-43e17a0098c7}">
           <p14:sldIdLst>
             <p14:sldId id="267"/>
             <p14:sldId id="268"/>
             <p14:sldId id="269"/>
           </p14:sldIdLst>
         </p14:section>
-        <p14:section name="04 Bơm &amp; xử lý nước" id="{3239c8a7-1416-305b-2bc5-e2b06065fb82}">
+        <p14:section name="04 Bơm &amp; xử lý nước" id="{9fe28723-a0df-e9df-b913-1e83ea03b5b2}">
           <p14:sldIdLst>
             <p14:sldId id="270"/>
           </p14:sldIdLst>
         </p14:section>
-        <p14:section name="05 Quản trị dự án" id="{b2df1781-af03-e34c-749c-8a17c35e14ca}">
+        <p14:section name="05 Quản trị dự án" id="{cdfde152-a3c2-26dd-29b1-6f65f5c527ae}">
           <p14:sldIdLst>
             <p14:sldId id="271"/>
             <p14:sldId id="272"/>
             <p14:sldId id="273"/>
           </p14:sldIdLst>
         </p14:section>
-        <p14:section name="06 Nguồn lực" id="{4d54e0ed-3836-55df-d266-c496a339a5f3}">
+        <p14:section name="06 Nguồn lực" id="{77766e98-97c0-d22b-6c15-5ee7c3cb9951}">
           <p14:sldIdLst>
             <p14:sldId id="274"/>
             <p14:sldId id="275"/>
           </p14:sldIdLst>
         </p14:section>
-        <p14:section name="07 Công trình tiêu biểu" id="{a0cf37b7-1fc9-6446-e1ff-1ec7d6432dd9}">
+        <p14:section name="07 Công trình tiêu biểu" id="{d11c1036-f9d9-a780-485d-0947a8e2abca}">
           <p14:sldIdLst>
             <p14:sldId id="276"/>
             <p14:sldId id="277"/>
@@ -188,7 +188,7 @@
             <p14:sldId id="279"/>
           </p14:sldIdLst>
         </p14:section>
-        <p14:section name="08 Cam kết &amp; liên hệ" id="{ee14ec3e-3f4f-88af-a773-a6c799bd40ac}">
+        <p14:section name="08 Cam kết &amp; liên hệ" id="{adde38f6-93e1-9292-1e23-4767d8fea2ba}">
           <p14:sldIdLst>
             <p14:sldId id="280"/>
             <p14:sldId id="281"/>
@@ -3574,7 +3574,7 @@
       </p:grpSpPr>
       <p:pic>
         <p:nvPicPr>
-          <p:cNvPr id="2" name="cover photo" descr="preencoded.png">    </p:cNvPr>
+          <p:cNvPr id="2" name="cover team img57.jpg" descr="Đội ngũ công nhân BLT">    </p:cNvPr>
           <p:cNvPicPr>
             <a:picLocks noChangeAspect="1"/>
           </p:cNvPicPr>
@@ -3589,45 +3589,16 @@
         <p:spPr>
           <a:xfrm>
             <a:off x="0" y="0"/>
-            <a:ext cx="7562088" cy="6583680"/>
+            <a:ext cx="7562088" cy="3977640"/>
           </a:xfrm>
           <a:prstGeom prst="rect">
             <a:avLst/>
           </a:prstGeom>
         </p:spPr>
       </p:pic>
-      <p:sp>
-        <p:nvSpPr>
-          <p:cNvPr id="3" name="Shape 0"/>
-          <p:cNvSpPr/>
-          <p:nvPr/>
-        </p:nvSpPr>
-        <p:spPr>
-          <a:xfrm>
-            <a:off x="0" y="0"/>
-            <a:ext cx="7562088" cy="6583680"/>
-          </a:xfrm>
-          <a:prstGeom prst="rect">
-            <a:avLst/>
-          </a:prstGeom>
-          <a:solidFill>
-            <a:schemeClr val="tx2">
-              <a:alpha val="30000"/>
-            </a:schemeClr>
-          </a:solidFill>
-          <a:ln w="12700">
-            <a:solidFill>
-              <a:schemeClr val="tx2">
-                <a:alpha val="0"/>
-              </a:schemeClr>
-            </a:solidFill>
-            <a:prstDash val="solid"/>
-          </a:ln>
-        </p:spPr>
-      </p:sp>
       <p:pic>
         <p:nvPicPr>
-          <p:cNvPr id="4" name="logo" descr="preencoded.png">    </p:cNvPr>
+          <p:cNvPr id="3" name="cover team img45.jpg" descr="Đội ngũ công nhân BLT">    </p:cNvPr>
           <p:cNvPicPr>
             <a:picLocks noChangeAspect="1"/>
           </p:cNvPicPr>
@@ -3641,17 +3612,131 @@
         </p:blipFill>
         <p:spPr>
           <a:xfrm>
-            <a:off x="502920" y="457200"/>
-            <a:ext cx="1143000" cy="1143000"/>
+            <a:off x="0" y="4050792"/>
+            <a:ext cx="2471928" cy="2532888"/>
           </a:xfrm>
           <a:prstGeom prst="rect">
             <a:avLst/>
           </a:prstGeom>
         </p:spPr>
       </p:pic>
-      <p:sp>
-        <p:nvSpPr>
-          <p:cNvPr id="5" name="Shape 1"/>
+      <p:pic>
+        <p:nvPicPr>
+          <p:cNvPr id="4" name="cover team img35.jpg" descr="Đội ngũ công nhân BLT">    </p:cNvPr>
+          <p:cNvPicPr>
+            <a:picLocks noChangeAspect="1"/>
+          </p:cNvPicPr>
+          <p:nvPr/>
+        </p:nvPicPr>
+        <p:blipFill>
+          <a:blip r:embed="rId3"/>
+          <a:stretch>
+            <a:fillRect/>
+          </a:stretch>
+        </p:blipFill>
+        <p:spPr>
+          <a:xfrm>
+            <a:off x="2545080" y="4050792"/>
+            <a:ext cx="2471928" cy="2532888"/>
+          </a:xfrm>
+          <a:prstGeom prst="rect">
+            <a:avLst/>
+          </a:prstGeom>
+        </p:spPr>
+      </p:pic>
+      <p:pic>
+        <p:nvPicPr>
+          <p:cNvPr id="5" name="cover team img56.jpg" descr="Đội ngũ công nhân BLT">    </p:cNvPr>
+          <p:cNvPicPr>
+            <a:picLocks noChangeAspect="1"/>
+          </p:cNvPicPr>
+          <p:nvPr/>
+        </p:nvPicPr>
+        <p:blipFill>
+          <a:blip r:embed="rId4"/>
+          <a:stretch>
+            <a:fillRect/>
+          </a:stretch>
+        </p:blipFill>
+        <p:spPr>
+          <a:xfrm>
+            <a:off x="5090160" y="4050792"/>
+            <a:ext cx="2471928" cy="2532888"/>
+          </a:xfrm>
+          <a:prstGeom prst="rect">
+            <a:avLst/>
+          </a:prstGeom>
+        </p:spPr>
+      </p:pic>
+      <p:sp>
+        <p:nvSpPr>
+          <p:cNvPr id="6" name="Shape 0"/>
+          <p:cNvSpPr/>
+          <p:nvPr/>
+        </p:nvSpPr>
+        <p:spPr>
+          <a:xfrm>
+            <a:off x="4544568" y="3364992"/>
+            <a:ext cx="2514600" cy="457200"/>
+          </a:xfrm>
+          <a:prstGeom prst="roundRect">
+            <a:avLst>
+              <a:gd name="adj" fmla="val 16000"/>
+            </a:avLst>
+          </a:prstGeom>
+          <a:solidFill>
+            <a:schemeClr val="accent1"/>
+          </a:solidFill>
+          <a:ln w="12700">
+            <a:solidFill>
+              <a:schemeClr val="accent1"/>
+            </a:solidFill>
+            <a:prstDash val="solid"/>
+          </a:ln>
+        </p:spPr>
+      </p:sp>
+      <p:sp>
+        <p:nvSpPr>
+          <p:cNvPr id="7" name="Text 1"/>
+          <p:cNvSpPr txBox="1"/>
+          <p:nvPr/>
+        </p:nvSpPr>
+        <p:spPr>
+          <a:xfrm>
+            <a:off x="4544568" y="3364992"/>
+            <a:ext cx="2514600" cy="457200"/>
+          </a:xfrm>
+          <a:prstGeom prst="rect">
+            <a:avLst/>
+          </a:prstGeom>
+          <a:noFill/>
+          <a:ln/>
+        </p:spPr>
+        <p:txBody>
+          <a:bodyPr wrap="square" lIns="0" tIns="0" rIns="0" bIns="0" rtlCol="0" anchor="ctr"/>
+          <a:lstStyle/>
+          <a:p>
+            <a:pPr algn="ctr" indent="0" marL="0">
+              <a:buNone/>
+            </a:pPr>
+            <a:r>
+              <a:rPr lang="en-US" sz="1400" b="1" spc="100" kern="0" dirty="0">
+                <a:solidFill>
+                  <a:schemeClr val="bg1"/>
+                </a:solidFill>
+                <a:latin typeface="Arial" pitchFamily="34" charset="0"/>
+                <a:ea typeface="Arial" pitchFamily="34" charset="-122"/>
+                <a:cs typeface="Arial" pitchFamily="34" charset="-120"/>
+              </a:rPr>
+              <a:t>ĐỘI NGŨ 50 NHÂN SỰ</a:t>
+            </a:r>
+            <a:endParaRPr lang="en-US" sz="1400" dirty="0"/>
+          </a:p>
+        </p:txBody>
+      </p:sp>
+      <p:sp>
+        <p:nvSpPr>
+          <p:cNvPr id="8" name="Shape 2"/>
           <p:cNvSpPr/>
           <p:nvPr/>
         </p:nvSpPr>
@@ -3674,16 +3759,40 @@
           </a:ln>
         </p:spPr>
       </p:sp>
-      <p:sp>
-        <p:nvSpPr>
-          <p:cNvPr id="6" name="Text 2"/>
+      <p:pic>
+        <p:nvPicPr>
+          <p:cNvPr id="9" name="logo" descr="preencoded.png">    </p:cNvPr>
+          <p:cNvPicPr>
+            <a:picLocks noChangeAspect="1"/>
+          </p:cNvPicPr>
+          <p:nvPr/>
+        </p:nvPicPr>
+        <p:blipFill>
+          <a:blip r:embed="rId5"/>
+          <a:stretch>
+            <a:fillRect/>
+          </a:stretch>
+        </p:blipFill>
+        <p:spPr>
+          <a:xfrm>
+            <a:off x="6007608" y="6903720"/>
+            <a:ext cx="1051560" cy="1051560"/>
+          </a:xfrm>
+          <a:prstGeom prst="rect">
+            <a:avLst/>
+          </a:prstGeom>
+        </p:spPr>
+      </p:pic>
+      <p:sp>
+        <p:nvSpPr>
+          <p:cNvPr id="10" name="Text 3"/>
           <p:cNvSpPr txBox="1"/>
           <p:nvPr/>
         </p:nvSpPr>
         <p:spPr>
           <a:xfrm>
             <a:off x="502920" y="6903720"/>
-            <a:ext cx="6556248" cy="274320"/>
+            <a:ext cx="4937760" cy="274320"/>
           </a:xfrm>
           <a:prstGeom prst="rect">
             <a:avLst/>
@@ -3715,14 +3824,14 @@
       </p:sp>
       <p:sp>
         <p:nvSpPr>
-          <p:cNvPr id="7" name="Text 3"/>
+          <p:cNvPr id="11" name="Text 4"/>
           <p:cNvSpPr txBox="1"/>
           <p:nvPr/>
         </p:nvSpPr>
         <p:spPr>
           <a:xfrm>
             <a:off x="502920" y="7178040"/>
-            <a:ext cx="6556248" cy="411480"/>
+            <a:ext cx="4937760" cy="411480"/>
           </a:xfrm>
           <a:prstGeom prst="rect">
             <a:avLst/>
@@ -3754,7 +3863,7 @@
       </p:sp>
       <p:sp>
         <p:nvSpPr>
-          <p:cNvPr id="8" name="Text 4"/>
+          <p:cNvPr id="12" name="Text 5"/>
           <p:cNvSpPr txBox="1"/>
           <p:nvPr/>
         </p:nvSpPr>
@@ -3807,7 +3916,7 @@
       </p:sp>
       <p:sp>
         <p:nvSpPr>
-          <p:cNvPr id="9" name="Text 5"/>
+          <p:cNvPr id="13" name="Text 6"/>
           <p:cNvSpPr txBox="1"/>
           <p:nvPr/>
         </p:nvSpPr>
@@ -3843,7 +3952,7 @@
       </p:sp>
       <p:sp>
         <p:nvSpPr>
-          <p:cNvPr id="10" name="Text 6"/>
+          <p:cNvPr id="14" name="Text 7"/>
           <p:cNvSpPr txBox="1"/>
           <p:nvPr/>
         </p:nvSpPr>
@@ -3879,7 +3988,7 @@
       </p:sp>
       <p:sp>
         <p:nvSpPr>
-          <p:cNvPr id="11" name="Text 7"/>
+          <p:cNvPr id="15" name="Text 8"/>
           <p:cNvSpPr txBox="1"/>
           <p:nvPr/>
         </p:nvSpPr>
@@ -3915,7 +4024,7 @@
       </p:sp>
       <p:sp>
         <p:nvSpPr>
-          <p:cNvPr id="12" name="Text 8"/>
+          <p:cNvPr id="16" name="Text 9"/>
           <p:cNvSpPr txBox="1"/>
           <p:nvPr/>
         </p:nvSpPr>

</xml_diff>

<commit_message>
Hồ sơ năng lực BLT: thêm ảnh đội thi công Quảng Trị và phối cảnh nhà phố
Bìa: thay một ô ảnh bằng ảnh đội thi công tại Gio Linh, Quảng Trị.
Trang 9: ghép ảnh hiện trường với phối cảnh nhà phố, gắn nhãn phối cảnh minh họa.

Co-Authored-By: Claude Opus 5.5 <noreply@anthropic.com>
Claude-Session: https://claude.ai/code/session_01SkwAuDP5YjDrv41kDvnzWb
</commit_message>
<xml_diff>
--- a/ho-so-nang-luc-BLT/HO_SO_NANG_LUC_BLT.pptx
+++ b/ho-so-nang-luc-BLT/HO_SO_NANG_LUC_BLT.pptx
@@ -132,14 +132,14 @@
   <p:extLst>
     <p:ext uri="{521415D9-36F7-43E2-AB2F-B90AF26B5E84}">
       <p14:sectionLst xmlns:p14="http://schemas.microsoft.com/office/powerpoint/2010/main">
-        <p14:section name="Mở đầu" id="{55715496-9de9-e922-bdf8-e0140192ff91}">
+        <p14:section name="Mở đầu" id="{4a27b49f-14f7-d116-363b-8b4b3f418060}">
           <p14:sldIdLst>
             <p14:sldId id="256"/>
             <p14:sldId id="257"/>
             <p14:sldId id="258"/>
           </p14:sldIdLst>
         </p14:section>
-        <p14:section name="01 Tổng quan" id="{17fca54e-8d1d-380a-b214-b40fe5da3ae4}">
+        <p14:section name="01 Tổng quan" id="{31e3abc5-57c4-fada-442d-c61aa42356be}">
           <p14:sldIdLst>
             <p14:sldId id="259"/>
             <p14:sldId id="260"/>
@@ -148,39 +148,39 @@
             <p14:sldId id="263"/>
           </p14:sldIdLst>
         </p14:section>
-        <p14:section name="02 Điện nước công trình" id="{92e6f1a4-c17d-7018-feb0-1258c2413746}">
+        <p14:section name="02 Điện nước công trình" id="{73013b9b-c3e7-1522-b6db-543fff4305ed}">
           <p14:sldIdLst>
             <p14:sldId id="264"/>
             <p14:sldId id="265"/>
             <p14:sldId id="266"/>
           </p14:sldIdLst>
         </p14:section>
-        <p14:section name="03 Hút sương dầu nhà xưởng" id="{33c11192-cb4c-2084-34a2-43e17a0098c7}">
+        <p14:section name="03 Hút sương dầu nhà xưởng" id="{a3335cf2-3af5-15f6-3b04-01b4d8675f49}">
           <p14:sldIdLst>
             <p14:sldId id="267"/>
             <p14:sldId id="268"/>
             <p14:sldId id="269"/>
           </p14:sldIdLst>
         </p14:section>
-        <p14:section name="04 Bơm &amp; xử lý nước" id="{9fe28723-a0df-e9df-b913-1e83ea03b5b2}">
+        <p14:section name="04 Bơm &amp; xử lý nước" id="{d2966d91-82c4-c081-6ba4-d4ae11a0682a}">
           <p14:sldIdLst>
             <p14:sldId id="270"/>
           </p14:sldIdLst>
         </p14:section>
-        <p14:section name="05 Quản trị dự án" id="{cdfde152-a3c2-26dd-29b1-6f65f5c527ae}">
+        <p14:section name="05 Quản trị dự án" id="{16cd0b7e-ed3b-fbd7-8c53-aceba35b0d5c}">
           <p14:sldIdLst>
             <p14:sldId id="271"/>
             <p14:sldId id="272"/>
             <p14:sldId id="273"/>
           </p14:sldIdLst>
         </p14:section>
-        <p14:section name="06 Nguồn lực" id="{77766e98-97c0-d22b-6c15-5ee7c3cb9951}">
+        <p14:section name="06 Nguồn lực" id="{f988fe43-436d-d3c0-8703-b6c0e13cbb12}">
           <p14:sldIdLst>
             <p14:sldId id="274"/>
             <p14:sldId id="275"/>
           </p14:sldIdLst>
         </p14:section>
-        <p14:section name="07 Công trình tiêu biểu" id="{d11c1036-f9d9-a780-485d-0947a8e2abca}">
+        <p14:section name="07 Công trình tiêu biểu" id="{4bc1d3fe-58e2-8edf-c3fc-d47bfa743cf7}">
           <p14:sldIdLst>
             <p14:sldId id="276"/>
             <p14:sldId id="277"/>
@@ -188,7 +188,7 @@
             <p14:sldId id="279"/>
           </p14:sldIdLst>
         </p14:section>
-        <p14:section name="08 Cam kết &amp; liên hệ" id="{adde38f6-93e1-9292-1e23-4767d8fea2ba}">
+        <p14:section name="08 Cam kết &amp; liên hệ" id="{04dc08d5-69f2-e4bc-85f3-8974fb8439e3}">
           <p14:sldIdLst>
             <p14:sldId id="280"/>
             <p14:sldId id="281"/>
@@ -3622,7 +3622,7 @@
       </p:pic>
       <p:pic>
         <p:nvPicPr>
-          <p:cNvPr id="4" name="cover team img35.jpg" descr="Đội ngũ công nhân BLT">    </p:cNvPr>
+          <p:cNvPr id="4" name="cover team qt_team.jpg" descr="Đội ngũ công nhân BLT">    </p:cNvPr>
           <p:cNvPicPr>
             <a:picLocks noChangeAspect="1"/>
           </p:cNvPicPr>
@@ -34005,16 +34005,131 @@
         <p:spPr>
           <a:xfrm>
             <a:off x="0" y="0"/>
-            <a:ext cx="7562088" cy="6766560"/>
+            <a:ext cx="4114800" cy="6766560"/>
           </a:xfrm>
           <a:prstGeom prst="rect">
             <a:avLst/>
           </a:prstGeom>
         </p:spPr>
       </p:pic>
-      <p:sp>
-        <p:nvSpPr>
-          <p:cNvPr id="3" name="Text 0"/>
+      <p:pic>
+        <p:nvPicPr>
+          <p:cNvPr id="3" name="photo render_nha.jpg" descr="Ảnh hiện trường BLT">    </p:cNvPr>
+          <p:cNvPicPr>
+            <a:picLocks noChangeAspect="1"/>
+          </p:cNvPicPr>
+          <p:nvPr/>
+        </p:nvPicPr>
+        <p:blipFill>
+          <a:blip r:embed="rId2"/>
+          <a:stretch>
+            <a:fillRect/>
+          </a:stretch>
+        </p:blipFill>
+        <p:spPr>
+          <a:xfrm>
+            <a:off x="4187952" y="0"/>
+            <a:ext cx="3374136" cy="3346704"/>
+          </a:xfrm>
+          <a:prstGeom prst="rect">
+            <a:avLst/>
+          </a:prstGeom>
+        </p:spPr>
+      </p:pic>
+      <p:pic>
+        <p:nvPicPr>
+          <p:cNvPr id="4" name="photo img08.jpg" descr="Ảnh hiện trường BLT">    </p:cNvPr>
+          <p:cNvPicPr>
+            <a:picLocks noChangeAspect="1"/>
+          </p:cNvPicPr>
+          <p:nvPr/>
+        </p:nvPicPr>
+        <p:blipFill>
+          <a:blip r:embed="rId3"/>
+          <a:stretch>
+            <a:fillRect/>
+          </a:stretch>
+        </p:blipFill>
+        <p:spPr>
+          <a:xfrm>
+            <a:off x="4187952" y="3419856"/>
+            <a:ext cx="3374136" cy="3346704"/>
+          </a:xfrm>
+          <a:prstGeom prst="rect">
+            <a:avLst/>
+          </a:prstGeom>
+        </p:spPr>
+      </p:pic>
+      <p:sp>
+        <p:nvSpPr>
+          <p:cNvPr id="5" name="Shape 0"/>
+          <p:cNvSpPr/>
+          <p:nvPr/>
+        </p:nvSpPr>
+        <p:spPr>
+          <a:xfrm>
+            <a:off x="4370832" y="2926080"/>
+            <a:ext cx="1600200" cy="274320"/>
+          </a:xfrm>
+          <a:prstGeom prst="roundRect">
+            <a:avLst>
+              <a:gd name="adj" fmla="val 16667"/>
+            </a:avLst>
+          </a:prstGeom>
+          <a:solidFill>
+            <a:schemeClr val="tx2">
+              <a:alpha val="85000"/>
+            </a:schemeClr>
+          </a:solidFill>
+          <a:ln w="12700">
+            <a:solidFill>
+              <a:schemeClr val="tx2">
+                <a:alpha val="0"/>
+              </a:schemeClr>
+            </a:solidFill>
+            <a:prstDash val="solid"/>
+          </a:ln>
+        </p:spPr>
+      </p:sp>
+      <p:sp>
+        <p:nvSpPr>
+          <p:cNvPr id="6" name="Text 1"/>
+          <p:cNvSpPr txBox="1"/>
+          <p:nvPr/>
+        </p:nvSpPr>
+        <p:spPr>
+          <a:xfrm>
+            <a:off x="4370832" y="2926080"/>
+            <a:ext cx="1600200" cy="274320"/>
+          </a:xfrm>
+          <a:prstGeom prst="rect">
+            <a:avLst/>
+          </a:prstGeom>
+          <a:noFill/>
+          <a:ln/>
+        </p:spPr>
+        <p:txBody>
+          <a:bodyPr wrap="square" lIns="0" tIns="0" rIns="0" bIns="0" rtlCol="0" anchor="ctr"/>
+          <a:lstStyle/>
+          <a:p>
+            <a:pPr algn="ctr" indent="0" marL="0">
+              <a:buNone/>
+            </a:pPr>
+            <a:r>
+              <a:rPr lang="en-US" sz="750" b="1" spc="100" kern="0" dirty="0">
+                <a:solidFill>
+                  <a:schemeClr val="bg1"/>
+                </a:solidFill>
+              </a:rPr>
+              <a:t>PHỐI CẢNH MINH HỌA</a:t>
+            </a:r>
+            <a:endParaRPr lang="en-US" sz="750" dirty="0"/>
+          </a:p>
+        </p:txBody>
+      </p:sp>
+      <p:sp>
+        <p:nvSpPr>
+          <p:cNvPr id="7" name="Text 2"/>
           <p:cNvSpPr txBox="1"/>
           <p:nvPr/>
         </p:nvSpPr>
@@ -34050,7 +34165,7 @@
       </p:sp>
       <p:sp>
         <p:nvSpPr>
-          <p:cNvPr id="4" name="Text 1"/>
+          <p:cNvPr id="8" name="Text 3"/>
           <p:cNvSpPr txBox="1"/>
           <p:nvPr/>
         </p:nvSpPr>
@@ -34106,7 +34221,7 @@
       </p:sp>
       <p:sp>
         <p:nvSpPr>
-          <p:cNvPr id="5" name="Text 2"/>
+          <p:cNvPr id="9" name="Text 4"/>
           <p:cNvSpPr txBox="1"/>
           <p:nvPr/>
         </p:nvSpPr>

</xml_diff>

<commit_message>
Hồ sơ năng lực BLT: thêm ảnh hoàn thiện máy lọc trên giá đỡ (trang 14)
Co-Authored-By: Claude Opus 5.5 <noreply@anthropic.com>
Claude-Session: https://claude.ai/code/session_01SkwAuDP5YjDrv41kDvnzWb
</commit_message>
<xml_diff>
--- a/ho-so-nang-luc-BLT/HO_SO_NANG_LUC_BLT.pptx
+++ b/ho-so-nang-luc-BLT/HO_SO_NANG_LUC_BLT.pptx
@@ -132,14 +132,14 @@
   <p:extLst>
     <p:ext uri="{521415D9-36F7-43E2-AB2F-B90AF26B5E84}">
       <p14:sectionLst xmlns:p14="http://schemas.microsoft.com/office/powerpoint/2010/main">
-        <p14:section name="Mở đầu" id="{4a27b49f-14f7-d116-363b-8b4b3f418060}">
+        <p14:section name="Mở đầu" id="{b6b3af05-bf6d-c949-7b6c-c6400a4dfc2e}">
           <p14:sldIdLst>
             <p14:sldId id="256"/>
             <p14:sldId id="257"/>
             <p14:sldId id="258"/>
           </p14:sldIdLst>
         </p14:section>
-        <p14:section name="01 Tổng quan" id="{31e3abc5-57c4-fada-442d-c61aa42356be}">
+        <p14:section name="01 Tổng quan" id="{b9b22ee0-a47f-af3d-93f7-0c4d99af6aa4}">
           <p14:sldIdLst>
             <p14:sldId id="259"/>
             <p14:sldId id="260"/>
@@ -148,39 +148,39 @@
             <p14:sldId id="263"/>
           </p14:sldIdLst>
         </p14:section>
-        <p14:section name="02 Điện nước công trình" id="{73013b9b-c3e7-1522-b6db-543fff4305ed}">
+        <p14:section name="02 Điện nước công trình" id="{a4986891-b793-c7f3-7755-49189c0df814}">
           <p14:sldIdLst>
             <p14:sldId id="264"/>
             <p14:sldId id="265"/>
             <p14:sldId id="266"/>
           </p14:sldIdLst>
         </p14:section>
-        <p14:section name="03 Hút sương dầu nhà xưởng" id="{a3335cf2-3af5-15f6-3b04-01b4d8675f49}">
+        <p14:section name="03 Hút sương dầu nhà xưởng" id="{ca5af126-9ec2-b3f8-1818-1df6b6dd6de1}">
           <p14:sldIdLst>
             <p14:sldId id="267"/>
             <p14:sldId id="268"/>
             <p14:sldId id="269"/>
           </p14:sldIdLst>
         </p14:section>
-        <p14:section name="04 Bơm &amp; xử lý nước" id="{d2966d91-82c4-c081-6ba4-d4ae11a0682a}">
+        <p14:section name="04 Bơm &amp; xử lý nước" id="{3fceb4b8-2bd8-f7c9-322a-b7af08013cde}">
           <p14:sldIdLst>
             <p14:sldId id="270"/>
           </p14:sldIdLst>
         </p14:section>
-        <p14:section name="05 Quản trị dự án" id="{16cd0b7e-ed3b-fbd7-8c53-aceba35b0d5c}">
+        <p14:section name="05 Quản trị dự án" id="{ce89f80e-fbb1-c3dd-c4c1-e6026c5020a9}">
           <p14:sldIdLst>
             <p14:sldId id="271"/>
             <p14:sldId id="272"/>
             <p14:sldId id="273"/>
           </p14:sldIdLst>
         </p14:section>
-        <p14:section name="06 Nguồn lực" id="{f988fe43-436d-d3c0-8703-b6c0e13cbb12}">
+        <p14:section name="06 Nguồn lực" id="{737d82a7-68bb-2897-af92-492a2bc6435b}">
           <p14:sldIdLst>
             <p14:sldId id="274"/>
             <p14:sldId id="275"/>
           </p14:sldIdLst>
         </p14:section>
-        <p14:section name="07 Công trình tiêu biểu" id="{4bc1d3fe-58e2-8edf-c3fc-d47bfa743cf7}">
+        <p14:section name="07 Công trình tiêu biểu" id="{1103b9cc-30b3-10ad-e67c-6473b52ce642}">
           <p14:sldIdLst>
             <p14:sldId id="276"/>
             <p14:sldId id="277"/>
@@ -188,7 +188,7 @@
             <p14:sldId id="279"/>
           </p14:sldIdLst>
         </p14:section>
-        <p14:section name="08 Cam kết &amp; liên hệ" id="{04dc08d5-69f2-e4bc-85f3-8974fb8439e3}">
+        <p14:section name="08 Cam kết &amp; liên hệ" id="{856cabb8-a502-b117-753e-e0d0d0a36498}">
           <p14:sldIdLst>
             <p14:sldId id="280"/>
             <p14:sldId id="281"/>
@@ -7727,7 +7727,7 @@
       </p:sp>
       <p:pic>
         <p:nvPicPr>
-          <p:cNvPr id="6" name="photo img30.jpg" descr="Máy lọc trên giá đỡ cột">    </p:cNvPr>
+          <p:cNvPr id="6" name="photo img26.jpg" descr="Hoàn thiện máy lọc trên giá đỡ">    </p:cNvPr>
           <p:cNvPicPr>
             <a:picLocks noChangeAspect="1"/>
           </p:cNvPicPr>
@@ -7742,7 +7742,7 @@
         <p:spPr>
           <a:xfrm>
             <a:off x="502920" y="5120640"/>
-            <a:ext cx="2063496" cy="2377440"/>
+            <a:ext cx="1536192" cy="2377440"/>
           </a:xfrm>
           <a:prstGeom prst="rect">
             <a:avLst/>
@@ -7758,7 +7758,7 @@
         <p:spPr>
           <a:xfrm>
             <a:off x="502920" y="7534656"/>
-            <a:ext cx="2063496" cy="201168"/>
+            <a:ext cx="1536192" cy="201168"/>
           </a:xfrm>
           <a:prstGeom prst="rect">
             <a:avLst/>
@@ -7781,7 +7781,7 @@
                   <a:schemeClr val="accent3"/>
                 </a:solidFill>
               </a:rPr>
-              <a:t>Máy lọc trên giá đỡ cột</a:t>
+              <a:t>Hoàn thiện máy lọc trên giá đỡ</a:t>
             </a:r>
             <a:endParaRPr lang="en-US" sz="800" dirty="0"/>
           </a:p>
@@ -7789,7 +7789,7 @@
       </p:sp>
       <p:pic>
         <p:nvPicPr>
-          <p:cNvPr id="8" name="photo img29.jpg" descr="Gia công giá đỡ thép">    </p:cNvPr>
+          <p:cNvPr id="8" name="photo img30.jpg" descr="Máy lọc trên giá đỡ cột">    </p:cNvPr>
           <p:cNvPicPr>
             <a:picLocks noChangeAspect="1"/>
           </p:cNvPicPr>
@@ -7803,8 +7803,8 @@
         </p:blipFill>
         <p:spPr>
           <a:xfrm>
-            <a:off x="2749296" y="5120640"/>
-            <a:ext cx="2063496" cy="2377440"/>
+            <a:off x="2176272" y="5120640"/>
+            <a:ext cx="1536192" cy="2377440"/>
           </a:xfrm>
           <a:prstGeom prst="rect">
             <a:avLst/>
@@ -7819,8 +7819,8 @@
         </p:nvSpPr>
         <p:spPr>
           <a:xfrm>
-            <a:off x="2749296" y="7534656"/>
-            <a:ext cx="2063496" cy="201168"/>
+            <a:off x="2176272" y="7534656"/>
+            <a:ext cx="1536192" cy="201168"/>
           </a:xfrm>
           <a:prstGeom prst="rect">
             <a:avLst/>
@@ -7843,7 +7843,7 @@
                   <a:schemeClr val="accent3"/>
                 </a:solidFill>
               </a:rPr>
-              <a:t>Gia công giá đỡ thép</a:t>
+              <a:t>Máy lọc trên giá đỡ cột</a:t>
             </a:r>
             <a:endParaRPr lang="en-US" sz="800" dirty="0"/>
           </a:p>
@@ -7851,7 +7851,7 @@
       </p:sp>
       <p:pic>
         <p:nvPicPr>
-          <p:cNvPr id="10" name="photo img33.jpg" descr="Bơm keo làm kín mối nối">    </p:cNvPr>
+          <p:cNvPr id="10" name="photo img29.jpg" descr="Gia công giá đỡ thép">    </p:cNvPr>
           <p:cNvPicPr>
             <a:picLocks noChangeAspect="1"/>
           </p:cNvPicPr>
@@ -7865,8 +7865,8 @@
         </p:blipFill>
         <p:spPr>
           <a:xfrm>
-            <a:off x="4995672" y="5120640"/>
-            <a:ext cx="2063496" cy="2377440"/>
+            <a:off x="3849624" y="5120640"/>
+            <a:ext cx="1536192" cy="2377440"/>
           </a:xfrm>
           <a:prstGeom prst="rect">
             <a:avLst/>
@@ -7881,8 +7881,8 @@
         </p:nvSpPr>
         <p:spPr>
           <a:xfrm>
-            <a:off x="4995672" y="7534656"/>
-            <a:ext cx="2063496" cy="201168"/>
+            <a:off x="3849624" y="7534656"/>
+            <a:ext cx="1536192" cy="201168"/>
           </a:xfrm>
           <a:prstGeom prst="rect">
             <a:avLst/>
@@ -7905,6 +7905,68 @@
                   <a:schemeClr val="accent3"/>
                 </a:solidFill>
               </a:rPr>
+              <a:t>Gia công giá đỡ thép</a:t>
+            </a:r>
+            <a:endParaRPr lang="en-US" sz="800" dirty="0"/>
+          </a:p>
+        </p:txBody>
+      </p:sp>
+      <p:pic>
+        <p:nvPicPr>
+          <p:cNvPr id="12" name="photo img33.jpg" descr="Bơm keo làm kín mối nối">    </p:cNvPr>
+          <p:cNvPicPr>
+            <a:picLocks noChangeAspect="1"/>
+          </p:cNvPicPr>
+          <p:nvPr/>
+        </p:nvPicPr>
+        <p:blipFill>
+          <a:blip r:embed="rId5"/>
+          <a:stretch>
+            <a:fillRect/>
+          </a:stretch>
+        </p:blipFill>
+        <p:spPr>
+          <a:xfrm>
+            <a:off x="5522976" y="5120640"/>
+            <a:ext cx="1536192" cy="2377440"/>
+          </a:xfrm>
+          <a:prstGeom prst="rect">
+            <a:avLst/>
+          </a:prstGeom>
+        </p:spPr>
+      </p:pic>
+      <p:sp>
+        <p:nvSpPr>
+          <p:cNvPr id="13" name="Text 6"/>
+          <p:cNvSpPr txBox="1"/>
+          <p:nvPr/>
+        </p:nvSpPr>
+        <p:spPr>
+          <a:xfrm>
+            <a:off x="5522976" y="7534656"/>
+            <a:ext cx="1536192" cy="201168"/>
+          </a:xfrm>
+          <a:prstGeom prst="rect">
+            <a:avLst/>
+          </a:prstGeom>
+          <a:noFill/>
+          <a:ln/>
+        </p:spPr>
+        <p:txBody>
+          <a:bodyPr wrap="square" lIns="0" tIns="0" rIns="0" bIns="0" rtlCol="0" anchor="ctr">
+            <a:normAutofit/>
+          </a:bodyPr>
+          <a:lstStyle/>
+          <a:p>
+            <a:pPr indent="0" marL="0">
+              <a:buNone/>
+            </a:pPr>
+            <a:r>
+              <a:rPr lang="en-US" sz="800" i="1" dirty="0">
+                <a:solidFill>
+                  <a:schemeClr val="accent3"/>
+                </a:solidFill>
+              </a:rPr>
               <a:t>Bơm keo làm kín mối nối</a:t>
             </a:r>
             <a:endParaRPr lang="en-US" sz="800" dirty="0"/>
@@ -7913,7 +7975,7 @@
       </p:sp>
       <p:sp>
         <p:nvSpPr>
-          <p:cNvPr id="12" name="Text 6"/>
+          <p:cNvPr id="14" name="Text 7"/>
           <p:cNvSpPr txBox="1"/>
           <p:nvPr/>
         </p:nvSpPr>
@@ -7952,7 +8014,7 @@
       </p:sp>
       <p:sp>
         <p:nvSpPr>
-          <p:cNvPr id="13" name="Shape 7"/>
+          <p:cNvPr id="15" name="Shape 8"/>
           <p:cNvSpPr/>
           <p:nvPr/>
         </p:nvSpPr>
@@ -7979,7 +8041,7 @@
       </p:sp>
       <p:sp>
         <p:nvSpPr>
-          <p:cNvPr id="14" name="Shape 8"/>
+          <p:cNvPr id="16" name="Shape 9"/>
           <p:cNvSpPr/>
           <p:nvPr/>
         </p:nvSpPr>
@@ -8004,7 +8066,7 @@
       </p:sp>
       <p:sp>
         <p:nvSpPr>
-          <p:cNvPr id="15" name="Text 9"/>
+          <p:cNvPr id="17" name="Text 10"/>
           <p:cNvSpPr txBox="1"/>
           <p:nvPr/>
         </p:nvSpPr>
@@ -8043,7 +8105,7 @@
       </p:sp>
       <p:sp>
         <p:nvSpPr>
-          <p:cNvPr id="16" name="Text 10"/>
+          <p:cNvPr id="18" name="Text 11"/>
           <p:cNvSpPr txBox="1"/>
           <p:nvPr/>
         </p:nvSpPr>
@@ -8082,7 +8144,7 @@
       </p:sp>
       <p:sp>
         <p:nvSpPr>
-          <p:cNvPr id="17" name="Text 11"/>
+          <p:cNvPr id="19" name="Text 12"/>
           <p:cNvSpPr txBox="1"/>
           <p:nvPr/>
         </p:nvSpPr>
@@ -8121,7 +8183,7 @@
       </p:sp>
       <p:sp>
         <p:nvSpPr>
-          <p:cNvPr id="18" name="Shape 12"/>
+          <p:cNvPr id="20" name="Shape 13"/>
           <p:cNvSpPr/>
           <p:nvPr/>
         </p:nvSpPr>
@@ -8148,7 +8210,7 @@
       </p:sp>
       <p:sp>
         <p:nvSpPr>
-          <p:cNvPr id="19" name="Shape 13"/>
+          <p:cNvPr id="21" name="Shape 14"/>
           <p:cNvSpPr/>
           <p:nvPr/>
         </p:nvSpPr>
@@ -8173,7 +8235,7 @@
       </p:sp>
       <p:sp>
         <p:nvSpPr>
-          <p:cNvPr id="20" name="Text 14"/>
+          <p:cNvPr id="22" name="Text 15"/>
           <p:cNvSpPr txBox="1"/>
           <p:nvPr/>
         </p:nvSpPr>
@@ -8212,7 +8274,7 @@
       </p:sp>
       <p:sp>
         <p:nvSpPr>
-          <p:cNvPr id="21" name="Text 15"/>
+          <p:cNvPr id="23" name="Text 16"/>
           <p:cNvSpPr txBox="1"/>
           <p:nvPr/>
         </p:nvSpPr>
@@ -8251,7 +8313,7 @@
       </p:sp>
       <p:sp>
         <p:nvSpPr>
-          <p:cNvPr id="22" name="Text 16"/>
+          <p:cNvPr id="24" name="Text 17"/>
           <p:cNvSpPr txBox="1"/>
           <p:nvPr/>
         </p:nvSpPr>
@@ -8290,7 +8352,7 @@
       </p:sp>
       <p:sp>
         <p:nvSpPr>
-          <p:cNvPr id="23" name="Shape 17"/>
+          <p:cNvPr id="25" name="Shape 18"/>
           <p:cNvSpPr/>
           <p:nvPr/>
         </p:nvSpPr>
@@ -8317,7 +8379,7 @@
       </p:sp>
       <p:sp>
         <p:nvSpPr>
-          <p:cNvPr id="24" name="Shape 18"/>
+          <p:cNvPr id="26" name="Shape 19"/>
           <p:cNvSpPr/>
           <p:nvPr/>
         </p:nvSpPr>
@@ -8342,7 +8404,7 @@
       </p:sp>
       <p:sp>
         <p:nvSpPr>
-          <p:cNvPr id="25" name="Text 19"/>
+          <p:cNvPr id="27" name="Text 20"/>
           <p:cNvSpPr txBox="1"/>
           <p:nvPr/>
         </p:nvSpPr>
@@ -8381,7 +8443,7 @@
       </p:sp>
       <p:sp>
         <p:nvSpPr>
-          <p:cNvPr id="26" name="Text 20"/>
+          <p:cNvPr id="28" name="Text 21"/>
           <p:cNvSpPr txBox="1"/>
           <p:nvPr/>
         </p:nvSpPr>
@@ -8420,7 +8482,7 @@
       </p:sp>
       <p:sp>
         <p:nvSpPr>
-          <p:cNvPr id="27" name="Text 21"/>
+          <p:cNvPr id="29" name="Text 22"/>
           <p:cNvSpPr txBox="1"/>
           <p:nvPr/>
         </p:nvSpPr>

</xml_diff>

<commit_message>
Hồ sơ năng lực BLT: bìa bỏ ảnh tập thể 7 người, giữ nhãn đội ngũ 50 nhân sự
Bìa dùng bố cục 3 ảnh đội ngũ (Huế, Quảng Trị); nhãn đặt trên đường ranh
ảnh và dải tiêu đề để không che người trong ảnh.

Co-Authored-By: Claude Opus 5.5 <noreply@anthropic.com>
Claude-Session: https://claude.ai/code/session_01SkwAuDP5YjDrv41kDvnzWb
</commit_message>
<xml_diff>
--- a/ho-so-nang-luc-BLT/HO_SO_NANG_LUC_BLT.pptx
+++ b/ho-so-nang-luc-BLT/HO_SO_NANG_LUC_BLT.pptx
@@ -132,14 +132,14 @@
   <p:extLst>
     <p:ext uri="{521415D9-36F7-43E2-AB2F-B90AF26B5E84}">
       <p14:sectionLst xmlns:p14="http://schemas.microsoft.com/office/powerpoint/2010/main">
-        <p14:section name="Mở đầu" id="{27cd69b8-5d94-0a91-8c6d-a58dd4d0d0ee}">
+        <p14:section name="Mở đầu" id="{2e8ac25b-04ae-7a4a-465d-5a9aee80bbab}">
           <p14:sldIdLst>
             <p14:sldId id="256"/>
             <p14:sldId id="257"/>
             <p14:sldId id="258"/>
           </p14:sldIdLst>
         </p14:section>
-        <p14:section name="01 Tổng quan" id="{9cde1d9b-c4d8-c2cc-6163-19b41e274200}">
+        <p14:section name="01 Tổng quan" id="{1a5fdbac-4f18-999f-c492-7de02233f7b4}">
           <p14:sldIdLst>
             <p14:sldId id="259"/>
             <p14:sldId id="260"/>
@@ -148,39 +148,39 @@
             <p14:sldId id="263"/>
           </p14:sldIdLst>
         </p14:section>
-        <p14:section name="02 Điện nước công trình" id="{98ccb3cd-94e9-4a7d-99d9-53275ca8cbb1}">
+        <p14:section name="02 Điện nước công trình" id="{aade84d3-c1f4-50e8-2a3e-0386d078c779}">
           <p14:sldIdLst>
             <p14:sldId id="264"/>
             <p14:sldId id="265"/>
             <p14:sldId id="266"/>
           </p14:sldIdLst>
         </p14:section>
-        <p14:section name="03 Hút sương dầu nhà xưởng" id="{7ab66364-b84f-3acd-1e12-4ffadb8c22d0}">
+        <p14:section name="03 Hút sương dầu nhà xưởng" id="{8d0d0a72-32d7-9386-264c-966fa6c5a677}">
           <p14:sldIdLst>
             <p14:sldId id="267"/>
             <p14:sldId id="268"/>
             <p14:sldId id="269"/>
           </p14:sldIdLst>
         </p14:section>
-        <p14:section name="04 Bơm &amp; xử lý nước" id="{ec8f1167-8296-2fda-68f1-628e927e8bc1}">
+        <p14:section name="04 Bơm &amp; xử lý nước" id="{191684f8-1231-5318-b79d-90e12b5ace0e}">
           <p14:sldIdLst>
             <p14:sldId id="270"/>
           </p14:sldIdLst>
         </p14:section>
-        <p14:section name="05 Quản trị dự án" id="{22dd7fe4-232f-18e0-787d-ee3af76ab44c}">
+        <p14:section name="05 Quản trị dự án" id="{e97ce6ce-550a-c6b4-cbea-146b30dffdba}">
           <p14:sldIdLst>
             <p14:sldId id="271"/>
             <p14:sldId id="272"/>
             <p14:sldId id="273"/>
           </p14:sldIdLst>
         </p14:section>
-        <p14:section name="06 Nguồn lực" id="{5c35c788-511c-4df4-382b-a2da2f5a8eef}">
+        <p14:section name="06 Nguồn lực" id="{abe803dd-9157-b66f-10d3-2f9d33b0c325}">
           <p14:sldIdLst>
             <p14:sldId id="274"/>
             <p14:sldId id="275"/>
           </p14:sldIdLst>
         </p14:section>
-        <p14:section name="07 Công trình tiêu biểu" id="{87157b3f-e221-469f-7ce9-6dd26054cb2d}">
+        <p14:section name="07 Công trình tiêu biểu" id="{14b75113-42e2-9d27-99de-ae994a78eca1}">
           <p14:sldIdLst>
             <p14:sldId id="276"/>
             <p14:sldId id="277"/>
@@ -188,7 +188,7 @@
             <p14:sldId id="279"/>
           </p14:sldIdLst>
         </p14:section>
-        <p14:section name="08 Cam kết &amp; liên hệ" id="{80156dc7-746c-3659-adaf-65bffb8f1d1b}">
+        <p14:section name="08 Cam kết &amp; liên hệ" id="{749a0013-182c-e872-96b9-64660d5a57ab}">
           <p14:sldIdLst>
             <p14:sldId id="280"/>
             <p14:sldId id="281"/>
@@ -3574,7 +3574,7 @@
       </p:grpSpPr>
       <p:pic>
         <p:nvPicPr>
-          <p:cNvPr id="2" name="cover team img57.jpg" descr="Đội ngũ công nhân BLT">    </p:cNvPr>
+          <p:cNvPr id="2" name="cover team img56_cov.jpg" descr="Đội ngũ công nhân BLT">    </p:cNvPr>
           <p:cNvPicPr>
             <a:picLocks noChangeAspect="1"/>
           </p:cNvPicPr>
@@ -3589,7 +3589,7 @@
         <p:spPr>
           <a:xfrm>
             <a:off x="0" y="0"/>
-            <a:ext cx="7562088" cy="3977640"/>
+            <a:ext cx="3749040" cy="6583680"/>
           </a:xfrm>
           <a:prstGeom prst="rect">
             <a:avLst/>
@@ -3612,8 +3612,8 @@
         </p:blipFill>
         <p:spPr>
           <a:xfrm>
-            <a:off x="0" y="4050792"/>
-            <a:ext cx="2471928" cy="2532888"/>
+            <a:off x="3822192" y="0"/>
+            <a:ext cx="3739896" cy="3255264"/>
           </a:xfrm>
           <a:prstGeom prst="rect">
             <a:avLst/>
@@ -3636,17 +3636,42 @@
         </p:blipFill>
         <p:spPr>
           <a:xfrm>
-            <a:off x="2545080" y="4050792"/>
-            <a:ext cx="2471928" cy="2532888"/>
+            <a:off x="3822192" y="3328416"/>
+            <a:ext cx="3739896" cy="3255264"/>
           </a:xfrm>
           <a:prstGeom prst="rect">
             <a:avLst/>
           </a:prstGeom>
         </p:spPr>
       </p:pic>
+      <p:sp>
+        <p:nvSpPr>
+          <p:cNvPr id="5" name="Shape 0"/>
+          <p:cNvSpPr/>
+          <p:nvPr/>
+        </p:nvSpPr>
+        <p:spPr>
+          <a:xfrm>
+            <a:off x="0" y="6583680"/>
+            <a:ext cx="7562088" cy="4105656"/>
+          </a:xfrm>
+          <a:prstGeom prst="rect">
+            <a:avLst/>
+          </a:prstGeom>
+          <a:solidFill>
+            <a:schemeClr val="tx2"/>
+          </a:solidFill>
+          <a:ln w="12700">
+            <a:solidFill>
+              <a:schemeClr val="tx2"/>
+            </a:solidFill>
+            <a:prstDash val="solid"/>
+          </a:ln>
+        </p:spPr>
+      </p:sp>
       <p:pic>
         <p:nvPicPr>
-          <p:cNvPr id="5" name="cover team img56.jpg" descr="Đội ngũ công nhân BLT">    </p:cNvPr>
+          <p:cNvPr id="6" name="logo" descr="preencoded.png">    </p:cNvPr>
           <p:cNvPicPr>
             <a:picLocks noChangeAspect="1"/>
           </p:cNvPicPr>
@@ -3660,8 +3685,8 @@
         </p:blipFill>
         <p:spPr>
           <a:xfrm>
-            <a:off x="5090160" y="4050792"/>
-            <a:ext cx="2471928" cy="2532888"/>
+            <a:off x="6007608" y="7040880"/>
+            <a:ext cx="1051560" cy="1051560"/>
           </a:xfrm>
           <a:prstGeom prst="rect">
             <a:avLst/>
@@ -3670,13 +3695,13 @@
       </p:pic>
       <p:sp>
         <p:nvSpPr>
-          <p:cNvPr id="6" name="Shape 0"/>
+          <p:cNvPr id="7" name="Shape 1"/>
           <p:cNvSpPr/>
           <p:nvPr/>
         </p:nvSpPr>
         <p:spPr>
           <a:xfrm>
-            <a:off x="4544568" y="3364992"/>
+            <a:off x="4544568" y="6355080"/>
             <a:ext cx="2514600" cy="457200"/>
           </a:xfrm>
           <a:prstGeom prst="roundRect">
@@ -3697,13 +3722,13 @@
       </p:sp>
       <p:sp>
         <p:nvSpPr>
-          <p:cNvPr id="7" name="Text 1"/>
-          <p:cNvSpPr txBox="1"/>
-          <p:nvPr/>
-        </p:nvSpPr>
-        <p:spPr>
-          <a:xfrm>
-            <a:off x="4544568" y="3364992"/>
+          <p:cNvPr id="8" name="Text 2"/>
+          <p:cNvSpPr txBox="1"/>
+          <p:nvPr/>
+        </p:nvSpPr>
+        <p:spPr>
+          <a:xfrm>
+            <a:off x="4544568" y="6355080"/>
             <a:ext cx="2514600" cy="457200"/>
           </a:xfrm>
           <a:prstGeom prst="rect">
@@ -3736,56 +3761,7 @@
       </p:sp>
       <p:sp>
         <p:nvSpPr>
-          <p:cNvPr id="8" name="Shape 2"/>
-          <p:cNvSpPr/>
-          <p:nvPr/>
-        </p:nvSpPr>
-        <p:spPr>
-          <a:xfrm>
-            <a:off x="0" y="6583680"/>
-            <a:ext cx="7562088" cy="4105656"/>
-          </a:xfrm>
-          <a:prstGeom prst="rect">
-            <a:avLst/>
-          </a:prstGeom>
-          <a:solidFill>
-            <a:schemeClr val="tx2"/>
-          </a:solidFill>
-          <a:ln w="12700">
-            <a:solidFill>
-              <a:schemeClr val="tx2"/>
-            </a:solidFill>
-            <a:prstDash val="solid"/>
-          </a:ln>
-        </p:spPr>
-      </p:sp>
-      <p:pic>
-        <p:nvPicPr>
-          <p:cNvPr id="9" name="logo" descr="preencoded.png">    </p:cNvPr>
-          <p:cNvPicPr>
-            <a:picLocks noChangeAspect="1"/>
-          </p:cNvPicPr>
-          <p:nvPr/>
-        </p:nvPicPr>
-        <p:blipFill>
-          <a:blip r:embed="rId5"/>
-          <a:stretch>
-            <a:fillRect/>
-          </a:stretch>
-        </p:blipFill>
-        <p:spPr>
-          <a:xfrm>
-            <a:off x="6007608" y="6903720"/>
-            <a:ext cx="1051560" cy="1051560"/>
-          </a:xfrm>
-          <a:prstGeom prst="rect">
-            <a:avLst/>
-          </a:prstGeom>
-        </p:spPr>
-      </p:pic>
-      <p:sp>
-        <p:nvSpPr>
-          <p:cNvPr id="10" name="Text 3"/>
+          <p:cNvPr id="9" name="Text 3"/>
           <p:cNvSpPr txBox="1"/>
           <p:nvPr/>
         </p:nvSpPr>
@@ -3824,7 +3800,7 @@
       </p:sp>
       <p:sp>
         <p:nvSpPr>
-          <p:cNvPr id="11" name="Text 4"/>
+          <p:cNvPr id="10" name="Text 4"/>
           <p:cNvSpPr txBox="1"/>
           <p:nvPr/>
         </p:nvSpPr>
@@ -3863,7 +3839,7 @@
       </p:sp>
       <p:sp>
         <p:nvSpPr>
-          <p:cNvPr id="12" name="Text 5"/>
+          <p:cNvPr id="11" name="Text 5"/>
           <p:cNvSpPr txBox="1"/>
           <p:nvPr/>
         </p:nvSpPr>
@@ -3916,7 +3892,7 @@
       </p:sp>
       <p:sp>
         <p:nvSpPr>
-          <p:cNvPr id="13" name="Text 6"/>
+          <p:cNvPr id="12" name="Text 6"/>
           <p:cNvSpPr txBox="1"/>
           <p:nvPr/>
         </p:nvSpPr>
@@ -3966,7 +3942,7 @@
       </p:sp>
       <p:sp>
         <p:nvSpPr>
-          <p:cNvPr id="14" name="Text 7"/>
+          <p:cNvPr id="13" name="Text 7"/>
           <p:cNvSpPr txBox="1"/>
           <p:nvPr/>
         </p:nvSpPr>
@@ -4002,7 +3978,7 @@
       </p:sp>
       <p:sp>
         <p:nvSpPr>
-          <p:cNvPr id="15" name="Text 8"/>
+          <p:cNvPr id="14" name="Text 8"/>
           <p:cNvSpPr txBox="1"/>
           <p:nvPr/>
         </p:nvSpPr>
@@ -4038,7 +4014,7 @@
       </p:sp>
       <p:sp>
         <p:nvSpPr>
-          <p:cNvPr id="16" name="Text 9"/>
+          <p:cNvPr id="15" name="Text 9"/>
           <p:cNvSpPr txBox="1"/>
           <p:nvPr/>
         </p:nvSpPr>

</xml_diff>

<commit_message>
Hồ sơ năng lực BLT: trang 2 dùng ảnh lắp máy lọc thay ảnh giàn giáo
Trang 2: bỏ ảnh giàn giáo Hà Nam, dùng ảnh lắp máy lọc sương dầu ở Hưng Nguyên
hiển thị đủ khung. Trang 5: ảnh này được dời đi nên dùng một ảnh rộng
lắp giá đỡ thép. Mỗi ảnh vẫn chỉ xuất hiện một lần.

Co-Authored-By: Claude Opus 5.5 <noreply@anthropic.com>
Claude-Session: https://claude.ai/code/session_01SkwAuDP5YjDrv41kDvnzWb
</commit_message>
<xml_diff>
--- a/ho-so-nang-luc-BLT/HO_SO_NANG_LUC_BLT.pptx
+++ b/ho-so-nang-luc-BLT/HO_SO_NANG_LUC_BLT.pptx
@@ -132,14 +132,14 @@
   <p:extLst>
     <p:ext uri="{521415D9-36F7-43E2-AB2F-B90AF26B5E84}">
       <p14:sectionLst xmlns:p14="http://schemas.microsoft.com/office/powerpoint/2010/main">
-        <p14:section name="Mở đầu" id="{2e8ac25b-04ae-7a4a-465d-5a9aee80bbab}">
+        <p14:section name="Mở đầu" id="{597f9ff5-9b2f-a2d9-7065-065be2b3af12}">
           <p14:sldIdLst>
             <p14:sldId id="256"/>
             <p14:sldId id="257"/>
             <p14:sldId id="258"/>
           </p14:sldIdLst>
         </p14:section>
-        <p14:section name="01 Tổng quan" id="{1a5fdbac-4f18-999f-c492-7de02233f7b4}">
+        <p14:section name="01 Tổng quan" id="{04ce6e18-7ec5-9088-1a40-36031a8ef2a0}">
           <p14:sldIdLst>
             <p14:sldId id="259"/>
             <p14:sldId id="260"/>
@@ -148,39 +148,39 @@
             <p14:sldId id="263"/>
           </p14:sldIdLst>
         </p14:section>
-        <p14:section name="02 Điện nước công trình" id="{aade84d3-c1f4-50e8-2a3e-0386d078c779}">
+        <p14:section name="02 Điện nước công trình" id="{77b3b7d6-2843-7372-fbfc-a5277d80e7bf}">
           <p14:sldIdLst>
             <p14:sldId id="264"/>
             <p14:sldId id="265"/>
             <p14:sldId id="266"/>
           </p14:sldIdLst>
         </p14:section>
-        <p14:section name="03 Hút sương dầu nhà xưởng" id="{8d0d0a72-32d7-9386-264c-966fa6c5a677}">
+        <p14:section name="03 Hút sương dầu nhà xưởng" id="{596f0819-d33e-d7a1-ab72-6a1b040e3e14}">
           <p14:sldIdLst>
             <p14:sldId id="267"/>
             <p14:sldId id="268"/>
             <p14:sldId id="269"/>
           </p14:sldIdLst>
         </p14:section>
-        <p14:section name="04 Bơm &amp; xử lý nước" id="{191684f8-1231-5318-b79d-90e12b5ace0e}">
+        <p14:section name="04 Bơm &amp; xử lý nước" id="{82c3b68f-ea19-abb4-d0c8-5776b10da299}">
           <p14:sldIdLst>
             <p14:sldId id="270"/>
           </p14:sldIdLst>
         </p14:section>
-        <p14:section name="05 Quản trị dự án" id="{e97ce6ce-550a-c6b4-cbea-146b30dffdba}">
+        <p14:section name="05 Quản trị dự án" id="{88691ed8-1214-11e0-55d9-d9c8f630ec9f}">
           <p14:sldIdLst>
             <p14:sldId id="271"/>
             <p14:sldId id="272"/>
             <p14:sldId id="273"/>
           </p14:sldIdLst>
         </p14:section>
-        <p14:section name="06 Nguồn lực" id="{abe803dd-9157-b66f-10d3-2f9d33b0c325}">
+        <p14:section name="06 Nguồn lực" id="{ac2e4181-29e4-b233-37f7-809dcfe9b873}">
           <p14:sldIdLst>
             <p14:sldId id="274"/>
             <p14:sldId id="275"/>
           </p14:sldIdLst>
         </p14:section>
-        <p14:section name="07 Công trình tiêu biểu" id="{14b75113-42e2-9d27-99de-ae994a78eca1}">
+        <p14:section name="07 Công trình tiêu biểu" id="{6c88a69c-94cf-4273-e8af-5597bd8fabb1}">
           <p14:sldIdLst>
             <p14:sldId id="276"/>
             <p14:sldId id="277"/>
@@ -188,7 +188,7 @@
             <p14:sldId id="279"/>
           </p14:sldIdLst>
         </p14:section>
-        <p14:section name="08 Cam kết &amp; liên hệ" id="{749a0013-182c-e872-96b9-64660d5a57ab}">
+        <p14:section name="08 Cam kết &amp; liên hệ" id="{7329ba14-29a3-f5d1-9de2-6d4390f9e434}">
           <p14:sldIdLst>
             <p14:sldId id="280"/>
             <p14:sldId id="281"/>
@@ -16036,7 +16036,7 @@
       </p:grpSpPr>
       <p:pic>
         <p:nvPicPr>
-          <p:cNvPr id="2" name="photo img13.jpg" descr="Ảnh hiện trường BLT">    </p:cNvPr>
+          <p:cNvPr id="2" name="photo img36.jpg" descr="Ảnh hiện trường BLT">    </p:cNvPr>
           <p:cNvPicPr>
             <a:picLocks noChangeAspect="1"/>
           </p:cNvPicPr>
@@ -16051,7 +16051,7 @@
         <p:spPr>
           <a:xfrm>
             <a:off x="0" y="0"/>
-            <a:ext cx="7562088" cy="4937760"/>
+            <a:ext cx="7562088" cy="5669280"/>
           </a:xfrm>
           <a:prstGeom prst="rect">
             <a:avLst/>
@@ -16066,7 +16066,7 @@
         </p:nvSpPr>
         <p:spPr>
           <a:xfrm>
-            <a:off x="502920" y="5349240"/>
+            <a:off x="502920" y="5943600"/>
             <a:ext cx="6556248" cy="228600"/>
           </a:xfrm>
           <a:prstGeom prst="rect">
@@ -16105,8 +16105,8 @@
         </p:nvSpPr>
         <p:spPr>
           <a:xfrm>
-            <a:off x="502920" y="5623560"/>
-            <a:ext cx="6556248" cy="1188720"/>
+            <a:off x="502920" y="6199632"/>
+            <a:ext cx="6556248" cy="1097280"/>
           </a:xfrm>
           <a:prstGeom prst="rect">
             <a:avLst/>
@@ -16161,8 +16161,8 @@
         </p:nvSpPr>
         <p:spPr>
           <a:xfrm>
-            <a:off x="502920" y="6903720"/>
-            <a:ext cx="6556248" cy="731520"/>
+            <a:off x="502920" y="7360920"/>
+            <a:ext cx="6556248" cy="685800"/>
           </a:xfrm>
           <a:prstGeom prst="rect">
             <a:avLst/>
@@ -16203,7 +16203,7 @@
         </p:nvSpPr>
         <p:spPr>
           <a:xfrm>
-            <a:off x="502920" y="7863840"/>
+            <a:off x="502920" y="8183880"/>
             <a:ext cx="457200" cy="457200"/>
           </a:xfrm>
           <a:prstGeom prst="ellipse">
@@ -16228,7 +16228,7 @@
         </p:nvSpPr>
         <p:spPr>
           <a:xfrm>
-            <a:off x="502920" y="7863840"/>
+            <a:off x="502920" y="8183880"/>
             <a:ext cx="457200" cy="457200"/>
           </a:xfrm>
           <a:prstGeom prst="rect">
@@ -16267,7 +16267,7 @@
         </p:nvSpPr>
         <p:spPr>
           <a:xfrm>
-            <a:off x="502920" y="8412480"/>
+            <a:off x="502920" y="8732520"/>
             <a:ext cx="2063496" cy="274320"/>
           </a:xfrm>
           <a:prstGeom prst="rect">
@@ -16306,8 +16306,8 @@
         </p:nvSpPr>
         <p:spPr>
           <a:xfrm>
-            <a:off x="502920" y="8686800"/>
-            <a:ext cx="2063496" cy="822960"/>
+            <a:off x="502920" y="9034272"/>
+            <a:ext cx="2063496" cy="731520"/>
           </a:xfrm>
           <a:prstGeom prst="rect">
             <a:avLst/>
@@ -16348,7 +16348,7 @@
         </p:nvSpPr>
         <p:spPr>
           <a:xfrm>
-            <a:off x="2749296" y="7863840"/>
+            <a:off x="2749296" y="8183880"/>
             <a:ext cx="457200" cy="457200"/>
           </a:xfrm>
           <a:prstGeom prst="ellipse">
@@ -16373,7 +16373,7 @@
         </p:nvSpPr>
         <p:spPr>
           <a:xfrm>
-            <a:off x="2749296" y="7863840"/>
+            <a:off x="2749296" y="8183880"/>
             <a:ext cx="457200" cy="457200"/>
           </a:xfrm>
           <a:prstGeom prst="rect">
@@ -16412,7 +16412,7 @@
         </p:nvSpPr>
         <p:spPr>
           <a:xfrm>
-            <a:off x="2749296" y="8412480"/>
+            <a:off x="2749296" y="8732520"/>
             <a:ext cx="2063496" cy="274320"/>
           </a:xfrm>
           <a:prstGeom prst="rect">
@@ -16451,8 +16451,8 @@
         </p:nvSpPr>
         <p:spPr>
           <a:xfrm>
-            <a:off x="2749296" y="8686800"/>
-            <a:ext cx="2063496" cy="822960"/>
+            <a:off x="2749296" y="9034272"/>
+            <a:ext cx="2063496" cy="731520"/>
           </a:xfrm>
           <a:prstGeom prst="rect">
             <a:avLst/>
@@ -16493,7 +16493,7 @@
         </p:nvSpPr>
         <p:spPr>
           <a:xfrm>
-            <a:off x="4995672" y="7863840"/>
+            <a:off x="4995672" y="8183880"/>
             <a:ext cx="457200" cy="457200"/>
           </a:xfrm>
           <a:prstGeom prst="ellipse">
@@ -16518,7 +16518,7 @@
         </p:nvSpPr>
         <p:spPr>
           <a:xfrm>
-            <a:off x="4995672" y="7863840"/>
+            <a:off x="4995672" y="8183880"/>
             <a:ext cx="457200" cy="457200"/>
           </a:xfrm>
           <a:prstGeom prst="rect">
@@ -16557,7 +16557,7 @@
         </p:nvSpPr>
         <p:spPr>
           <a:xfrm>
-            <a:off x="4995672" y="8412480"/>
+            <a:off x="4995672" y="8732520"/>
             <a:ext cx="2063496" cy="274320"/>
           </a:xfrm>
           <a:prstGeom prst="rect">
@@ -16596,8 +16596,8 @@
         </p:nvSpPr>
         <p:spPr>
           <a:xfrm>
-            <a:off x="4995672" y="8686800"/>
-            <a:ext cx="2063496" cy="822960"/>
+            <a:off x="4995672" y="9034272"/>
+            <a:ext cx="2063496" cy="731520"/>
           </a:xfrm>
           <a:prstGeom prst="rect">
             <a:avLst/>
@@ -30154,7 +30154,7 @@
       </p:sp>
       <p:pic>
         <p:nvPicPr>
-          <p:cNvPr id="22" name="photo img36.jpg" descr="Lắp máy lọc sương dầu – Hưng Nguyên, Nghệ An">    </p:cNvPr>
+          <p:cNvPr id="22" name="photo img74_wide.jpg" descr="Đội BLT lắp giá đỡ thép trên xe nâng người – Hưng Nguyên, Nghệ An">    </p:cNvPr>
           <p:cNvPicPr>
             <a:picLocks noChangeAspect="1"/>
           </p:cNvPicPr>
@@ -30168,8 +30168,8 @@
         </p:blipFill>
         <p:spPr>
           <a:xfrm>
-            <a:off x="502920" y="4526280"/>
-            <a:ext cx="3200400" cy="2377440"/>
+            <a:off x="502920" y="4206240"/>
+            <a:ext cx="6556248" cy="2926080"/>
           </a:xfrm>
           <a:prstGeom prst="rect">
             <a:avLst/>
@@ -30184,8 +30184,8 @@
         </p:nvSpPr>
         <p:spPr>
           <a:xfrm>
-            <a:off x="502920" y="6940296"/>
-            <a:ext cx="3200400" cy="201168"/>
+            <a:off x="502920" y="7168896"/>
+            <a:ext cx="6556248" cy="201168"/>
           </a:xfrm>
           <a:prstGeom prst="rect">
             <a:avLst/>
@@ -30208,83 +30208,21 @@
                   <a:schemeClr val="accent3"/>
                 </a:solidFill>
               </a:rPr>
-              <a:t>Lắp máy lọc sương dầu – Hưng Nguyên, Nghệ An</a:t>
+              <a:t>Đội BLT lắp giá đỡ thép trên xe nâng người – Hưng Nguyên, Nghệ An</a:t>
             </a:r>
             <a:endParaRPr lang="en-US" sz="800" dirty="0"/>
           </a:p>
         </p:txBody>
       </p:sp>
-      <p:pic>
-        <p:nvPicPr>
-          <p:cNvPr id="24" name="photo img74.jpg" descr="Lắp giá đỡ thép trên xe nâng người – Hưng Nguyên, Nghệ An">    </p:cNvPr>
-          <p:cNvPicPr>
-            <a:picLocks noChangeAspect="1"/>
-          </p:cNvPicPr>
-          <p:nvPr/>
-        </p:nvPicPr>
-        <p:blipFill>
-          <a:blip r:embed="rId2"/>
-          <a:stretch>
-            <a:fillRect/>
-          </a:stretch>
-        </p:blipFill>
-        <p:spPr>
-          <a:xfrm>
-            <a:off x="3858768" y="4526280"/>
-            <a:ext cx="3200400" cy="2377440"/>
-          </a:xfrm>
-          <a:prstGeom prst="rect">
-            <a:avLst/>
-          </a:prstGeom>
-        </p:spPr>
-      </p:pic>
-      <p:sp>
-        <p:nvSpPr>
-          <p:cNvPr id="25" name="Text 21"/>
-          <p:cNvSpPr txBox="1"/>
-          <p:nvPr/>
-        </p:nvSpPr>
-        <p:spPr>
-          <a:xfrm>
-            <a:off x="3858768" y="6940296"/>
-            <a:ext cx="3200400" cy="201168"/>
-          </a:xfrm>
-          <a:prstGeom prst="rect">
-            <a:avLst/>
-          </a:prstGeom>
-          <a:noFill/>
-          <a:ln/>
-        </p:spPr>
-        <p:txBody>
-          <a:bodyPr wrap="square" lIns="0" tIns="0" rIns="0" bIns="0" rtlCol="0" anchor="ctr">
-            <a:normAutofit/>
-          </a:bodyPr>
-          <a:lstStyle/>
-          <a:p>
-            <a:pPr indent="0" marL="0">
-              <a:buNone/>
-            </a:pPr>
-            <a:r>
-              <a:rPr lang="en-US" sz="800" i="1" dirty="0">
-                <a:solidFill>
-                  <a:schemeClr val="accent3"/>
-                </a:solidFill>
-              </a:rPr>
-              <a:t>Lắp giá đỡ thép trên xe nâng người – Hưng Nguyên, Nghệ An</a:t>
-            </a:r>
-            <a:endParaRPr lang="en-US" sz="800" dirty="0"/>
-          </a:p>
-        </p:txBody>
-      </p:sp>
-      <p:sp>
-        <p:nvSpPr>
-          <p:cNvPr id="26" name="Text 22"/>
-          <p:cNvSpPr txBox="1"/>
-          <p:nvPr/>
-        </p:nvSpPr>
-        <p:spPr>
-          <a:xfrm>
-            <a:off x="502920" y="7315200"/>
+      <p:sp>
+        <p:nvSpPr>
+          <p:cNvPr id="24" name="Text 21"/>
+          <p:cNvSpPr txBox="1"/>
+          <p:nvPr/>
+        </p:nvSpPr>
+        <p:spPr>
+          <a:xfrm>
+            <a:off x="502920" y="7635240"/>
             <a:ext cx="3108960" cy="228600"/>
           </a:xfrm>
           <a:prstGeom prst="rect">
@@ -30317,14 +30255,14 @@
       </p:sp>
       <p:sp>
         <p:nvSpPr>
-          <p:cNvPr id="27" name="Text 23"/>
-          <p:cNvSpPr txBox="1"/>
-          <p:nvPr/>
-        </p:nvSpPr>
-        <p:spPr>
-          <a:xfrm>
-            <a:off x="502920" y="7589520"/>
-            <a:ext cx="3200400" cy="2286000"/>
+          <p:cNvPr id="25" name="Text 22"/>
+          <p:cNvSpPr txBox="1"/>
+          <p:nvPr/>
+        </p:nvSpPr>
+        <p:spPr>
+          <a:xfrm>
+            <a:off x="502920" y="7909560"/>
+            <a:ext cx="3200400" cy="2011680"/>
           </a:xfrm>
           <a:prstGeom prst="rect">
             <a:avLst/>
@@ -30411,13 +30349,13 @@
       </p:sp>
       <p:sp>
         <p:nvSpPr>
-          <p:cNvPr id="28" name="Text 24"/>
-          <p:cNvSpPr txBox="1"/>
-          <p:nvPr/>
-        </p:nvSpPr>
-        <p:spPr>
-          <a:xfrm>
-            <a:off x="3858768" y="7315200"/>
+          <p:cNvPr id="26" name="Text 23"/>
+          <p:cNvSpPr txBox="1"/>
+          <p:nvPr/>
+        </p:nvSpPr>
+        <p:spPr>
+          <a:xfrm>
+            <a:off x="3858768" y="7635240"/>
             <a:ext cx="3108960" cy="228600"/>
           </a:xfrm>
           <a:prstGeom prst="rect">
@@ -30450,14 +30388,14 @@
       </p:sp>
       <p:sp>
         <p:nvSpPr>
-          <p:cNvPr id="29" name="Text 25"/>
-          <p:cNvSpPr txBox="1"/>
-          <p:nvPr/>
-        </p:nvSpPr>
-        <p:spPr>
-          <a:xfrm>
-            <a:off x="3858768" y="7589520"/>
-            <a:ext cx="3200400" cy="2286000"/>
+          <p:cNvPr id="27" name="Text 24"/>
+          <p:cNvSpPr txBox="1"/>
+          <p:nvPr/>
+        </p:nvSpPr>
+        <p:spPr>
+          <a:xfrm>
+            <a:off x="3858768" y="7909560"/>
+            <a:ext cx="3200400" cy="2011680"/>
           </a:xfrm>
           <a:prstGeom prst="rect">
             <a:avLst/>

</xml_diff>

<commit_message>
Hồ sơ năng lực BLT: thay 2 ảnh trang 8 bằng ảnh sáng, rõ hơn
Trang 8: ô Hệ thống điện và Cấp thoát nước dùng ảnh thi công trên xe nâng
và giàn ống uPVC; xếp lại trang 10, 15, 23 để không ảnh nào lặp; thêm mô tả
dòng 08 ở mục lục.

Co-Authored-By: Claude Opus 5.5 <noreply@anthropic.com>
Claude-Session: https://claude.ai/code/session_01SkwAuDP5YjDrv41kDvnzWb
</commit_message>
<xml_diff>
--- a/ho-so-nang-luc-BLT/HO_SO_NANG_LUC_BLT.pptx
+++ b/ho-so-nang-luc-BLT/HO_SO_NANG_LUC_BLT.pptx
@@ -132,14 +132,14 @@
   <p:extLst>
     <p:ext uri="{521415D9-36F7-43E2-AB2F-B90AF26B5E84}">
       <p14:sectionLst xmlns:p14="http://schemas.microsoft.com/office/powerpoint/2010/main">
-        <p14:section name="Mở đầu" id="{597f9ff5-9b2f-a2d9-7065-065be2b3af12}">
+        <p14:section name="Mở đầu" id="{19dfa5f3-b608-e72f-8776-642710ee261e}">
           <p14:sldIdLst>
             <p14:sldId id="256"/>
             <p14:sldId id="257"/>
             <p14:sldId id="258"/>
           </p14:sldIdLst>
         </p14:section>
-        <p14:section name="01 Tổng quan" id="{04ce6e18-7ec5-9088-1a40-36031a8ef2a0}">
+        <p14:section name="01 Tổng quan" id="{e9e5db81-ae41-abed-d305-286ef1f787a3}">
           <p14:sldIdLst>
             <p14:sldId id="259"/>
             <p14:sldId id="260"/>
@@ -148,39 +148,39 @@
             <p14:sldId id="263"/>
           </p14:sldIdLst>
         </p14:section>
-        <p14:section name="02 Điện nước công trình" id="{77b3b7d6-2843-7372-fbfc-a5277d80e7bf}">
+        <p14:section name="02 Điện nước công trình" id="{8675cc9b-05b1-77c9-ad8d-2067faaa07b4}">
           <p14:sldIdLst>
             <p14:sldId id="264"/>
             <p14:sldId id="265"/>
             <p14:sldId id="266"/>
           </p14:sldIdLst>
         </p14:section>
-        <p14:section name="03 Hút sương dầu nhà xưởng" id="{596f0819-d33e-d7a1-ab72-6a1b040e3e14}">
+        <p14:section name="03 Hút sương dầu nhà xưởng" id="{fa9cf539-6568-d5a3-4bb7-e67529b179ad}">
           <p14:sldIdLst>
             <p14:sldId id="267"/>
             <p14:sldId id="268"/>
             <p14:sldId id="269"/>
           </p14:sldIdLst>
         </p14:section>
-        <p14:section name="04 Bơm &amp; xử lý nước" id="{82c3b68f-ea19-abb4-d0c8-5776b10da299}">
+        <p14:section name="04 Bơm &amp; xử lý nước" id="{bd7950e4-df5c-8170-02ae-e86ec30d22da}">
           <p14:sldIdLst>
             <p14:sldId id="270"/>
           </p14:sldIdLst>
         </p14:section>
-        <p14:section name="05 Quản trị dự án" id="{88691ed8-1214-11e0-55d9-d9c8f630ec9f}">
+        <p14:section name="05 Quản trị dự án" id="{a268219a-9005-e449-f998-092717f87fff}">
           <p14:sldIdLst>
             <p14:sldId id="271"/>
             <p14:sldId id="272"/>
             <p14:sldId id="273"/>
           </p14:sldIdLst>
         </p14:section>
-        <p14:section name="06 Nguồn lực" id="{ac2e4181-29e4-b233-37f7-809dcfe9b873}">
+        <p14:section name="06 Nguồn lực" id="{82069a71-d559-1cd8-0162-7fba3de01eee}">
           <p14:sldIdLst>
             <p14:sldId id="274"/>
             <p14:sldId id="275"/>
           </p14:sldIdLst>
         </p14:section>
-        <p14:section name="07 Công trình tiêu biểu" id="{6c88a69c-94cf-4273-e8af-5597bd8fabb1}">
+        <p14:section name="07 Công trình tiêu biểu" id="{6c0a7e47-4f36-a894-e382-c145a6c7b5f5}">
           <p14:sldIdLst>
             <p14:sldId id="276"/>
             <p14:sldId id="277"/>
@@ -188,7 +188,7 @@
             <p14:sldId id="279"/>
           </p14:sldIdLst>
         </p14:section>
-        <p14:section name="08 Cam kết &amp; liên hệ" id="{7329ba14-29a3-f5d1-9de2-6d4390f9e434}">
+        <p14:section name="08 Cam kết &amp; liên hệ" id="{cffa540f-d4ce-ff54-b263-6fd1f2b4bccb}">
           <p14:sldIdLst>
             <p14:sldId id="280"/>
             <p14:sldId id="281"/>
@@ -4151,7 +4151,7 @@
       </p:sp>
       <p:pic>
         <p:nvPicPr>
-          <p:cNvPr id="4" name="photo img14.jpg" descr="Thi công trên trần bằng xe nâng người">    </p:cNvPr>
+          <p:cNvPr id="4" name="photo img10.jpg" descr="Gia công ống luồn dây tại hiện trường – Hà Nam, Ninh Bình">    </p:cNvPr>
           <p:cNvPicPr>
             <a:picLocks noChangeAspect="1"/>
           </p:cNvPicPr>
@@ -4166,7 +4166,7 @@
         <p:spPr>
           <a:xfrm>
             <a:off x="502920" y="1463040"/>
-            <a:ext cx="3186684" cy="2514600"/>
+            <a:ext cx="6556248" cy="2926080"/>
           </a:xfrm>
           <a:prstGeom prst="rect">
             <a:avLst/>
@@ -4181,8 +4181,8 @@
         </p:nvSpPr>
         <p:spPr>
           <a:xfrm>
-            <a:off x="502920" y="4014216"/>
-            <a:ext cx="3186684" cy="201168"/>
+            <a:off x="502920" y="4425696"/>
+            <a:ext cx="6556248" cy="201168"/>
           </a:xfrm>
           <a:prstGeom prst="rect">
             <a:avLst/>
@@ -4205,7 +4205,7 @@
                   <a:schemeClr val="accent3"/>
                 </a:solidFill>
               </a:rPr>
-              <a:t>Thi công trên trần bằng xe nâng người</a:t>
+              <a:t>Gia công ống luồn dây tại hiện trường – Hà Nam, Ninh Bình</a:t>
             </a:r>
             <a:endParaRPr lang="en-US" sz="800" dirty="0"/>
           </a:p>
@@ -4213,7 +4213,7 @@
       </p:sp>
       <p:pic>
         <p:nvPicPr>
-          <p:cNvPr id="6" name="photo img10.jpg" descr="Gia công ống luồn dây tại hiện trường">    </p:cNvPr>
+          <p:cNvPr id="6" name="photo img03.jpg" descr="Đi ống luồn dây dưới sàn">    </p:cNvPr>
           <p:cNvPicPr>
             <a:picLocks noChangeAspect="1"/>
           </p:cNvPicPr>
@@ -4227,8 +4227,8 @@
         </p:blipFill>
         <p:spPr>
           <a:xfrm>
-            <a:off x="3872484" y="1463040"/>
-            <a:ext cx="3186684" cy="2514600"/>
+            <a:off x="502920" y="4754880"/>
+            <a:ext cx="3186684" cy="2057400"/>
           </a:xfrm>
           <a:prstGeom prst="rect">
             <a:avLst/>
@@ -4243,7 +4243,7 @@
         </p:nvSpPr>
         <p:spPr>
           <a:xfrm>
-            <a:off x="3872484" y="4014216"/>
+            <a:off x="502920" y="6848856"/>
             <a:ext cx="3186684" cy="201168"/>
           </a:xfrm>
           <a:prstGeom prst="rect">
@@ -4267,7 +4267,7 @@
                   <a:schemeClr val="accent3"/>
                 </a:solidFill>
               </a:rPr>
-              <a:t>Gia công ống luồn dây tại hiện trường</a:t>
+              <a:t>Đi ống luồn dây dưới sàn</a:t>
             </a:r>
             <a:endParaRPr lang="en-US" sz="800" dirty="0"/>
           </a:p>
@@ -4275,7 +4275,7 @@
       </p:sp>
       <p:pic>
         <p:nvPicPr>
-          <p:cNvPr id="8" name="photo img03.jpg" descr="Đi ống luồn dây dưới sàn – Hà Nam, Ninh Bình">    </p:cNvPr>
+          <p:cNvPr id="8" name="photo img20.jpg" descr="Lắp giá đỡ, tuyến ống trên cao">    </p:cNvPr>
           <p:cNvPicPr>
             <a:picLocks noChangeAspect="1"/>
           </p:cNvPicPr>
@@ -4289,8 +4289,8 @@
         </p:blipFill>
         <p:spPr>
           <a:xfrm>
-            <a:off x="502920" y="4297680"/>
-            <a:ext cx="3186684" cy="2514600"/>
+            <a:off x="3872484" y="4754880"/>
+            <a:ext cx="3186684" cy="2057400"/>
           </a:xfrm>
           <a:prstGeom prst="rect">
             <a:avLst/>
@@ -4305,7 +4305,7 @@
         </p:nvSpPr>
         <p:spPr>
           <a:xfrm>
-            <a:off x="502920" y="6848856"/>
+            <a:off x="3872484" y="6848856"/>
             <a:ext cx="3186684" cy="201168"/>
           </a:xfrm>
           <a:prstGeom prst="rect">
@@ -4329,77 +4329,15 @@
                   <a:schemeClr val="accent3"/>
                 </a:solidFill>
               </a:rPr>
-              <a:t>Đi ống luồn dây dưới sàn – Hà Nam, Ninh Bình</a:t>
+              <a:t>Lắp giá đỡ, tuyến ống trên cao</a:t>
             </a:r>
             <a:endParaRPr lang="en-US" sz="800" dirty="0"/>
           </a:p>
         </p:txBody>
       </p:sp>
-      <p:pic>
-        <p:nvPicPr>
-          <p:cNvPr id="10" name="photo img20.jpg" descr="Lắp giá đỡ, tuyến ống trên cao – Hà Nam, Ninh Bình">    </p:cNvPr>
-          <p:cNvPicPr>
-            <a:picLocks noChangeAspect="1"/>
-          </p:cNvPicPr>
-          <p:nvPr/>
-        </p:nvPicPr>
-        <p:blipFill>
-          <a:blip r:embed="rId4"/>
-          <a:stretch>
-            <a:fillRect/>
-          </a:stretch>
-        </p:blipFill>
-        <p:spPr>
-          <a:xfrm>
-            <a:off x="3872484" y="4297680"/>
-            <a:ext cx="3186684" cy="2514600"/>
-          </a:xfrm>
-          <a:prstGeom prst="rect">
-            <a:avLst/>
-          </a:prstGeom>
-        </p:spPr>
-      </p:pic>
-      <p:sp>
-        <p:nvSpPr>
-          <p:cNvPr id="11" name="Text 5"/>
-          <p:cNvSpPr txBox="1"/>
-          <p:nvPr/>
-        </p:nvSpPr>
-        <p:spPr>
-          <a:xfrm>
-            <a:off x="3872484" y="6848856"/>
-            <a:ext cx="3186684" cy="201168"/>
-          </a:xfrm>
-          <a:prstGeom prst="rect">
-            <a:avLst/>
-          </a:prstGeom>
-          <a:noFill/>
-          <a:ln/>
-        </p:spPr>
-        <p:txBody>
-          <a:bodyPr wrap="square" lIns="0" tIns="0" rIns="0" bIns="0" rtlCol="0" anchor="ctr">
-            <a:normAutofit/>
-          </a:bodyPr>
-          <a:lstStyle/>
-          <a:p>
-            <a:pPr indent="0" marL="0">
-              <a:buNone/>
-            </a:pPr>
-            <a:r>
-              <a:rPr lang="en-US" sz="800" i="1" dirty="0">
-                <a:solidFill>
-                  <a:schemeClr val="accent3"/>
-                </a:solidFill>
-              </a:rPr>
-              <a:t>Lắp giá đỡ, tuyến ống trên cao – Hà Nam, Ninh Bình</a:t>
-            </a:r>
-            <a:endParaRPr lang="en-US" sz="800" dirty="0"/>
-          </a:p>
-        </p:txBody>
-      </p:sp>
-      <p:sp>
-        <p:nvSpPr>
-          <p:cNvPr id="12" name="Text 6"/>
+      <p:sp>
+        <p:nvSpPr>
+          <p:cNvPr id="10" name="Text 5"/>
           <p:cNvSpPr txBox="1"/>
           <p:nvPr/>
         </p:nvSpPr>
@@ -4438,7 +4376,7 @@
       </p:sp>
       <p:sp>
         <p:nvSpPr>
-          <p:cNvPr id="13" name="Shape 7"/>
+          <p:cNvPr id="11" name="Shape 6"/>
           <p:cNvSpPr/>
           <p:nvPr/>
         </p:nvSpPr>
@@ -4465,7 +4403,7 @@
       </p:sp>
       <p:sp>
         <p:nvSpPr>
-          <p:cNvPr id="14" name="Text 8"/>
+          <p:cNvPr id="12" name="Text 7"/>
           <p:cNvSpPr txBox="1"/>
           <p:nvPr/>
         </p:nvSpPr>
@@ -4595,7 +4533,7 @@
       </p:sp>
       <p:sp>
         <p:nvSpPr>
-          <p:cNvPr id="15" name="Text 9"/>
+          <p:cNvPr id="13" name="Text 8"/>
           <p:cNvSpPr txBox="1"/>
           <p:nvPr/>
         </p:nvSpPr>
@@ -4634,7 +4572,7 @@
       </p:sp>
       <p:sp>
         <p:nvSpPr>
-          <p:cNvPr id="16" name="Shape 10"/>
+          <p:cNvPr id="14" name="Shape 9"/>
           <p:cNvSpPr/>
           <p:nvPr/>
         </p:nvSpPr>
@@ -4661,7 +4599,7 @@
       </p:sp>
       <p:sp>
         <p:nvSpPr>
-          <p:cNvPr id="17" name="Text 11"/>
+          <p:cNvPr id="15" name="Text 10"/>
           <p:cNvSpPr txBox="1"/>
           <p:nvPr/>
         </p:nvSpPr>
@@ -8560,7 +8498,7 @@
       </p:sp>
       <p:pic>
         <p:nvPicPr>
-          <p:cNvPr id="4" name="photo img38.jpg" descr="Khung đỡ và tuyến ống công nghệ trạm xử lý nước – Thành phố Huế (09/2026)">    </p:cNvPr>
+          <p:cNvPr id="4" name="photo img60.jpg" descr="Bồn hóa chất, máy khuấy, bơm định lượng và hệ màng UF/RO – Thành phố Huế (09/2026)">    </p:cNvPr>
           <p:cNvPicPr>
             <a:picLocks noChangeAspect="1"/>
           </p:cNvPicPr>
@@ -8614,7 +8552,7 @@
                   <a:schemeClr val="accent3"/>
                 </a:solidFill>
               </a:rPr>
-              <a:t>Khung đỡ và tuyến ống công nghệ trạm xử lý nước – Thành phố Huế (09/2026)</a:t>
+              <a:t>Bồn hóa chất, máy khuấy, bơm định lượng và hệ màng UF/RO – Thành phố Huế (09/2026)</a:t>
             </a:r>
             <a:endParaRPr lang="en-US" sz="800" dirty="0"/>
           </a:p>
@@ -22717,7 +22655,7 @@
       </p:graphicFrame>
       <p:pic>
         <p:nvPicPr>
-          <p:cNvPr id="5" name="photo img48.jpg" descr="Lắp bơm định lượng hóa chất">    </p:cNvPr>
+          <p:cNvPr id="5" name="photo img16.jpg" descr="Lắp đặt cụm bơm, van và đồng hồ áp">    </p:cNvPr>
           <p:cNvPicPr>
             <a:picLocks noChangeAspect="1"/>
           </p:cNvPicPr>
@@ -22732,7 +22670,7 @@
         <p:spPr>
           <a:xfrm>
             <a:off x="502920" y="3200400"/>
-            <a:ext cx="3186684" cy="2743200"/>
+            <a:ext cx="6556248" cy="3017520"/>
           </a:xfrm>
           <a:prstGeom prst="rect">
             <a:avLst/>
@@ -22747,8 +22685,8 @@
         </p:nvSpPr>
         <p:spPr>
           <a:xfrm>
-            <a:off x="502920" y="5980176"/>
-            <a:ext cx="3186684" cy="201168"/>
+            <a:off x="502920" y="6254496"/>
+            <a:ext cx="6556248" cy="201168"/>
           </a:xfrm>
           <a:prstGeom prst="rect">
             <a:avLst/>
@@ -22771,7 +22709,7 @@
                   <a:schemeClr val="accent3"/>
                 </a:solidFill>
               </a:rPr>
-              <a:t>Lắp bơm định lượng hóa chất</a:t>
+              <a:t>Lắp đặt cụm bơm, van và đồng hồ áp</a:t>
             </a:r>
             <a:endParaRPr lang="en-US" sz="800" dirty="0"/>
           </a:p>
@@ -22779,7 +22717,7 @@
       </p:sp>
       <p:pic>
         <p:nvPicPr>
-          <p:cNvPr id="7" name="photo img16.jpg" descr="Lắp đặt cụm bơm, van và đồng hồ áp">    </p:cNvPr>
+          <p:cNvPr id="7" name="photo img48.jpg" descr="Lắp bơm định lượng hóa chất">    </p:cNvPr>
           <p:cNvPicPr>
             <a:picLocks noChangeAspect="1"/>
           </p:cNvPicPr>
@@ -22793,8 +22731,8 @@
         </p:blipFill>
         <p:spPr>
           <a:xfrm>
-            <a:off x="3872484" y="3200400"/>
-            <a:ext cx="3186684" cy="2743200"/>
+            <a:off x="502920" y="6583680"/>
+            <a:ext cx="3186684" cy="3017520"/>
           </a:xfrm>
           <a:prstGeom prst="rect">
             <a:avLst/>
@@ -22809,7 +22747,7 @@
         </p:nvSpPr>
         <p:spPr>
           <a:xfrm>
-            <a:off x="3872484" y="5980176"/>
+            <a:off x="502920" y="9637776"/>
             <a:ext cx="3186684" cy="201168"/>
           </a:xfrm>
           <a:prstGeom prst="rect">
@@ -22833,7 +22771,7 @@
                   <a:schemeClr val="accent3"/>
                 </a:solidFill>
               </a:rPr>
-              <a:t>Lắp đặt cụm bơm, van và đồng hồ áp</a:t>
+              <a:t>Lắp bơm định lượng hóa chất</a:t>
             </a:r>
             <a:endParaRPr lang="en-US" sz="800" dirty="0"/>
           </a:p>
@@ -22855,8 +22793,8 @@
         </p:blipFill>
         <p:spPr>
           <a:xfrm>
-            <a:off x="502920" y="6309360"/>
-            <a:ext cx="3186684" cy="3291840"/>
+            <a:off x="3872484" y="6583680"/>
+            <a:ext cx="3186684" cy="3017520"/>
           </a:xfrm>
           <a:prstGeom prst="rect">
             <a:avLst/>
@@ -22871,7 +22809,7 @@
         </p:nvSpPr>
         <p:spPr>
           <a:xfrm>
-            <a:off x="502920" y="9637776"/>
+            <a:off x="3872484" y="9637776"/>
             <a:ext cx="3186684" cy="201168"/>
           </a:xfrm>
           <a:prstGeom prst="rect">
@@ -22896,68 +22834,6 @@
                 </a:solidFill>
               </a:rPr>
               <a:t>Thi công khung đỡ ống trên cao</a:t>
-            </a:r>
-            <a:endParaRPr lang="en-US" sz="800" dirty="0"/>
-          </a:p>
-        </p:txBody>
-      </p:sp>
-      <p:pic>
-        <p:nvPicPr>
-          <p:cNvPr id="11" name="photo img60.jpg" descr="Bồn hóa chất, máy khuấy và hệ màng UF/RO">    </p:cNvPr>
-          <p:cNvPicPr>
-            <a:picLocks noChangeAspect="1"/>
-          </p:cNvPicPr>
-          <p:nvPr/>
-        </p:nvPicPr>
-        <p:blipFill>
-          <a:blip r:embed="rId4"/>
-          <a:stretch>
-            <a:fillRect/>
-          </a:stretch>
-        </p:blipFill>
-        <p:spPr>
-          <a:xfrm>
-            <a:off x="3872484" y="6309360"/>
-            <a:ext cx="3186684" cy="3291840"/>
-          </a:xfrm>
-          <a:prstGeom prst="rect">
-            <a:avLst/>
-          </a:prstGeom>
-        </p:spPr>
-      </p:pic>
-      <p:sp>
-        <p:nvSpPr>
-          <p:cNvPr id="12" name="Text 5"/>
-          <p:cNvSpPr txBox="1"/>
-          <p:nvPr/>
-        </p:nvSpPr>
-        <p:spPr>
-          <a:xfrm>
-            <a:off x="3872484" y="9637776"/>
-            <a:ext cx="3186684" cy="201168"/>
-          </a:xfrm>
-          <a:prstGeom prst="rect">
-            <a:avLst/>
-          </a:prstGeom>
-          <a:noFill/>
-          <a:ln/>
-        </p:spPr>
-        <p:txBody>
-          <a:bodyPr wrap="square" lIns="0" tIns="0" rIns="0" bIns="0" rtlCol="0" anchor="ctr">
-            <a:normAutofit/>
-          </a:bodyPr>
-          <a:lstStyle/>
-          <a:p>
-            <a:pPr indent="0" marL="0">
-              <a:buNone/>
-            </a:pPr>
-            <a:r>
-              <a:rPr lang="en-US" sz="800" i="1" dirty="0">
-                <a:solidFill>
-                  <a:schemeClr val="accent3"/>
-                </a:solidFill>
-              </a:rPr>
-              <a:t>Bồn hóa chất, máy khuấy và hệ màng UF/RO</a:t>
             </a:r>
             <a:endParaRPr lang="en-US" sz="800" dirty="0"/>
           </a:p>
@@ -28920,6 +28796,42 @@
         </p:nvSpPr>
         <p:spPr>
           <a:xfrm>
+            <a:off x="1143000" y="9390888"/>
+            <a:ext cx="4754880" cy="228600"/>
+          </a:xfrm>
+          <a:prstGeom prst="rect">
+            <a:avLst/>
+          </a:prstGeom>
+          <a:noFill/>
+          <a:ln/>
+        </p:spPr>
+        <p:txBody>
+          <a:bodyPr wrap="square" lIns="0" tIns="0" rIns="0" bIns="0" rtlCol="0" anchor="ctr"/>
+          <a:lstStyle/>
+          <a:p>
+            <a:pPr indent="0" marL="0">
+              <a:buNone/>
+            </a:pPr>
+            <a:r>
+              <a:rPr lang="en-US" sz="900" dirty="0">
+                <a:solidFill>
+                  <a:schemeClr val="accent3"/>
+                </a:solidFill>
+              </a:rPr>
+              <a:t>Cam kết chất lượng • Bảo hành • Thông tin liên hệ</a:t>
+            </a:r>
+            <a:endParaRPr lang="en-US" sz="900" dirty="0"/>
+          </a:p>
+        </p:txBody>
+      </p:sp>
+      <p:sp>
+        <p:nvSpPr>
+          <p:cNvPr id="51" name="Text 48"/>
+          <p:cNvSpPr txBox="1"/>
+          <p:nvPr/>
+        </p:nvSpPr>
+        <p:spPr>
+          <a:xfrm>
             <a:off x="5961888" y="9153144"/>
             <a:ext cx="1097280" cy="365760"/>
           </a:xfrm>
@@ -33989,7 +33901,7 @@
       </p:sp>
       <p:pic>
         <p:nvPicPr>
-          <p:cNvPr id="5" name="photo img12.jpg" descr="Ảnh hiện trường BLT">    </p:cNvPr>
+          <p:cNvPr id="5" name="photo img14.jpg" descr="Ảnh hiện trường BLT">    </p:cNvPr>
           <p:cNvPicPr>
             <a:picLocks noChangeAspect="1"/>
           </p:cNvPicPr>
@@ -34237,7 +34149,7 @@
       </p:sp>
       <p:pic>
         <p:nvPicPr>
-          <p:cNvPr id="11" name="photo img15.jpg" descr="Ảnh hiện trường BLT">    </p:cNvPr>
+          <p:cNvPr id="11" name="photo img38.jpg" descr="Ảnh hiện trường BLT">    </p:cNvPr>
           <p:cNvPicPr>
             <a:picLocks noChangeAspect="1"/>
           </p:cNvPicPr>

</xml_diff>

<commit_message>
Hồ sơ năng lực BLT: bỏ khung hồ sơ cung cấp khi có yêu cầu (trang 24)
Giãn bảng công trình và ô địa bàn thi công để lấp kín trang.

Co-Authored-By: Claude Opus 5.5 <noreply@anthropic.com>
Claude-Session: https://claude.ai/code/session_01SkwAuDP5YjDrv41kDvnzWb
</commit_message>
<xml_diff>
--- a/ho-so-nang-luc-BLT/HO_SO_NANG_LUC_BLT.pptx
+++ b/ho-so-nang-luc-BLT/HO_SO_NANG_LUC_BLT.pptx
@@ -132,14 +132,14 @@
   <p:extLst>
     <p:ext uri="{521415D9-36F7-43E2-AB2F-B90AF26B5E84}">
       <p14:sectionLst xmlns:p14="http://schemas.microsoft.com/office/powerpoint/2010/main">
-        <p14:section name="Mở đầu" id="{19dfa5f3-b608-e72f-8776-642710ee261e}">
+        <p14:section name="Mở đầu" id="{d2d75668-9e89-8362-847c-447f0a0cab44}">
           <p14:sldIdLst>
             <p14:sldId id="256"/>
             <p14:sldId id="257"/>
             <p14:sldId id="258"/>
           </p14:sldIdLst>
         </p14:section>
-        <p14:section name="01 Tổng quan" id="{e9e5db81-ae41-abed-d305-286ef1f787a3}">
+        <p14:section name="01 Tổng quan" id="{fe2ad2fc-a135-3a79-4a73-5d65b2964f31}">
           <p14:sldIdLst>
             <p14:sldId id="259"/>
             <p14:sldId id="260"/>
@@ -148,39 +148,39 @@
             <p14:sldId id="263"/>
           </p14:sldIdLst>
         </p14:section>
-        <p14:section name="02 Điện nước công trình" id="{8675cc9b-05b1-77c9-ad8d-2067faaa07b4}">
+        <p14:section name="02 Điện nước công trình" id="{4d191460-7e11-0b26-0a27-f80f0164c9ad}">
           <p14:sldIdLst>
             <p14:sldId id="264"/>
             <p14:sldId id="265"/>
             <p14:sldId id="266"/>
           </p14:sldIdLst>
         </p14:section>
-        <p14:section name="03 Hút sương dầu nhà xưởng" id="{fa9cf539-6568-d5a3-4bb7-e67529b179ad}">
+        <p14:section name="03 Hút sương dầu nhà xưởng" id="{f480d4e0-948d-8534-cb8a-c4ec9a9061e3}">
           <p14:sldIdLst>
             <p14:sldId id="267"/>
             <p14:sldId id="268"/>
             <p14:sldId id="269"/>
           </p14:sldIdLst>
         </p14:section>
-        <p14:section name="04 Bơm &amp; xử lý nước" id="{bd7950e4-df5c-8170-02ae-e86ec30d22da}">
+        <p14:section name="04 Bơm &amp; xử lý nước" id="{087c28b5-faf9-6bf3-317a-6aad68f07b4e}">
           <p14:sldIdLst>
             <p14:sldId id="270"/>
           </p14:sldIdLst>
         </p14:section>
-        <p14:section name="05 Quản trị dự án" id="{a268219a-9005-e449-f998-092717f87fff}">
+        <p14:section name="05 Quản trị dự án" id="{a0e624b9-b0e9-6e26-ca07-47cefd2450f1}">
           <p14:sldIdLst>
             <p14:sldId id="271"/>
             <p14:sldId id="272"/>
             <p14:sldId id="273"/>
           </p14:sldIdLst>
         </p14:section>
-        <p14:section name="06 Nguồn lực" id="{82069a71-d559-1cd8-0162-7fba3de01eee}">
+        <p14:section name="06 Nguồn lực" id="{59ba8e18-645e-b90c-d913-2adb7df5b24e}">
           <p14:sldIdLst>
             <p14:sldId id="274"/>
             <p14:sldId id="275"/>
           </p14:sldIdLst>
         </p14:section>
-        <p14:section name="07 Công trình tiêu biểu" id="{6c0a7e47-4f36-a894-e382-c145a6c7b5f5}">
+        <p14:section name="07 Công trình tiêu biểu" id="{50837fe0-90c7-16b4-dd0d-2072709c20ae}">
           <p14:sldIdLst>
             <p14:sldId id="276"/>
             <p14:sldId id="277"/>
@@ -188,7 +188,7 @@
             <p14:sldId id="279"/>
           </p14:sldIdLst>
         </p14:section>
-        <p14:section name="08 Cam kết &amp; liên hệ" id="{cffa540f-d4ce-ff54-b263-6fd1f2b4bccb}">
+        <p14:section name="08 Cam kết &amp; liên hệ" id="{78527d66-43e1-8beb-1b62-108563cb1944}">
           <p14:sldIdLst>
             <p14:sldId id="280"/>
             <p14:sldId id="281"/>
@@ -23013,7 +23013,7 @@
                 <a:gridCol w="2578608"/>
                 <a:gridCol w="960120"/>
               </a:tblGrid>
-              <a:tr h="457200">
+              <a:tr h="502920">
                 <a:tc>
                   <a:txBody>
                     <a:bodyPr/>
@@ -23259,7 +23259,7 @@
                   </a:tcPr>
                 </a:tc>
               </a:tr>
-              <a:tr h="914400">
+              <a:tr h="1097280">
                 <a:tc>
                   <a:txBody>
                     <a:bodyPr/>
@@ -23519,7 +23519,7 @@
                   </a:tcPr>
                 </a:tc>
               </a:tr>
-              <a:tr h="914400">
+              <a:tr h="1097280">
                 <a:tc>
                   <a:txBody>
                     <a:bodyPr/>
@@ -23779,7 +23779,7 @@
                   </a:tcPr>
                 </a:tc>
               </a:tr>
-              <a:tr h="914400">
+              <a:tr h="1097280">
                 <a:tc>
                   <a:txBody>
                     <a:bodyPr/>
@@ -24051,7 +24051,7 @@
         </p:nvSpPr>
         <p:spPr>
           <a:xfrm>
-            <a:off x="502920" y="5120640"/>
+            <a:off x="502920" y="5760720"/>
             <a:ext cx="6556248" cy="228600"/>
           </a:xfrm>
           <a:prstGeom prst="rect">
@@ -24090,8 +24090,8 @@
         </p:nvSpPr>
         <p:spPr>
           <a:xfrm>
-            <a:off x="502920" y="5394960"/>
-            <a:ext cx="2063496" cy="2377440"/>
+            <a:off x="502920" y="6035040"/>
+            <a:ext cx="2063496" cy="3520440"/>
           </a:xfrm>
           <a:prstGeom prst="roundRect">
             <a:avLst>
@@ -24117,8 +24117,8 @@
         </p:nvSpPr>
         <p:spPr>
           <a:xfrm>
-            <a:off x="685800" y="5559552"/>
-            <a:ext cx="411480" cy="411480"/>
+            <a:off x="731520" y="6263640"/>
+            <a:ext cx="502920" cy="502920"/>
           </a:xfrm>
           <a:prstGeom prst="ellipse">
             <a:avLst/>
@@ -24142,8 +24142,8 @@
         </p:nvSpPr>
         <p:spPr>
           <a:xfrm>
-            <a:off x="685800" y="5559552"/>
-            <a:ext cx="411480" cy="411480"/>
+            <a:off x="731520" y="6263640"/>
+            <a:ext cx="502920" cy="502920"/>
           </a:xfrm>
           <a:prstGeom prst="rect">
             <a:avLst/>
@@ -24159,7 +24159,7 @@
               <a:buNone/>
             </a:pPr>
             <a:r>
-              <a:rPr lang="en-US" sz="1050" b="1" dirty="0">
+              <a:rPr lang="en-US" sz="1300" b="1" dirty="0">
                 <a:solidFill>
                   <a:schemeClr val="bg1"/>
                 </a:solidFill>
@@ -24169,7 +24169,7 @@
               </a:rPr>
               <a:t>01</a:t>
             </a:r>
-            <a:endParaRPr lang="en-US" sz="1050" dirty="0"/>
+            <a:endParaRPr lang="en-US" sz="1300" dirty="0"/>
           </a:p>
         </p:txBody>
       </p:sp>
@@ -24181,8 +24181,8 @@
         </p:nvSpPr>
         <p:spPr>
           <a:xfrm>
-            <a:off x="685800" y="6080760"/>
-            <a:ext cx="1697736" cy="365760"/>
+            <a:off x="731520" y="6949440"/>
+            <a:ext cx="1606296" cy="457200"/>
           </a:xfrm>
           <a:prstGeom prst="rect">
             <a:avLst/>
@@ -24198,7 +24198,7 @@
               <a:buNone/>
             </a:pPr>
             <a:r>
-              <a:rPr lang="en-US" sz="1600" b="1" dirty="0">
+              <a:rPr lang="en-US" sz="2000" b="1" dirty="0">
                 <a:solidFill>
                   <a:schemeClr val="accent1"/>
                 </a:solidFill>
@@ -24208,7 +24208,7 @@
               </a:rPr>
               <a:t>NGHỆ AN</a:t>
             </a:r>
-            <a:endParaRPr lang="en-US" sz="1600" dirty="0"/>
+            <a:endParaRPr lang="en-US" sz="2000" dirty="0"/>
           </a:p>
         </p:txBody>
       </p:sp>
@@ -24220,8 +24220,8 @@
         </p:nvSpPr>
         <p:spPr>
           <a:xfrm>
-            <a:off x="685800" y="6492240"/>
-            <a:ext cx="1697736" cy="457200"/>
+            <a:off x="731520" y="7498080"/>
+            <a:ext cx="1606296" cy="594360"/>
           </a:xfrm>
           <a:prstGeom prst="rect">
             <a:avLst/>
@@ -24237,99 +24237,122 @@
               <a:buNone/>
             </a:pPr>
             <a:r>
-              <a:rPr lang="en-US" sz="1050" b="1" dirty="0">
+              <a:rPr lang="en-US" sz="1200" b="1" dirty="0">
                 <a:solidFill>
                   <a:schemeClr val="bg1"/>
                 </a:solidFill>
               </a:rPr>
               <a:t>Nhà xưởng gia công CNC</a:t>
             </a:r>
+            <a:endParaRPr lang="en-US" sz="1200" dirty="0"/>
+          </a:p>
+        </p:txBody>
+      </p:sp>
+      <p:sp>
+        <p:nvSpPr>
+          <p:cNvPr id="11" name="Text 8"/>
+          <p:cNvSpPr txBox="1"/>
+          <p:nvPr/>
+        </p:nvSpPr>
+        <p:spPr>
+          <a:xfrm>
+            <a:off x="731520" y="8183880"/>
+            <a:ext cx="1606296" cy="594360"/>
+          </a:xfrm>
+          <a:prstGeom prst="rect">
+            <a:avLst/>
+          </a:prstGeom>
+          <a:noFill/>
+          <a:ln/>
+        </p:spPr>
+        <p:txBody>
+          <a:bodyPr wrap="square" lIns="0" tIns="0" rIns="0" bIns="0" rtlCol="0" anchor="t"/>
+          <a:lstStyle/>
+          <a:p>
+            <a:pPr indent="0" marL="0">
+              <a:buNone/>
+            </a:pPr>
+            <a:r>
+              <a:rPr lang="en-US" sz="1050" dirty="0">
+                <a:solidFill>
+                  <a:schemeClr val="accent4"/>
+                </a:solidFill>
+              </a:rPr>
+              <a:t>Hút sương dầu, máy lọc, điện</a:t>
+            </a:r>
             <a:endParaRPr lang="en-US" sz="1050" dirty="0"/>
           </a:p>
         </p:txBody>
       </p:sp>
       <p:sp>
         <p:nvSpPr>
-          <p:cNvPr id="11" name="Text 8"/>
-          <p:cNvSpPr txBox="1"/>
-          <p:nvPr/>
-        </p:nvSpPr>
-        <p:spPr>
-          <a:xfrm>
-            <a:off x="685800" y="6949440"/>
-            <a:ext cx="1697736" cy="411480"/>
-          </a:xfrm>
-          <a:prstGeom prst="rect">
-            <a:avLst/>
-          </a:prstGeom>
-          <a:noFill/>
-          <a:ln/>
-        </p:spPr>
-        <p:txBody>
-          <a:bodyPr wrap="square" lIns="0" tIns="0" rIns="0" bIns="0" rtlCol="0" anchor="t"/>
+          <p:cNvPr id="12" name="Shape 9"/>
+          <p:cNvSpPr/>
+          <p:nvPr/>
+        </p:nvSpPr>
+        <p:spPr>
+          <a:xfrm>
+            <a:off x="731520" y="8915400"/>
+            <a:ext cx="1606296" cy="0"/>
+          </a:xfrm>
+          <a:prstGeom prst="line">
+            <a:avLst/>
+          </a:prstGeom>
+          <a:noFill/>
+          <a:ln w="9525">
+            <a:solidFill>
+              <a:schemeClr val="accent3"/>
+            </a:solidFill>
+            <a:prstDash val="solid"/>
+          </a:ln>
+        </p:spPr>
+      </p:sp>
+      <p:sp>
+        <p:nvSpPr>
+          <p:cNvPr id="13" name="Text 10"/>
+          <p:cNvSpPr txBox="1"/>
+          <p:nvPr/>
+        </p:nvSpPr>
+        <p:spPr>
+          <a:xfrm>
+            <a:off x="731520" y="9034272"/>
+            <a:ext cx="1606296" cy="292608"/>
+          </a:xfrm>
+          <a:prstGeom prst="rect">
+            <a:avLst/>
+          </a:prstGeom>
+          <a:noFill/>
+          <a:ln/>
+        </p:spPr>
+        <p:txBody>
+          <a:bodyPr wrap="square" lIns="0" tIns="0" rIns="0" bIns="0" rtlCol="0" anchor="ctr"/>
           <a:lstStyle/>
           <a:p>
             <a:pPr indent="0" marL="0">
               <a:buNone/>
             </a:pPr>
             <a:r>
-              <a:rPr lang="en-US" sz="900" dirty="0">
-                <a:solidFill>
-                  <a:schemeClr val="accent4"/>
-                </a:solidFill>
-              </a:rPr>
-              <a:t>Hút sương dầu, máy lọc, điện</a:t>
-            </a:r>
-            <a:endParaRPr lang="en-US" sz="900" dirty="0"/>
-          </a:p>
-        </p:txBody>
-      </p:sp>
-      <p:sp>
-        <p:nvSpPr>
-          <p:cNvPr id="12" name="Text 9"/>
-          <p:cNvSpPr txBox="1"/>
-          <p:nvPr/>
-        </p:nvSpPr>
-        <p:spPr>
-          <a:xfrm>
-            <a:off x="685800" y="7388352"/>
-            <a:ext cx="1697736" cy="256032"/>
-          </a:xfrm>
-          <a:prstGeom prst="rect">
-            <a:avLst/>
-          </a:prstGeom>
-          <a:noFill/>
-          <a:ln/>
-        </p:spPr>
-        <p:txBody>
-          <a:bodyPr wrap="square" lIns="0" tIns="0" rIns="0" bIns="0" rtlCol="0" anchor="ctr"/>
-          <a:lstStyle/>
-          <a:p>
-            <a:pPr indent="0" marL="0">
-              <a:buNone/>
-            </a:pPr>
-            <a:r>
-              <a:rPr lang="en-US" sz="900" b="1" dirty="0">
+              <a:rPr lang="en-US" sz="1100" b="1" dirty="0">
                 <a:solidFill>
                   <a:schemeClr val="accent6"/>
                 </a:solidFill>
               </a:rPr>
               <a:t>09–10/2026</a:t>
             </a:r>
-            <a:endParaRPr lang="en-US" sz="900" dirty="0"/>
-          </a:p>
-        </p:txBody>
-      </p:sp>
-      <p:sp>
-        <p:nvSpPr>
-          <p:cNvPr id="13" name="Shape 10"/>
+            <a:endParaRPr lang="en-US" sz="1100" dirty="0"/>
+          </a:p>
+        </p:txBody>
+      </p:sp>
+      <p:sp>
+        <p:nvSpPr>
+          <p:cNvPr id="14" name="Shape 11"/>
           <p:cNvSpPr/>
           <p:nvPr/>
         </p:nvSpPr>
         <p:spPr>
           <a:xfrm>
-            <a:off x="2749296" y="5394960"/>
-            <a:ext cx="2063496" cy="2377440"/>
+            <a:off x="2749296" y="6035040"/>
+            <a:ext cx="2063496" cy="3520440"/>
           </a:xfrm>
           <a:prstGeom prst="roundRect">
             <a:avLst>
@@ -24349,14 +24372,14 @@
       </p:sp>
       <p:sp>
         <p:nvSpPr>
-          <p:cNvPr id="14" name="Shape 11"/>
+          <p:cNvPr id="15" name="Shape 12"/>
           <p:cNvSpPr/>
           <p:nvPr/>
         </p:nvSpPr>
         <p:spPr>
           <a:xfrm>
-            <a:off x="2932176" y="5559552"/>
-            <a:ext cx="411480" cy="411480"/>
+            <a:off x="2977896" y="6263640"/>
+            <a:ext cx="502920" cy="502920"/>
           </a:xfrm>
           <a:prstGeom prst="ellipse">
             <a:avLst/>
@@ -24374,14 +24397,14 @@
       </p:sp>
       <p:sp>
         <p:nvSpPr>
-          <p:cNvPr id="15" name="Text 12"/>
-          <p:cNvSpPr txBox="1"/>
-          <p:nvPr/>
-        </p:nvSpPr>
-        <p:spPr>
-          <a:xfrm>
-            <a:off x="2932176" y="5559552"/>
-            <a:ext cx="411480" cy="411480"/>
+          <p:cNvPr id="16" name="Text 13"/>
+          <p:cNvSpPr txBox="1"/>
+          <p:nvPr/>
+        </p:nvSpPr>
+        <p:spPr>
+          <a:xfrm>
+            <a:off x="2977896" y="6263640"/>
+            <a:ext cx="502920" cy="502920"/>
           </a:xfrm>
           <a:prstGeom prst="rect">
             <a:avLst/>
@@ -24397,7 +24420,7 @@
               <a:buNone/>
             </a:pPr>
             <a:r>
-              <a:rPr lang="en-US" sz="1050" b="1" dirty="0">
+              <a:rPr lang="en-US" sz="1300" b="1" dirty="0">
                 <a:solidFill>
                   <a:schemeClr val="bg1"/>
                 </a:solidFill>
@@ -24407,20 +24430,20 @@
               </a:rPr>
               <a:t>02</a:t>
             </a:r>
-            <a:endParaRPr lang="en-US" sz="1050" dirty="0"/>
-          </a:p>
-        </p:txBody>
-      </p:sp>
-      <p:sp>
-        <p:nvSpPr>
-          <p:cNvPr id="16" name="Text 13"/>
-          <p:cNvSpPr txBox="1"/>
-          <p:nvPr/>
-        </p:nvSpPr>
-        <p:spPr>
-          <a:xfrm>
-            <a:off x="2932176" y="6080760"/>
-            <a:ext cx="1697736" cy="365760"/>
+            <a:endParaRPr lang="en-US" sz="1300" dirty="0"/>
+          </a:p>
+        </p:txBody>
+      </p:sp>
+      <p:sp>
+        <p:nvSpPr>
+          <p:cNvPr id="17" name="Text 14"/>
+          <p:cNvSpPr txBox="1"/>
+          <p:nvPr/>
+        </p:nvSpPr>
+        <p:spPr>
+          <a:xfrm>
+            <a:off x="2977896" y="6949440"/>
+            <a:ext cx="1606296" cy="457200"/>
           </a:xfrm>
           <a:prstGeom prst="rect">
             <a:avLst/>
@@ -24436,7 +24459,7 @@
               <a:buNone/>
             </a:pPr>
             <a:r>
-              <a:rPr lang="en-US" sz="1600" b="1" dirty="0">
+              <a:rPr lang="en-US" sz="2000" b="1" dirty="0">
                 <a:solidFill>
                   <a:schemeClr val="accent1"/>
                 </a:solidFill>
@@ -24446,20 +24469,20 @@
               </a:rPr>
               <a:t>NINH BÌNH</a:t>
             </a:r>
-            <a:endParaRPr lang="en-US" sz="1600" dirty="0"/>
-          </a:p>
-        </p:txBody>
-      </p:sp>
-      <p:sp>
-        <p:nvSpPr>
-          <p:cNvPr id="17" name="Text 14"/>
-          <p:cNvSpPr txBox="1"/>
-          <p:nvPr/>
-        </p:nvSpPr>
-        <p:spPr>
-          <a:xfrm>
-            <a:off x="2932176" y="6492240"/>
-            <a:ext cx="1697736" cy="457200"/>
+            <a:endParaRPr lang="en-US" sz="2000" dirty="0"/>
+          </a:p>
+        </p:txBody>
+      </p:sp>
+      <p:sp>
+        <p:nvSpPr>
+          <p:cNvPr id="18" name="Text 15"/>
+          <p:cNvSpPr txBox="1"/>
+          <p:nvPr/>
+        </p:nvSpPr>
+        <p:spPr>
+          <a:xfrm>
+            <a:off x="2977896" y="7498080"/>
+            <a:ext cx="1606296" cy="594360"/>
           </a:xfrm>
           <a:prstGeom prst="rect">
             <a:avLst/>
@@ -24475,86 +24498,50 @@
               <a:buNone/>
             </a:pPr>
             <a:r>
-              <a:rPr lang="en-US" sz="1050" b="1" dirty="0">
+              <a:rPr lang="en-US" sz="1200" b="1" dirty="0">
                 <a:solidFill>
                   <a:schemeClr val="bg1"/>
                 </a:solidFill>
               </a:rPr>
               <a:t>Công trình nhiều tầng</a:t>
             </a:r>
+            <a:endParaRPr lang="en-US" sz="1200" dirty="0"/>
+          </a:p>
+        </p:txBody>
+      </p:sp>
+      <p:sp>
+        <p:nvSpPr>
+          <p:cNvPr id="19" name="Text 16"/>
+          <p:cNvSpPr txBox="1"/>
+          <p:nvPr/>
+        </p:nvSpPr>
+        <p:spPr>
+          <a:xfrm>
+            <a:off x="2977896" y="8183880"/>
+            <a:ext cx="1606296" cy="594360"/>
+          </a:xfrm>
+          <a:prstGeom prst="rect">
+            <a:avLst/>
+          </a:prstGeom>
+          <a:noFill/>
+          <a:ln/>
+        </p:spPr>
+        <p:txBody>
+          <a:bodyPr wrap="square" lIns="0" tIns="0" rIns="0" bIns="0" rtlCol="0" anchor="t"/>
+          <a:lstStyle/>
+          <a:p>
+            <a:pPr indent="0" marL="0">
+              <a:buNone/>
+            </a:pPr>
+            <a:r>
+              <a:rPr lang="en-US" sz="1050" dirty="0">
+                <a:solidFill>
+                  <a:schemeClr val="accent4"/>
+                </a:solidFill>
+              </a:rPr>
+              <a:t>Điện, cấp thoát nước</a:t>
+            </a:r>
             <a:endParaRPr lang="en-US" sz="1050" dirty="0"/>
-          </a:p>
-        </p:txBody>
-      </p:sp>
-      <p:sp>
-        <p:nvSpPr>
-          <p:cNvPr id="18" name="Text 15"/>
-          <p:cNvSpPr txBox="1"/>
-          <p:nvPr/>
-        </p:nvSpPr>
-        <p:spPr>
-          <a:xfrm>
-            <a:off x="2932176" y="6949440"/>
-            <a:ext cx="1697736" cy="411480"/>
-          </a:xfrm>
-          <a:prstGeom prst="rect">
-            <a:avLst/>
-          </a:prstGeom>
-          <a:noFill/>
-          <a:ln/>
-        </p:spPr>
-        <p:txBody>
-          <a:bodyPr wrap="square" lIns="0" tIns="0" rIns="0" bIns="0" rtlCol="0" anchor="t"/>
-          <a:lstStyle/>
-          <a:p>
-            <a:pPr indent="0" marL="0">
-              <a:buNone/>
-            </a:pPr>
-            <a:r>
-              <a:rPr lang="en-US" sz="900" dirty="0">
-                <a:solidFill>
-                  <a:schemeClr val="accent4"/>
-                </a:solidFill>
-              </a:rPr>
-              <a:t>Điện, cấp thoát nước</a:t>
-            </a:r>
-            <a:endParaRPr lang="en-US" sz="900" dirty="0"/>
-          </a:p>
-        </p:txBody>
-      </p:sp>
-      <p:sp>
-        <p:nvSpPr>
-          <p:cNvPr id="19" name="Text 16"/>
-          <p:cNvSpPr txBox="1"/>
-          <p:nvPr/>
-        </p:nvSpPr>
-        <p:spPr>
-          <a:xfrm>
-            <a:off x="2932176" y="7388352"/>
-            <a:ext cx="1697736" cy="256032"/>
-          </a:xfrm>
-          <a:prstGeom prst="rect">
-            <a:avLst/>
-          </a:prstGeom>
-          <a:noFill/>
-          <a:ln/>
-        </p:spPr>
-        <p:txBody>
-          <a:bodyPr wrap="square" lIns="0" tIns="0" rIns="0" bIns="0" rtlCol="0" anchor="ctr"/>
-          <a:lstStyle/>
-          <a:p>
-            <a:pPr indent="0" marL="0">
-              <a:buNone/>
-            </a:pPr>
-            <a:r>
-              <a:rPr lang="en-US" sz="900" b="1" dirty="0">
-                <a:solidFill>
-                  <a:schemeClr val="accent6"/>
-                </a:solidFill>
-              </a:rPr>
-              <a:t>09/2026</a:t>
-            </a:r>
-            <a:endParaRPr lang="en-US" sz="900" dirty="0"/>
           </a:p>
         </p:txBody>
       </p:sp>
@@ -24566,8 +24553,67 @@
         </p:nvSpPr>
         <p:spPr>
           <a:xfrm>
-            <a:off x="4995672" y="5394960"/>
-            <a:ext cx="2063496" cy="2377440"/>
+            <a:off x="2977896" y="8915400"/>
+            <a:ext cx="1606296" cy="0"/>
+          </a:xfrm>
+          <a:prstGeom prst="line">
+            <a:avLst/>
+          </a:prstGeom>
+          <a:noFill/>
+          <a:ln w="9525">
+            <a:solidFill>
+              <a:schemeClr val="accent3"/>
+            </a:solidFill>
+            <a:prstDash val="solid"/>
+          </a:ln>
+        </p:spPr>
+      </p:sp>
+      <p:sp>
+        <p:nvSpPr>
+          <p:cNvPr id="21" name="Text 18"/>
+          <p:cNvSpPr txBox="1"/>
+          <p:nvPr/>
+        </p:nvSpPr>
+        <p:spPr>
+          <a:xfrm>
+            <a:off x="2977896" y="9034272"/>
+            <a:ext cx="1606296" cy="292608"/>
+          </a:xfrm>
+          <a:prstGeom prst="rect">
+            <a:avLst/>
+          </a:prstGeom>
+          <a:noFill/>
+          <a:ln/>
+        </p:spPr>
+        <p:txBody>
+          <a:bodyPr wrap="square" lIns="0" tIns="0" rIns="0" bIns="0" rtlCol="0" anchor="ctr"/>
+          <a:lstStyle/>
+          <a:p>
+            <a:pPr indent="0" marL="0">
+              <a:buNone/>
+            </a:pPr>
+            <a:r>
+              <a:rPr lang="en-US" sz="1100" b="1" dirty="0">
+                <a:solidFill>
+                  <a:schemeClr val="accent6"/>
+                </a:solidFill>
+              </a:rPr>
+              <a:t>09/2026</a:t>
+            </a:r>
+            <a:endParaRPr lang="en-US" sz="1100" dirty="0"/>
+          </a:p>
+        </p:txBody>
+      </p:sp>
+      <p:sp>
+        <p:nvSpPr>
+          <p:cNvPr id="22" name="Shape 19"/>
+          <p:cNvSpPr/>
+          <p:nvPr/>
+        </p:nvSpPr>
+        <p:spPr>
+          <a:xfrm>
+            <a:off x="4995672" y="6035040"/>
+            <a:ext cx="2063496" cy="3520440"/>
           </a:xfrm>
           <a:prstGeom prst="roundRect">
             <a:avLst>
@@ -24587,14 +24633,14 @@
       </p:sp>
       <p:sp>
         <p:nvSpPr>
-          <p:cNvPr id="21" name="Shape 18"/>
+          <p:cNvPr id="23" name="Shape 20"/>
           <p:cNvSpPr/>
           <p:nvPr/>
         </p:nvSpPr>
         <p:spPr>
           <a:xfrm>
-            <a:off x="5178552" y="5559552"/>
-            <a:ext cx="411480" cy="411480"/>
+            <a:off x="5224272" y="6263640"/>
+            <a:ext cx="502920" cy="502920"/>
           </a:xfrm>
           <a:prstGeom prst="ellipse">
             <a:avLst/>
@@ -24612,14 +24658,14 @@
       </p:sp>
       <p:sp>
         <p:nvSpPr>
-          <p:cNvPr id="22" name="Text 19"/>
-          <p:cNvSpPr txBox="1"/>
-          <p:nvPr/>
-        </p:nvSpPr>
-        <p:spPr>
-          <a:xfrm>
-            <a:off x="5178552" y="5559552"/>
-            <a:ext cx="411480" cy="411480"/>
+          <p:cNvPr id="24" name="Text 21"/>
+          <p:cNvSpPr txBox="1"/>
+          <p:nvPr/>
+        </p:nvSpPr>
+        <p:spPr>
+          <a:xfrm>
+            <a:off x="5224272" y="6263640"/>
+            <a:ext cx="502920" cy="502920"/>
           </a:xfrm>
           <a:prstGeom prst="rect">
             <a:avLst/>
@@ -24635,7 +24681,7 @@
               <a:buNone/>
             </a:pPr>
             <a:r>
-              <a:rPr lang="en-US" sz="1050" b="1" dirty="0">
+              <a:rPr lang="en-US" sz="1300" b="1" dirty="0">
                 <a:solidFill>
                   <a:schemeClr val="bg1"/>
                 </a:solidFill>
@@ -24645,20 +24691,20 @@
               </a:rPr>
               <a:t>03</a:t>
             </a:r>
-            <a:endParaRPr lang="en-US" sz="1050" dirty="0"/>
-          </a:p>
-        </p:txBody>
-      </p:sp>
-      <p:sp>
-        <p:nvSpPr>
-          <p:cNvPr id="23" name="Text 20"/>
-          <p:cNvSpPr txBox="1"/>
-          <p:nvPr/>
-        </p:nvSpPr>
-        <p:spPr>
-          <a:xfrm>
-            <a:off x="5178552" y="6080760"/>
-            <a:ext cx="1697736" cy="365760"/>
+            <a:endParaRPr lang="en-US" sz="1300" dirty="0"/>
+          </a:p>
+        </p:txBody>
+      </p:sp>
+      <p:sp>
+        <p:nvSpPr>
+          <p:cNvPr id="25" name="Text 22"/>
+          <p:cNvSpPr txBox="1"/>
+          <p:nvPr/>
+        </p:nvSpPr>
+        <p:spPr>
+          <a:xfrm>
+            <a:off x="5224272" y="6949440"/>
+            <a:ext cx="1606296" cy="457200"/>
           </a:xfrm>
           <a:prstGeom prst="rect">
             <a:avLst/>
@@ -24674,7 +24720,7 @@
               <a:buNone/>
             </a:pPr>
             <a:r>
-              <a:rPr lang="en-US" sz="1600" b="1" dirty="0">
+              <a:rPr lang="en-US" sz="2000" b="1" dirty="0">
                 <a:solidFill>
                   <a:schemeClr val="accent1"/>
                 </a:solidFill>
@@ -24684,20 +24730,20 @@
               </a:rPr>
               <a:t>TP. HUẾ</a:t>
             </a:r>
-            <a:endParaRPr lang="en-US" sz="1600" dirty="0"/>
-          </a:p>
-        </p:txBody>
-      </p:sp>
-      <p:sp>
-        <p:nvSpPr>
-          <p:cNvPr id="24" name="Text 21"/>
-          <p:cNvSpPr txBox="1"/>
-          <p:nvPr/>
-        </p:nvSpPr>
-        <p:spPr>
-          <a:xfrm>
-            <a:off x="5178552" y="6492240"/>
-            <a:ext cx="1697736" cy="457200"/>
+            <a:endParaRPr lang="en-US" sz="2000" dirty="0"/>
+          </a:p>
+        </p:txBody>
+      </p:sp>
+      <p:sp>
+        <p:nvSpPr>
+          <p:cNvPr id="26" name="Text 23"/>
+          <p:cNvSpPr txBox="1"/>
+          <p:nvPr/>
+        </p:nvSpPr>
+        <p:spPr>
+          <a:xfrm>
+            <a:off x="5224272" y="7498080"/>
+            <a:ext cx="1606296" cy="594360"/>
           </a:xfrm>
           <a:prstGeom prst="rect">
             <a:avLst/>
@@ -24713,111 +24759,71 @@
               <a:buNone/>
             </a:pPr>
             <a:r>
-              <a:rPr lang="en-US" sz="1050" b="1" dirty="0">
+              <a:rPr lang="en-US" sz="1200" b="1" dirty="0">
                 <a:solidFill>
                   <a:schemeClr val="bg1"/>
                 </a:solidFill>
               </a:rPr>
               <a:t>Trạm xử lý nước UF/RO</a:t>
             </a:r>
+            <a:endParaRPr lang="en-US" sz="1200" dirty="0"/>
+          </a:p>
+        </p:txBody>
+      </p:sp>
+      <p:sp>
+        <p:nvSpPr>
+          <p:cNvPr id="27" name="Text 24"/>
+          <p:cNvSpPr txBox="1"/>
+          <p:nvPr/>
+        </p:nvSpPr>
+        <p:spPr>
+          <a:xfrm>
+            <a:off x="5224272" y="8183880"/>
+            <a:ext cx="1606296" cy="594360"/>
+          </a:xfrm>
+          <a:prstGeom prst="rect">
+            <a:avLst/>
+          </a:prstGeom>
+          <a:noFill/>
+          <a:ln/>
+        </p:spPr>
+        <p:txBody>
+          <a:bodyPr wrap="square" lIns="0" tIns="0" rIns="0" bIns="0" rtlCol="0" anchor="t"/>
+          <a:lstStyle/>
+          <a:p>
+            <a:pPr indent="0" marL="0">
+              <a:buNone/>
+            </a:pPr>
+            <a:r>
+              <a:rPr lang="en-US" sz="1050" dirty="0">
+                <a:solidFill>
+                  <a:schemeClr val="accent4"/>
+                </a:solidFill>
+              </a:rPr>
+              <a:t>Bơm, bồn lọc, ống công nghệ</a:t>
+            </a:r>
             <a:endParaRPr lang="en-US" sz="1050" dirty="0"/>
           </a:p>
         </p:txBody>
       </p:sp>
       <p:sp>
         <p:nvSpPr>
-          <p:cNvPr id="25" name="Text 22"/>
-          <p:cNvSpPr txBox="1"/>
-          <p:nvPr/>
-        </p:nvSpPr>
-        <p:spPr>
-          <a:xfrm>
-            <a:off x="5178552" y="6949440"/>
-            <a:ext cx="1697736" cy="411480"/>
-          </a:xfrm>
-          <a:prstGeom prst="rect">
-            <a:avLst/>
-          </a:prstGeom>
-          <a:noFill/>
-          <a:ln/>
-        </p:spPr>
-        <p:txBody>
-          <a:bodyPr wrap="square" lIns="0" tIns="0" rIns="0" bIns="0" rtlCol="0" anchor="t"/>
-          <a:lstStyle/>
-          <a:p>
-            <a:pPr indent="0" marL="0">
-              <a:buNone/>
-            </a:pPr>
-            <a:r>
-              <a:rPr lang="en-US" sz="900" dirty="0">
-                <a:solidFill>
-                  <a:schemeClr val="accent4"/>
-                </a:solidFill>
-              </a:rPr>
-              <a:t>Bơm, bồn lọc, ống công nghệ</a:t>
-            </a:r>
-            <a:endParaRPr lang="en-US" sz="900" dirty="0"/>
-          </a:p>
-        </p:txBody>
-      </p:sp>
-      <p:sp>
-        <p:nvSpPr>
-          <p:cNvPr id="26" name="Text 23"/>
-          <p:cNvSpPr txBox="1"/>
-          <p:nvPr/>
-        </p:nvSpPr>
-        <p:spPr>
-          <a:xfrm>
-            <a:off x="5178552" y="7388352"/>
-            <a:ext cx="1697736" cy="256032"/>
-          </a:xfrm>
-          <a:prstGeom prst="rect">
-            <a:avLst/>
-          </a:prstGeom>
-          <a:noFill/>
-          <a:ln/>
-        </p:spPr>
-        <p:txBody>
-          <a:bodyPr wrap="square" lIns="0" tIns="0" rIns="0" bIns="0" rtlCol="0" anchor="ctr"/>
-          <a:lstStyle/>
-          <a:p>
-            <a:pPr indent="0" marL="0">
-              <a:buNone/>
-            </a:pPr>
-            <a:r>
-              <a:rPr lang="en-US" sz="900" b="1" dirty="0">
-                <a:solidFill>
-                  <a:schemeClr val="accent6"/>
-                </a:solidFill>
-              </a:rPr>
-              <a:t>09/2026</a:t>
-            </a:r>
-            <a:endParaRPr lang="en-US" sz="900" dirty="0"/>
-          </a:p>
-        </p:txBody>
-      </p:sp>
-      <p:sp>
-        <p:nvSpPr>
-          <p:cNvPr id="27" name="Shape 24"/>
+          <p:cNvPr id="28" name="Shape 25"/>
           <p:cNvSpPr/>
           <p:nvPr/>
         </p:nvSpPr>
         <p:spPr>
           <a:xfrm>
-            <a:off x="502920" y="8229600"/>
-            <a:ext cx="6556248" cy="1508760"/>
-          </a:xfrm>
-          <a:prstGeom prst="roundRect">
-            <a:avLst>
-              <a:gd name="adj" fmla="val 4848"/>
-            </a:avLst>
-          </a:prstGeom>
-          <a:solidFill>
-            <a:schemeClr val="bg2"/>
-          </a:solidFill>
-          <a:ln w="12700">
+            <a:off x="5224272" y="8915400"/>
+            <a:ext cx="1606296" cy="0"/>
+          </a:xfrm>
+          <a:prstGeom prst="line">
+            <a:avLst/>
+          </a:prstGeom>
+          <a:noFill/>
+          <a:ln w="9525">
             <a:solidFill>
-              <a:schemeClr val="bg2"/>
+              <a:schemeClr val="accent3"/>
             </a:solidFill>
             <a:prstDash val="solid"/>
           </a:ln>
@@ -24825,14 +24831,14 @@
       </p:sp>
       <p:sp>
         <p:nvSpPr>
-          <p:cNvPr id="28" name="Text 25"/>
-          <p:cNvSpPr txBox="1"/>
-          <p:nvPr/>
-        </p:nvSpPr>
-        <p:spPr>
-          <a:xfrm>
-            <a:off x="685800" y="8339328"/>
-            <a:ext cx="6190488" cy="228600"/>
+          <p:cNvPr id="29" name="Text 26"/>
+          <p:cNvSpPr txBox="1"/>
+          <p:nvPr/>
+        </p:nvSpPr>
+        <p:spPr>
+          <a:xfrm>
+            <a:off x="5224272" y="9034272"/>
+            <a:ext cx="1606296" cy="292608"/>
           </a:xfrm>
           <a:prstGeom prst="rect">
             <a:avLst/>
@@ -24848,93 +24854,14 @@
               <a:buNone/>
             </a:pPr>
             <a:r>
-              <a:rPr lang="en-US" sz="900" b="1" spc="200" kern="0" dirty="0">
-                <a:solidFill>
-                  <a:schemeClr val="tx2"/>
-                </a:solidFill>
-                <a:latin typeface="Arial" pitchFamily="34" charset="0"/>
-                <a:ea typeface="Arial" pitchFamily="34" charset="-122"/>
-                <a:cs typeface="Arial" pitchFamily="34" charset="-120"/>
-              </a:rPr>
-              <a:t>HỒ SƠ CUNG CẤP KHI CÓ YÊU CẦU</a:t>
-            </a:r>
-            <a:endParaRPr lang="en-US" sz="900" dirty="0"/>
-          </a:p>
-        </p:txBody>
-      </p:sp>
-      <p:sp>
-        <p:nvSpPr>
-          <p:cNvPr id="29" name="Text 26"/>
-          <p:cNvSpPr txBox="1"/>
-          <p:nvPr/>
-        </p:nvSpPr>
-        <p:spPr>
-          <a:xfrm>
-            <a:off x="685800" y="8613648"/>
-            <a:ext cx="6190488" cy="1051560"/>
-          </a:xfrm>
-          <a:prstGeom prst="rect">
-            <a:avLst/>
-          </a:prstGeom>
-          <a:noFill/>
-          <a:ln/>
-        </p:spPr>
-        <p:txBody>
-          <a:bodyPr wrap="square" lIns="0" tIns="0" rIns="0" bIns="0" rtlCol="0" anchor="t"/>
-          <a:lstStyle/>
-          <a:p>
-            <a:pPr marL="152400" indent="-152400">
-              <a:spcAft>
-                <a:spcPts val="400"/>
-              </a:spcAft>
-              <a:buSzPct val="100000"/>
-              <a:buChar char="•"/>
-            </a:pPr>
-            <a:r>
-              <a:rPr lang="en-US" sz="950" dirty="0">
-                <a:solidFill>
-                  <a:schemeClr val="tx1"/>
-                </a:solidFill>
-              </a:rPr>
-              <a:t>Hợp đồng, biên bản nghiệm thu, thanh lý hợp đồng của các công trình</a:t>
-            </a:r>
-            <a:endParaRPr lang="en-US" sz="950" dirty="0"/>
-          </a:p>
-          <a:p>
-            <a:pPr marL="152400" indent="-152400">
-              <a:spcAft>
-                <a:spcPts val="400"/>
-              </a:spcAft>
-              <a:buSzPct val="100000"/>
-              <a:buChar char="•"/>
-            </a:pPr>
-            <a:r>
-              <a:rPr lang="en-US" sz="950" dirty="0">
-                <a:solidFill>
-                  <a:schemeClr val="tx1"/>
-                </a:solidFill>
-              </a:rPr>
-              <a:t>Thông tin chủ đầu tư, tổng thầu để Quý khách tham khảo, xác minh</a:t>
-            </a:r>
-            <a:endParaRPr lang="en-US" sz="950" dirty="0"/>
-          </a:p>
-          <a:p>
-            <a:pPr marL="152400" indent="-152400">
-              <a:spcAft>
-                <a:spcPts val="400"/>
-              </a:spcAft>
-              <a:buSzPct val="100000"/>
-              <a:buChar char="•"/>
-            </a:pPr>
-            <a:r>
-              <a:rPr lang="en-US" sz="950" dirty="0">
-                <a:solidFill>
-                  <a:schemeClr val="tx1"/>
-                </a:solidFill>
-              </a:rPr>
-              <a:t>Giấy chứng nhận đăng ký doanh nghiệp, chứng chỉ an toàn lao động của nhân sự</a:t>
-            </a:r>
-            <a:endParaRPr lang="en-US" sz="950" dirty="0"/>
+              <a:rPr lang="en-US" sz="1100" b="1" dirty="0">
+                <a:solidFill>
+                  <a:schemeClr val="accent6"/>
+                </a:solidFill>
+              </a:rPr>
+              <a:t>09/2026</a:t>
+            </a:r>
+            <a:endParaRPr lang="en-US" sz="1100" dirty="0"/>
           </a:p>
         </p:txBody>
       </p:sp>

</xml_diff>

<commit_message>
Hồ sơ năng lực BLT: thêm ảnh khu nhà cao tầng vào trang 9
Ảnh đặt ở trang mở đầu phần điện nước công trình, gắn nhãn ảnh minh họa;
bỏ ảnh hành lang tối để giữ bố cục 3 ảnh.

Co-Authored-By: Claude Opus 5.5 <noreply@anthropic.com>
Claude-Session: https://claude.ai/code/session_01SkwAuDP5YjDrv41kDvnzWb
</commit_message>
<xml_diff>
--- a/ho-so-nang-luc-BLT/HO_SO_NANG_LUC_BLT.pptx
+++ b/ho-so-nang-luc-BLT/HO_SO_NANG_LUC_BLT.pptx
@@ -132,14 +132,14 @@
   <p:extLst>
     <p:ext uri="{521415D9-36F7-43E2-AB2F-B90AF26B5E84}">
       <p14:sectionLst xmlns:p14="http://schemas.microsoft.com/office/powerpoint/2010/main">
-        <p14:section name="Mở đầu" id="{d2d75668-9e89-8362-847c-447f0a0cab44}">
+        <p14:section name="Mở đầu" id="{182fa455-e893-9667-dd64-4ab823b804d0}">
           <p14:sldIdLst>
             <p14:sldId id="256"/>
             <p14:sldId id="257"/>
             <p14:sldId id="258"/>
           </p14:sldIdLst>
         </p14:section>
-        <p14:section name="01 Tổng quan" id="{fe2ad2fc-a135-3a79-4a73-5d65b2964f31}">
+        <p14:section name="01 Tổng quan" id="{f3a3533f-b04d-722f-7c62-47dc8145aab4}">
           <p14:sldIdLst>
             <p14:sldId id="259"/>
             <p14:sldId id="260"/>
@@ -148,39 +148,39 @@
             <p14:sldId id="263"/>
           </p14:sldIdLst>
         </p14:section>
-        <p14:section name="02 Điện nước công trình" id="{4d191460-7e11-0b26-0a27-f80f0164c9ad}">
+        <p14:section name="02 Điện nước công trình" id="{1d9649b2-0ff4-a928-228d-ed22c2e5617c}">
           <p14:sldIdLst>
             <p14:sldId id="264"/>
             <p14:sldId id="265"/>
             <p14:sldId id="266"/>
           </p14:sldIdLst>
         </p14:section>
-        <p14:section name="03 Hút sương dầu nhà xưởng" id="{f480d4e0-948d-8534-cb8a-c4ec9a9061e3}">
+        <p14:section name="03 Hút sương dầu nhà xưởng" id="{44cc2189-a476-7a85-fe88-ab68c0f7dc79}">
           <p14:sldIdLst>
             <p14:sldId id="267"/>
             <p14:sldId id="268"/>
             <p14:sldId id="269"/>
           </p14:sldIdLst>
         </p14:section>
-        <p14:section name="04 Bơm &amp; xử lý nước" id="{087c28b5-faf9-6bf3-317a-6aad68f07b4e}">
+        <p14:section name="04 Bơm &amp; xử lý nước" id="{2649f439-536d-7ec4-1543-fb3532078bc7}">
           <p14:sldIdLst>
             <p14:sldId id="270"/>
           </p14:sldIdLst>
         </p14:section>
-        <p14:section name="05 Quản trị dự án" id="{a0e624b9-b0e9-6e26-ca07-47cefd2450f1}">
+        <p14:section name="05 Quản trị dự án" id="{5495e30f-f0d5-b81c-5ac4-0311d703ffd5}">
           <p14:sldIdLst>
             <p14:sldId id="271"/>
             <p14:sldId id="272"/>
             <p14:sldId id="273"/>
           </p14:sldIdLst>
         </p14:section>
-        <p14:section name="06 Nguồn lực" id="{59ba8e18-645e-b90c-d913-2adb7df5b24e}">
+        <p14:section name="06 Nguồn lực" id="{69f901ee-d9fa-55bb-9321-fd85117e12a0}">
           <p14:sldIdLst>
             <p14:sldId id="274"/>
             <p14:sldId id="275"/>
           </p14:sldIdLst>
         </p14:section>
-        <p14:section name="07 Công trình tiêu biểu" id="{50837fe0-90c7-16b4-dd0d-2072709c20ae}">
+        <p14:section name="07 Công trình tiêu biểu" id="{7a1e0bba-9bcc-4c30-8c80-e5beaabc62f3}">
           <p14:sldIdLst>
             <p14:sldId id="276"/>
             <p14:sldId id="277"/>
@@ -188,7 +188,7 @@
             <p14:sldId id="279"/>
           </p14:sldIdLst>
         </p14:section>
-        <p14:section name="08 Cam kết &amp; liên hệ" id="{78527d66-43e1-8beb-1b62-108563cb1944}">
+        <p14:section name="08 Cam kết &amp; liên hệ" id="{08ee5891-be5a-f9b7-774f-d588d144d4a0}">
           <p14:sldIdLst>
             <p14:sldId id="280"/>
             <p14:sldId id="281"/>
@@ -34887,7 +34887,7 @@
       </p:pic>
       <p:pic>
         <p:nvPicPr>
-          <p:cNvPr id="3" name="photo render_nha.jpg" descr="Ảnh hiện trường BLT">    </p:cNvPr>
+          <p:cNvPr id="3" name="photo caotang.jpg" descr="Ảnh hiện trường BLT">    </p:cNvPr>
           <p:cNvPicPr>
             <a:picLocks noChangeAspect="1"/>
           </p:cNvPicPr>
@@ -34911,7 +34911,7 @@
       </p:pic>
       <p:pic>
         <p:nvPicPr>
-          <p:cNvPr id="4" name="photo img08.jpg" descr="Ảnh hiện trường BLT">    </p:cNvPr>
+          <p:cNvPr id="4" name="photo render_nha.jpg" descr="Ảnh hiện trường BLT">    </p:cNvPr>
           <p:cNvPicPr>
             <a:picLocks noChangeAspect="1"/>
           </p:cNvPicPr>
@@ -34942,7 +34942,7 @@
         <p:spPr>
           <a:xfrm>
             <a:off x="4370832" y="2926080"/>
-            <a:ext cx="1600200" cy="274320"/>
+            <a:ext cx="1234440" cy="274320"/>
           </a:xfrm>
           <a:prstGeom prst="roundRect">
             <a:avLst>
@@ -34973,8 +34973,75 @@
         <p:spPr>
           <a:xfrm>
             <a:off x="4370832" y="2926080"/>
+            <a:ext cx="1234440" cy="274320"/>
+          </a:xfrm>
+          <a:prstGeom prst="rect">
+            <a:avLst/>
+          </a:prstGeom>
+          <a:noFill/>
+          <a:ln/>
+        </p:spPr>
+        <p:txBody>
+          <a:bodyPr wrap="square" lIns="0" tIns="0" rIns="0" bIns="0" rtlCol="0" anchor="ctr"/>
+          <a:lstStyle/>
+          <a:p>
+            <a:pPr algn="ctr" indent="0" marL="0">
+              <a:buNone/>
+            </a:pPr>
+            <a:r>
+              <a:rPr lang="en-US" sz="750" b="1" spc="100" kern="0" dirty="0">
+                <a:solidFill>
+                  <a:schemeClr val="bg1"/>
+                </a:solidFill>
+              </a:rPr>
+              <a:t>ẢNH MINH HỌA</a:t>
+            </a:r>
+            <a:endParaRPr lang="en-US" sz="750" dirty="0"/>
+          </a:p>
+        </p:txBody>
+      </p:sp>
+      <p:sp>
+        <p:nvSpPr>
+          <p:cNvPr id="7" name="Shape 2"/>
+          <p:cNvSpPr/>
+          <p:nvPr/>
+        </p:nvSpPr>
+        <p:spPr>
+          <a:xfrm>
+            <a:off x="4370832" y="6345936"/>
             <a:ext cx="1600200" cy="274320"/>
           </a:xfrm>
+          <a:prstGeom prst="roundRect">
+            <a:avLst>
+              <a:gd name="adj" fmla="val 16667"/>
+            </a:avLst>
+          </a:prstGeom>
+          <a:solidFill>
+            <a:schemeClr val="tx2">
+              <a:alpha val="85000"/>
+            </a:schemeClr>
+          </a:solidFill>
+          <a:ln w="12700">
+            <a:solidFill>
+              <a:schemeClr val="tx2">
+                <a:alpha val="0"/>
+              </a:schemeClr>
+            </a:solidFill>
+            <a:prstDash val="solid"/>
+          </a:ln>
+        </p:spPr>
+      </p:sp>
+      <p:sp>
+        <p:nvSpPr>
+          <p:cNvPr id="8" name="Text 3"/>
+          <p:cNvSpPr txBox="1"/>
+          <p:nvPr/>
+        </p:nvSpPr>
+        <p:spPr>
+          <a:xfrm>
+            <a:off x="4370832" y="6345936"/>
+            <a:ext cx="1600200" cy="274320"/>
+          </a:xfrm>
           <a:prstGeom prst="rect">
             <a:avLst/>
           </a:prstGeom>
@@ -35002,7 +35069,7 @@
       </p:sp>
       <p:sp>
         <p:nvSpPr>
-          <p:cNvPr id="7" name="Text 2"/>
+          <p:cNvPr id="9" name="Text 4"/>
           <p:cNvSpPr txBox="1"/>
           <p:nvPr/>
         </p:nvSpPr>
@@ -35038,7 +35105,7 @@
       </p:sp>
       <p:sp>
         <p:nvSpPr>
-          <p:cNvPr id="8" name="Text 3"/>
+          <p:cNvPr id="10" name="Text 5"/>
           <p:cNvSpPr txBox="1"/>
           <p:nvPr/>
         </p:nvSpPr>
@@ -35094,7 +35161,7 @@
       </p:sp>
       <p:sp>
         <p:nvSpPr>
-          <p:cNvPr id="9" name="Text 4"/>
+          <p:cNvPr id="11" name="Text 6"/>
           <p:cNvSpPr txBox="1"/>
           <p:nvPr/>
         </p:nvSpPr>

</xml_diff>

<commit_message>
Hồ sơ năng lực BLT: bỏ nhãn ảnh minh họa trên ảnh nhà cao tầng (trang 9)
Co-Authored-By: Claude Opus 5.5 <noreply@anthropic.com>
Claude-Session: https://claude.ai/code/session_01SkwAuDP5YjDrv41kDvnzWb
</commit_message>
<xml_diff>
--- a/ho-so-nang-luc-BLT/HO_SO_NANG_LUC_BLT.pptx
+++ b/ho-so-nang-luc-BLT/HO_SO_NANG_LUC_BLT.pptx
@@ -132,14 +132,14 @@
   <p:extLst>
     <p:ext uri="{521415D9-36F7-43E2-AB2F-B90AF26B5E84}">
       <p14:sectionLst xmlns:p14="http://schemas.microsoft.com/office/powerpoint/2010/main">
-        <p14:section name="Mở đầu" id="{182fa455-e893-9667-dd64-4ab823b804d0}">
+        <p14:section name="Mở đầu" id="{f82367c7-e37b-13b4-9831-0d0c3137cc05}">
           <p14:sldIdLst>
             <p14:sldId id="256"/>
             <p14:sldId id="257"/>
             <p14:sldId id="258"/>
           </p14:sldIdLst>
         </p14:section>
-        <p14:section name="01 Tổng quan" id="{f3a3533f-b04d-722f-7c62-47dc8145aab4}">
+        <p14:section name="01 Tổng quan" id="{71d548a8-3210-6f90-e3aa-0985269bde41}">
           <p14:sldIdLst>
             <p14:sldId id="259"/>
             <p14:sldId id="260"/>
@@ -148,39 +148,39 @@
             <p14:sldId id="263"/>
           </p14:sldIdLst>
         </p14:section>
-        <p14:section name="02 Điện nước công trình" id="{1d9649b2-0ff4-a928-228d-ed22c2e5617c}">
+        <p14:section name="02 Điện nước công trình" id="{9911fe74-6450-1b72-485e-f868bcf873da}">
           <p14:sldIdLst>
             <p14:sldId id="264"/>
             <p14:sldId id="265"/>
             <p14:sldId id="266"/>
           </p14:sldIdLst>
         </p14:section>
-        <p14:section name="03 Hút sương dầu nhà xưởng" id="{44cc2189-a476-7a85-fe88-ab68c0f7dc79}">
+        <p14:section name="03 Hút sương dầu nhà xưởng" id="{340ccb19-beee-fb55-0791-498b7b224688}">
           <p14:sldIdLst>
             <p14:sldId id="267"/>
             <p14:sldId id="268"/>
             <p14:sldId id="269"/>
           </p14:sldIdLst>
         </p14:section>
-        <p14:section name="04 Bơm &amp; xử lý nước" id="{2649f439-536d-7ec4-1543-fb3532078bc7}">
+        <p14:section name="04 Bơm &amp; xử lý nước" id="{d120f84e-0813-8819-65f9-92e5cab694e4}">
           <p14:sldIdLst>
             <p14:sldId id="270"/>
           </p14:sldIdLst>
         </p14:section>
-        <p14:section name="05 Quản trị dự án" id="{5495e30f-f0d5-b81c-5ac4-0311d703ffd5}">
+        <p14:section name="05 Quản trị dự án" id="{ebb497a1-8436-e4c7-70ec-f7622bc3cabf}">
           <p14:sldIdLst>
             <p14:sldId id="271"/>
             <p14:sldId id="272"/>
             <p14:sldId id="273"/>
           </p14:sldIdLst>
         </p14:section>
-        <p14:section name="06 Nguồn lực" id="{69f901ee-d9fa-55bb-9321-fd85117e12a0}">
+        <p14:section name="06 Nguồn lực" id="{03d3f5c6-4d43-3430-21ea-fab15475e993}">
           <p14:sldIdLst>
             <p14:sldId id="274"/>
             <p14:sldId id="275"/>
           </p14:sldIdLst>
         </p14:section>
-        <p14:section name="07 Công trình tiêu biểu" id="{7a1e0bba-9bcc-4c30-8c80-e5beaabc62f3}">
+        <p14:section name="07 Công trình tiêu biểu" id="{1db55b8b-f7cb-6779-aa02-f52273827b50}">
           <p14:sldIdLst>
             <p14:sldId id="276"/>
             <p14:sldId id="277"/>
@@ -188,7 +188,7 @@
             <p14:sldId id="279"/>
           </p14:sldIdLst>
         </p14:section>
-        <p14:section name="08 Cam kết &amp; liên hệ" id="{08ee5891-be5a-f9b7-774f-d588d144d4a0}">
+        <p14:section name="08 Cam kết &amp; liên hệ" id="{818dea26-c9c2-2d94-64d5-bef0131be5f4}">
           <p14:sldIdLst>
             <p14:sldId id="280"/>
             <p14:sldId id="281"/>
@@ -34941,8 +34941,8 @@
         </p:nvSpPr>
         <p:spPr>
           <a:xfrm>
-            <a:off x="4370832" y="2926080"/>
-            <a:ext cx="1234440" cy="274320"/>
+            <a:off x="4370832" y="6345936"/>
+            <a:ext cx="1600200" cy="274320"/>
           </a:xfrm>
           <a:prstGeom prst="roundRect">
             <a:avLst>
@@ -34972,76 +34972,9 @@
         </p:nvSpPr>
         <p:spPr>
           <a:xfrm>
-            <a:off x="4370832" y="2926080"/>
-            <a:ext cx="1234440" cy="274320"/>
-          </a:xfrm>
-          <a:prstGeom prst="rect">
-            <a:avLst/>
-          </a:prstGeom>
-          <a:noFill/>
-          <a:ln/>
-        </p:spPr>
-        <p:txBody>
-          <a:bodyPr wrap="square" lIns="0" tIns="0" rIns="0" bIns="0" rtlCol="0" anchor="ctr"/>
-          <a:lstStyle/>
-          <a:p>
-            <a:pPr algn="ctr" indent="0" marL="0">
-              <a:buNone/>
-            </a:pPr>
-            <a:r>
-              <a:rPr lang="en-US" sz="750" b="1" spc="100" kern="0" dirty="0">
-                <a:solidFill>
-                  <a:schemeClr val="bg1"/>
-                </a:solidFill>
-              </a:rPr>
-              <a:t>ẢNH MINH HỌA</a:t>
-            </a:r>
-            <a:endParaRPr lang="en-US" sz="750" dirty="0"/>
-          </a:p>
-        </p:txBody>
-      </p:sp>
-      <p:sp>
-        <p:nvSpPr>
-          <p:cNvPr id="7" name="Shape 2"/>
-          <p:cNvSpPr/>
-          <p:nvPr/>
-        </p:nvSpPr>
-        <p:spPr>
-          <a:xfrm>
             <a:off x="4370832" y="6345936"/>
             <a:ext cx="1600200" cy="274320"/>
           </a:xfrm>
-          <a:prstGeom prst="roundRect">
-            <a:avLst>
-              <a:gd name="adj" fmla="val 16667"/>
-            </a:avLst>
-          </a:prstGeom>
-          <a:solidFill>
-            <a:schemeClr val="tx2">
-              <a:alpha val="85000"/>
-            </a:schemeClr>
-          </a:solidFill>
-          <a:ln w="12700">
-            <a:solidFill>
-              <a:schemeClr val="tx2">
-                <a:alpha val="0"/>
-              </a:schemeClr>
-            </a:solidFill>
-            <a:prstDash val="solid"/>
-          </a:ln>
-        </p:spPr>
-      </p:sp>
-      <p:sp>
-        <p:nvSpPr>
-          <p:cNvPr id="8" name="Text 3"/>
-          <p:cNvSpPr txBox="1"/>
-          <p:nvPr/>
-        </p:nvSpPr>
-        <p:spPr>
-          <a:xfrm>
-            <a:off x="4370832" y="6345936"/>
-            <a:ext cx="1600200" cy="274320"/>
-          </a:xfrm>
           <a:prstGeom prst="rect">
             <a:avLst/>
           </a:prstGeom>
@@ -35069,7 +35002,7 @@
       </p:sp>
       <p:sp>
         <p:nvSpPr>
-          <p:cNvPr id="9" name="Text 4"/>
+          <p:cNvPr id="7" name="Text 2"/>
           <p:cNvSpPr txBox="1"/>
           <p:nvPr/>
         </p:nvSpPr>
@@ -35105,7 +35038,7 @@
       </p:sp>
       <p:sp>
         <p:nvSpPr>
-          <p:cNvPr id="10" name="Text 5"/>
+          <p:cNvPr id="8" name="Text 3"/>
           <p:cNvSpPr txBox="1"/>
           <p:nvPr/>
         </p:nvSpPr>
@@ -35161,7 +35094,7 @@
       </p:sp>
       <p:sp>
         <p:nvSpPr>
-          <p:cNvPr id="11" name="Text 6"/>
+          <p:cNvPr id="9" name="Text 4"/>
           <p:cNvSpPr txBox="1"/>
           <p:nvPr/>
         </p:nvSpPr>

</xml_diff>

<commit_message>
Hồ sơ năng lực BLT: ảnh tập thể đội ngũ làm ảnh chính trên bìa
Ảnh tập thể trước khu chung cư phủ ngang phía trên bìa; ba ảnh đội ngũ
tại Huế và Quảng Trị xếp thành hàng bên dưới.

Co-Authored-By: Claude Opus 5.5 <noreply@anthropic.com>
Claude-Session: https://claude.ai/code/session_01SkwAuDP5YjDrv41kDvnzWb
</commit_message>
<xml_diff>
--- a/ho-so-nang-luc-BLT/HO_SO_NANG_LUC_BLT.pptx
+++ b/ho-so-nang-luc-BLT/HO_SO_NANG_LUC_BLT.pptx
@@ -132,14 +132,14 @@
   <p:extLst>
     <p:ext uri="{521415D9-36F7-43E2-AB2F-B90AF26B5E84}">
       <p14:sectionLst xmlns:p14="http://schemas.microsoft.com/office/powerpoint/2010/main">
-        <p14:section name="Mở đầu" id="{f82367c7-e37b-13b4-9831-0d0c3137cc05}">
+        <p14:section name="Mở đầu" id="{a672791f-3e63-18b1-d181-8550a6f4335d}">
           <p14:sldIdLst>
             <p14:sldId id="256"/>
             <p14:sldId id="257"/>
             <p14:sldId id="258"/>
           </p14:sldIdLst>
         </p14:section>
-        <p14:section name="01 Tổng quan" id="{71d548a8-3210-6f90-e3aa-0985269bde41}">
+        <p14:section name="01 Tổng quan" id="{057f3cac-48f6-e923-2ee9-0faa12c5827f}">
           <p14:sldIdLst>
             <p14:sldId id="259"/>
             <p14:sldId id="260"/>
@@ -148,39 +148,39 @@
             <p14:sldId id="263"/>
           </p14:sldIdLst>
         </p14:section>
-        <p14:section name="02 Điện nước công trình" id="{9911fe74-6450-1b72-485e-f868bcf873da}">
+        <p14:section name="02 Điện nước công trình" id="{efe1aa15-d6cf-95f8-3f57-e5ea369a30ad}">
           <p14:sldIdLst>
             <p14:sldId id="264"/>
             <p14:sldId id="265"/>
             <p14:sldId id="266"/>
           </p14:sldIdLst>
         </p14:section>
-        <p14:section name="03 Hút sương dầu nhà xưởng" id="{340ccb19-beee-fb55-0791-498b7b224688}">
+        <p14:section name="03 Hút sương dầu nhà xưởng" id="{3122b7cf-306a-cead-d22c-e0f8095051a8}">
           <p14:sldIdLst>
             <p14:sldId id="267"/>
             <p14:sldId id="268"/>
             <p14:sldId id="269"/>
           </p14:sldIdLst>
         </p14:section>
-        <p14:section name="04 Bơm &amp; xử lý nước" id="{d120f84e-0813-8819-65f9-92e5cab694e4}">
+        <p14:section name="04 Bơm &amp; xử lý nước" id="{6850763c-4c99-be3a-7280-0d5b27fd17b1}">
           <p14:sldIdLst>
             <p14:sldId id="270"/>
           </p14:sldIdLst>
         </p14:section>
-        <p14:section name="05 Quản trị dự án" id="{ebb497a1-8436-e4c7-70ec-f7622bc3cabf}">
+        <p14:section name="05 Quản trị dự án" id="{cfaef61c-6ae1-297d-ad9a-8c96d9b32f93}">
           <p14:sldIdLst>
             <p14:sldId id="271"/>
             <p14:sldId id="272"/>
             <p14:sldId id="273"/>
           </p14:sldIdLst>
         </p14:section>
-        <p14:section name="06 Nguồn lực" id="{03d3f5c6-4d43-3430-21ea-fab15475e993}">
+        <p14:section name="06 Nguồn lực" id="{cdcd1b45-8fec-ec8a-6062-69e75b221c3c}">
           <p14:sldIdLst>
             <p14:sldId id="274"/>
             <p14:sldId id="275"/>
           </p14:sldIdLst>
         </p14:section>
-        <p14:section name="07 Công trình tiêu biểu" id="{1db55b8b-f7cb-6779-aa02-f52273827b50}">
+        <p14:section name="07 Công trình tiêu biểu" id="{acb63a34-a542-5928-3f7a-2f1c72590bf3}">
           <p14:sldIdLst>
             <p14:sldId id="276"/>
             <p14:sldId id="277"/>
@@ -188,7 +188,7 @@
             <p14:sldId id="279"/>
           </p14:sldIdLst>
         </p14:section>
-        <p14:section name="08 Cam kết &amp; liên hệ" id="{818dea26-c9c2-2d94-64d5-bef0131be5f4}">
+        <p14:section name="08 Cam kết &amp; liên hệ" id="{6c4134ad-eaf4-2cf7-75df-38ee680d9319}">
           <p14:sldIdLst>
             <p14:sldId id="280"/>
             <p14:sldId id="281"/>
@@ -3574,7 +3574,7 @@
       </p:grpSpPr>
       <p:pic>
         <p:nvPicPr>
-          <p:cNvPr id="2" name="cover team img56_cov.jpg" descr="Đội ngũ công nhân BLT">    </p:cNvPr>
+          <p:cNvPr id="2" name="cover team team_hero.jpg" descr="Đội ngũ công nhân BLT">    </p:cNvPr>
           <p:cNvPicPr>
             <a:picLocks noChangeAspect="1"/>
           </p:cNvPicPr>
@@ -3589,7 +3589,7 @@
         <p:spPr>
           <a:xfrm>
             <a:off x="0" y="0"/>
-            <a:ext cx="3749040" cy="6583680"/>
+            <a:ext cx="7562088" cy="4206240"/>
           </a:xfrm>
           <a:prstGeom prst="rect">
             <a:avLst/>
@@ -3598,7 +3598,7 @@
       </p:pic>
       <p:pic>
         <p:nvPicPr>
-          <p:cNvPr id="3" name="cover team img45.jpg" descr="Đội ngũ công nhân BLT">    </p:cNvPr>
+          <p:cNvPr id="3" name="cover team img56.jpg" descr="Đội ngũ công nhân BLT">    </p:cNvPr>
           <p:cNvPicPr>
             <a:picLocks noChangeAspect="1"/>
           </p:cNvPicPr>
@@ -3612,8 +3612,8 @@
         </p:blipFill>
         <p:spPr>
           <a:xfrm>
-            <a:off x="3822192" y="0"/>
-            <a:ext cx="3739896" cy="3255264"/>
+            <a:off x="0" y="4279392"/>
+            <a:ext cx="2471928" cy="2304288"/>
           </a:xfrm>
           <a:prstGeom prst="rect">
             <a:avLst/>
@@ -3622,7 +3622,7 @@
       </p:pic>
       <p:pic>
         <p:nvPicPr>
-          <p:cNvPr id="4" name="cover team qt_team.jpg" descr="Đội ngũ công nhân BLT">    </p:cNvPr>
+          <p:cNvPr id="4" name="cover team img45.jpg" descr="Đội ngũ công nhân BLT">    </p:cNvPr>
           <p:cNvPicPr>
             <a:picLocks noChangeAspect="1"/>
           </p:cNvPicPr>
@@ -3636,17 +3636,41 @@
         </p:blipFill>
         <p:spPr>
           <a:xfrm>
-            <a:off x="3822192" y="3328416"/>
-            <a:ext cx="3739896" cy="3255264"/>
+            <a:off x="2545080" y="4279392"/>
+            <a:ext cx="2471928" cy="2304288"/>
           </a:xfrm>
           <a:prstGeom prst="rect">
             <a:avLst/>
           </a:prstGeom>
         </p:spPr>
       </p:pic>
-      <p:sp>
-        <p:nvSpPr>
-          <p:cNvPr id="5" name="Shape 0"/>
+      <p:pic>
+        <p:nvPicPr>
+          <p:cNvPr id="5" name="cover team qt_team.jpg" descr="Đội ngũ công nhân BLT">    </p:cNvPr>
+          <p:cNvPicPr>
+            <a:picLocks noChangeAspect="1"/>
+          </p:cNvPicPr>
+          <p:nvPr/>
+        </p:nvPicPr>
+        <p:blipFill>
+          <a:blip r:embed="rId4"/>
+          <a:stretch>
+            <a:fillRect/>
+          </a:stretch>
+        </p:blipFill>
+        <p:spPr>
+          <a:xfrm>
+            <a:off x="5090160" y="4279392"/>
+            <a:ext cx="2471928" cy="2304288"/>
+          </a:xfrm>
+          <a:prstGeom prst="rect">
+            <a:avLst/>
+          </a:prstGeom>
+        </p:spPr>
+      </p:pic>
+      <p:sp>
+        <p:nvSpPr>
+          <p:cNvPr id="6" name="Shape 0"/>
           <p:cNvSpPr/>
           <p:nvPr/>
         </p:nvSpPr>
@@ -3671,14 +3695,14 @@
       </p:sp>
       <p:pic>
         <p:nvPicPr>
-          <p:cNvPr id="6" name="logo" descr="preencoded.png">    </p:cNvPr>
+          <p:cNvPr id="7" name="logo" descr="preencoded.png">    </p:cNvPr>
           <p:cNvPicPr>
             <a:picLocks noChangeAspect="1"/>
           </p:cNvPicPr>
           <p:nvPr/>
         </p:nvPicPr>
         <p:blipFill>
-          <a:blip r:embed="rId4"/>
+          <a:blip r:embed="rId5"/>
           <a:stretch>
             <a:fillRect/>
           </a:stretch>
@@ -3695,7 +3719,7 @@
       </p:pic>
       <p:sp>
         <p:nvSpPr>
-          <p:cNvPr id="7" name="Shape 1"/>
+          <p:cNvPr id="8" name="Shape 1"/>
           <p:cNvSpPr/>
           <p:nvPr/>
         </p:nvSpPr>
@@ -3722,7 +3746,7 @@
       </p:sp>
       <p:sp>
         <p:nvSpPr>
-          <p:cNvPr id="8" name="Text 2"/>
+          <p:cNvPr id="9" name="Text 2"/>
           <p:cNvSpPr txBox="1"/>
           <p:nvPr/>
         </p:nvSpPr>
@@ -3761,7 +3785,7 @@
       </p:sp>
       <p:sp>
         <p:nvSpPr>
-          <p:cNvPr id="9" name="Text 3"/>
+          <p:cNvPr id="10" name="Text 3"/>
           <p:cNvSpPr txBox="1"/>
           <p:nvPr/>
         </p:nvSpPr>
@@ -3800,7 +3824,7 @@
       </p:sp>
       <p:sp>
         <p:nvSpPr>
-          <p:cNvPr id="10" name="Text 4"/>
+          <p:cNvPr id="11" name="Text 4"/>
           <p:cNvSpPr txBox="1"/>
           <p:nvPr/>
         </p:nvSpPr>
@@ -3839,7 +3863,7 @@
       </p:sp>
       <p:sp>
         <p:nvSpPr>
-          <p:cNvPr id="11" name="Text 5"/>
+          <p:cNvPr id="12" name="Text 5"/>
           <p:cNvSpPr txBox="1"/>
           <p:nvPr/>
         </p:nvSpPr>
@@ -3892,7 +3916,7 @@
       </p:sp>
       <p:sp>
         <p:nvSpPr>
-          <p:cNvPr id="12" name="Text 6"/>
+          <p:cNvPr id="13" name="Text 6"/>
           <p:cNvSpPr txBox="1"/>
           <p:nvPr/>
         </p:nvSpPr>
@@ -3942,7 +3966,7 @@
       </p:sp>
       <p:sp>
         <p:nvSpPr>
-          <p:cNvPr id="13" name="Text 7"/>
+          <p:cNvPr id="14" name="Text 7"/>
           <p:cNvSpPr txBox="1"/>
           <p:nvPr/>
         </p:nvSpPr>
@@ -3978,7 +4002,7 @@
       </p:sp>
       <p:sp>
         <p:nvSpPr>
-          <p:cNvPr id="14" name="Text 8"/>
+          <p:cNvPr id="15" name="Text 8"/>
           <p:cNvSpPr txBox="1"/>
           <p:nvPr/>
         </p:nvSpPr>
@@ -4014,7 +4038,7 @@
       </p:sp>
       <p:sp>
         <p:nvSpPr>
-          <p:cNvPr id="15" name="Text 9"/>
+          <p:cNvPr id="16" name="Text 9"/>
           <p:cNvSpPr txBox="1"/>
           <p:nvPr/>
         </p:nvSpPr>

</xml_diff>

<commit_message>
Hồ sơ năng lực BLT: bìa dùng nguyên ảnh tập thể, thấy toàn cảnh tòa nhà và logo
Co-Authored-By: Claude Opus 5.5 <noreply@anthropic.com>
Claude-Session: https://claude.ai/code/session_01SkwAuDP5YjDrv41kDvnzWb
</commit_message>
<xml_diff>
--- a/ho-so-nang-luc-BLT/HO_SO_NANG_LUC_BLT.pptx
+++ b/ho-so-nang-luc-BLT/HO_SO_NANG_LUC_BLT.pptx
@@ -132,14 +132,14 @@
   <p:extLst>
     <p:ext uri="{521415D9-36F7-43E2-AB2F-B90AF26B5E84}">
       <p14:sectionLst xmlns:p14="http://schemas.microsoft.com/office/powerpoint/2010/main">
-        <p14:section name="Mở đầu" id="{a672791f-3e63-18b1-d181-8550a6f4335d}">
+        <p14:section name="Mở đầu" id="{dd61e08b-a3e4-8bd7-d9d4-c40118a07ed7}">
           <p14:sldIdLst>
             <p14:sldId id="256"/>
             <p14:sldId id="257"/>
             <p14:sldId id="258"/>
           </p14:sldIdLst>
         </p14:section>
-        <p14:section name="01 Tổng quan" id="{057f3cac-48f6-e923-2ee9-0faa12c5827f}">
+        <p14:section name="01 Tổng quan" id="{3580978b-b44c-f23a-006c-383668f90f20}">
           <p14:sldIdLst>
             <p14:sldId id="259"/>
             <p14:sldId id="260"/>
@@ -148,39 +148,39 @@
             <p14:sldId id="263"/>
           </p14:sldIdLst>
         </p14:section>
-        <p14:section name="02 Điện nước công trình" id="{efe1aa15-d6cf-95f8-3f57-e5ea369a30ad}">
+        <p14:section name="02 Điện nước công trình" id="{5c3ab4fa-2adf-5e56-049a-85a881410975}">
           <p14:sldIdLst>
             <p14:sldId id="264"/>
             <p14:sldId id="265"/>
             <p14:sldId id="266"/>
           </p14:sldIdLst>
         </p14:section>
-        <p14:section name="03 Hút sương dầu nhà xưởng" id="{3122b7cf-306a-cead-d22c-e0f8095051a8}">
+        <p14:section name="03 Hút sương dầu nhà xưởng" id="{d2990a52-2d7f-afc8-a788-585445309780}">
           <p14:sldIdLst>
             <p14:sldId id="267"/>
             <p14:sldId id="268"/>
             <p14:sldId id="269"/>
           </p14:sldIdLst>
         </p14:section>
-        <p14:section name="04 Bơm &amp; xử lý nước" id="{6850763c-4c99-be3a-7280-0d5b27fd17b1}">
+        <p14:section name="04 Bơm &amp; xử lý nước" id="{7f1ccf3e-84fb-be87-afe5-2b16bb180ea0}">
           <p14:sldIdLst>
             <p14:sldId id="270"/>
           </p14:sldIdLst>
         </p14:section>
-        <p14:section name="05 Quản trị dự án" id="{cfaef61c-6ae1-297d-ad9a-8c96d9b32f93}">
+        <p14:section name="05 Quản trị dự án" id="{aab50e06-2728-82ee-9d55-c927d04a0fb1}">
           <p14:sldIdLst>
             <p14:sldId id="271"/>
             <p14:sldId id="272"/>
             <p14:sldId id="273"/>
           </p14:sldIdLst>
         </p14:section>
-        <p14:section name="06 Nguồn lực" id="{cdcd1b45-8fec-ec8a-6062-69e75b221c3c}">
+        <p14:section name="06 Nguồn lực" id="{d5d16c8b-15b5-eb97-e7ee-ecc02bc2307b}">
           <p14:sldIdLst>
             <p14:sldId id="274"/>
             <p14:sldId id="275"/>
           </p14:sldIdLst>
         </p14:section>
-        <p14:section name="07 Công trình tiêu biểu" id="{acb63a34-a542-5928-3f7a-2f1c72590bf3}">
+        <p14:section name="07 Công trình tiêu biểu" id="{c824c9e3-c4bf-a94e-510d-37be04360a7e}">
           <p14:sldIdLst>
             <p14:sldId id="276"/>
             <p14:sldId id="277"/>
@@ -188,7 +188,7 @@
             <p14:sldId id="279"/>
           </p14:sldIdLst>
         </p14:section>
-        <p14:section name="08 Cam kết &amp; liên hệ" id="{6c4134ad-eaf4-2cf7-75df-38ee680d9319}">
+        <p14:section name="08 Cam kết &amp; liên hệ" id="{30284376-5e20-f791-ba1a-6bf5eeebe866}">
           <p14:sldIdLst>
             <p14:sldId id="280"/>
             <p14:sldId id="281"/>
@@ -3589,7 +3589,7 @@
         <p:spPr>
           <a:xfrm>
             <a:off x="0" y="0"/>
-            <a:ext cx="7562088" cy="4206240"/>
+            <a:ext cx="7562088" cy="5041392"/>
           </a:xfrm>
           <a:prstGeom prst="rect">
             <a:avLst/>
@@ -3612,8 +3612,8 @@
         </p:blipFill>
         <p:spPr>
           <a:xfrm>
-            <a:off x="0" y="4279392"/>
-            <a:ext cx="2471928" cy="2304288"/>
+            <a:off x="0" y="5114544"/>
+            <a:ext cx="2471928" cy="1469136"/>
           </a:xfrm>
           <a:prstGeom prst="rect">
             <a:avLst/>
@@ -3636,8 +3636,8 @@
         </p:blipFill>
         <p:spPr>
           <a:xfrm>
-            <a:off x="2545080" y="4279392"/>
-            <a:ext cx="2471928" cy="2304288"/>
+            <a:off x="2545080" y="5114544"/>
+            <a:ext cx="2471928" cy="1469136"/>
           </a:xfrm>
           <a:prstGeom prst="rect">
             <a:avLst/>
@@ -3660,8 +3660,8 @@
         </p:blipFill>
         <p:spPr>
           <a:xfrm>
-            <a:off x="5090160" y="4279392"/>
-            <a:ext cx="2471928" cy="2304288"/>
+            <a:off x="5090160" y="5114544"/>
+            <a:ext cx="2471928" cy="1469136"/>
           </a:xfrm>
           <a:prstGeom prst="rect">
             <a:avLst/>

</xml_diff>

<commit_message>
Hồ sơ năng lực BLT: phóng to logo trên bìa
Co-Authored-By: Claude Opus 5.5 <noreply@anthropic.com>
Claude-Session: https://claude.ai/code/session_01SkwAuDP5YjDrv41kDvnzWb
</commit_message>
<xml_diff>
--- a/ho-so-nang-luc-BLT/HO_SO_NANG_LUC_BLT.pptx
+++ b/ho-so-nang-luc-BLT/HO_SO_NANG_LUC_BLT.pptx
@@ -132,14 +132,14 @@
   <p:extLst>
     <p:ext uri="{521415D9-36F7-43E2-AB2F-B90AF26B5E84}">
       <p14:sectionLst xmlns:p14="http://schemas.microsoft.com/office/powerpoint/2010/main">
-        <p14:section name="Mở đầu" id="{dd61e08b-a3e4-8bd7-d9d4-c40118a07ed7}">
+        <p14:section name="Mở đầu" id="{2a6fcc34-09e9-fbd9-adf6-e0873fc02cf3}">
           <p14:sldIdLst>
             <p14:sldId id="256"/>
             <p14:sldId id="257"/>
             <p14:sldId id="258"/>
           </p14:sldIdLst>
         </p14:section>
-        <p14:section name="01 Tổng quan" id="{3580978b-b44c-f23a-006c-383668f90f20}">
+        <p14:section name="01 Tổng quan" id="{a94057ce-cf9f-82d5-41e1-ae983700efe7}">
           <p14:sldIdLst>
             <p14:sldId id="259"/>
             <p14:sldId id="260"/>
@@ -148,39 +148,39 @@
             <p14:sldId id="263"/>
           </p14:sldIdLst>
         </p14:section>
-        <p14:section name="02 Điện nước công trình" id="{5c3ab4fa-2adf-5e56-049a-85a881410975}">
+        <p14:section name="02 Điện nước công trình" id="{ebb49ce2-94bb-c674-e56d-969abe8e94d3}">
           <p14:sldIdLst>
             <p14:sldId id="264"/>
             <p14:sldId id="265"/>
             <p14:sldId id="266"/>
           </p14:sldIdLst>
         </p14:section>
-        <p14:section name="03 Hút sương dầu nhà xưởng" id="{d2990a52-2d7f-afc8-a788-585445309780}">
+        <p14:section name="03 Hút sương dầu nhà xưởng" id="{5cbf009b-7776-e4dc-05ed-687829378866}">
           <p14:sldIdLst>
             <p14:sldId id="267"/>
             <p14:sldId id="268"/>
             <p14:sldId id="269"/>
           </p14:sldIdLst>
         </p14:section>
-        <p14:section name="04 Bơm &amp; xử lý nước" id="{7f1ccf3e-84fb-be87-afe5-2b16bb180ea0}">
+        <p14:section name="04 Bơm &amp; xử lý nước" id="{7d7c5a59-6da3-b0c4-f327-5835da0aac2d}">
           <p14:sldIdLst>
             <p14:sldId id="270"/>
           </p14:sldIdLst>
         </p14:section>
-        <p14:section name="05 Quản trị dự án" id="{aab50e06-2728-82ee-9d55-c927d04a0fb1}">
+        <p14:section name="05 Quản trị dự án" id="{1837488a-8219-0349-745b-65401d3e21f9}">
           <p14:sldIdLst>
             <p14:sldId id="271"/>
             <p14:sldId id="272"/>
             <p14:sldId id="273"/>
           </p14:sldIdLst>
         </p14:section>
-        <p14:section name="06 Nguồn lực" id="{d5d16c8b-15b5-eb97-e7ee-ecc02bc2307b}">
+        <p14:section name="06 Nguồn lực" id="{4adc0c37-94d1-b061-a281-076cd09e726a}">
           <p14:sldIdLst>
             <p14:sldId id="274"/>
             <p14:sldId id="275"/>
           </p14:sldIdLst>
         </p14:section>
-        <p14:section name="07 Công trình tiêu biểu" id="{c824c9e3-c4bf-a94e-510d-37be04360a7e}">
+        <p14:section name="07 Công trình tiêu biểu" id="{7c0c92b7-ab67-24cd-1097-00a7eae29f6d}">
           <p14:sldIdLst>
             <p14:sldId id="276"/>
             <p14:sldId id="277"/>
@@ -188,7 +188,7 @@
             <p14:sldId id="279"/>
           </p14:sldIdLst>
         </p14:section>
-        <p14:section name="08 Cam kết &amp; liên hệ" id="{30284376-5e20-f791-ba1a-6bf5eeebe866}">
+        <p14:section name="08 Cam kết &amp; liên hệ" id="{5c1a7078-f4cc-f5ec-31de-3dbfcc6c63c2}">
           <p14:sldIdLst>
             <p14:sldId id="280"/>
             <p14:sldId id="281"/>
@@ -3668,9 +3668,33 @@
           </a:prstGeom>
         </p:spPr>
       </p:pic>
-      <p:sp>
-        <p:nvSpPr>
-          <p:cNvPr id="6" name="Shape 0"/>
+      <p:pic>
+        <p:nvPicPr>
+          <p:cNvPr id="6" name="cover logo large" descr="preencoded.png">    </p:cNvPr>
+          <p:cNvPicPr>
+            <a:picLocks noChangeAspect="1"/>
+          </p:cNvPicPr>
+          <p:nvPr/>
+        </p:nvPicPr>
+        <p:blipFill>
+          <a:blip r:embed="rId5"/>
+          <a:stretch>
+            <a:fillRect/>
+          </a:stretch>
+        </p:blipFill>
+        <p:spPr>
+          <a:xfrm>
+            <a:off x="109728" y="109728"/>
+            <a:ext cx="1645920" cy="1645920"/>
+          </a:xfrm>
+          <a:prstGeom prst="rect">
+            <a:avLst/>
+          </a:prstGeom>
+        </p:spPr>
+      </p:pic>
+      <p:sp>
+        <p:nvSpPr>
+          <p:cNvPr id="7" name="Shape 0"/>
           <p:cNvSpPr/>
           <p:nvPr/>
         </p:nvSpPr>
@@ -3695,14 +3719,14 @@
       </p:sp>
       <p:pic>
         <p:nvPicPr>
-          <p:cNvPr id="7" name="logo" descr="preencoded.png">    </p:cNvPr>
+          <p:cNvPr id="8" name="logo" descr="preencoded.png">    </p:cNvPr>
           <p:cNvPicPr>
             <a:picLocks noChangeAspect="1"/>
           </p:cNvPicPr>
           <p:nvPr/>
         </p:nvPicPr>
         <p:blipFill>
-          <a:blip r:embed="rId5"/>
+          <a:blip r:embed="rId6"/>
           <a:stretch>
             <a:fillRect/>
           </a:stretch>
@@ -3719,7 +3743,7 @@
       </p:pic>
       <p:sp>
         <p:nvSpPr>
-          <p:cNvPr id="8" name="Shape 1"/>
+          <p:cNvPr id="9" name="Shape 1"/>
           <p:cNvSpPr/>
           <p:nvPr/>
         </p:nvSpPr>
@@ -3746,7 +3770,7 @@
       </p:sp>
       <p:sp>
         <p:nvSpPr>
-          <p:cNvPr id="9" name="Text 2"/>
+          <p:cNvPr id="10" name="Text 2"/>
           <p:cNvSpPr txBox="1"/>
           <p:nvPr/>
         </p:nvSpPr>
@@ -3785,7 +3809,7 @@
       </p:sp>
       <p:sp>
         <p:nvSpPr>
-          <p:cNvPr id="10" name="Text 3"/>
+          <p:cNvPr id="11" name="Text 3"/>
           <p:cNvSpPr txBox="1"/>
           <p:nvPr/>
         </p:nvSpPr>
@@ -3824,7 +3848,7 @@
       </p:sp>
       <p:sp>
         <p:nvSpPr>
-          <p:cNvPr id="11" name="Text 4"/>
+          <p:cNvPr id="12" name="Text 4"/>
           <p:cNvSpPr txBox="1"/>
           <p:nvPr/>
         </p:nvSpPr>
@@ -3863,7 +3887,7 @@
       </p:sp>
       <p:sp>
         <p:nvSpPr>
-          <p:cNvPr id="12" name="Text 5"/>
+          <p:cNvPr id="13" name="Text 5"/>
           <p:cNvSpPr txBox="1"/>
           <p:nvPr/>
         </p:nvSpPr>
@@ -3916,7 +3940,7 @@
       </p:sp>
       <p:sp>
         <p:nvSpPr>
-          <p:cNvPr id="13" name="Text 6"/>
+          <p:cNvPr id="14" name="Text 6"/>
           <p:cNvSpPr txBox="1"/>
           <p:nvPr/>
         </p:nvSpPr>
@@ -3966,7 +3990,7 @@
       </p:sp>
       <p:sp>
         <p:nvSpPr>
-          <p:cNvPr id="14" name="Text 7"/>
+          <p:cNvPr id="15" name="Text 7"/>
           <p:cNvSpPr txBox="1"/>
           <p:nvPr/>
         </p:nvSpPr>
@@ -4002,7 +4026,7 @@
       </p:sp>
       <p:sp>
         <p:nvSpPr>
-          <p:cNvPr id="15" name="Text 8"/>
+          <p:cNvPr id="16" name="Text 8"/>
           <p:cNvSpPr txBox="1"/>
           <p:nvPr/>
         </p:nvSpPr>
@@ -4038,7 +4062,7 @@
       </p:sp>
       <p:sp>
         <p:nvSpPr>
-          <p:cNvPr id="16" name="Text 9"/>
+          <p:cNvPr id="17" name="Text 9"/>
           <p:cNvSpPr txBox="1"/>
           <p:nvPr/>
         </p:nvSpPr>

</xml_diff>

<commit_message>
Hồ sơ năng lực BLT: cập nhật đội ngũ 100 nhân sự
Đổi số nhân sự trên bìa, thư ngỏ, trang giới thiệu và trang cơ cấu nhân sự.

Co-Authored-By: Claude Opus 5.5 <noreply@anthropic.com>
Claude-Session: https://claude.ai/code/session_01SkwAuDP5YjDrv41kDvnzWb
</commit_message>
<xml_diff>
--- a/ho-so-nang-luc-BLT/HO_SO_NANG_LUC_BLT.pptx
+++ b/ho-so-nang-luc-BLT/HO_SO_NANG_LUC_BLT.pptx
@@ -132,14 +132,14 @@
   <p:extLst>
     <p:ext uri="{521415D9-36F7-43E2-AB2F-B90AF26B5E84}">
       <p14:sectionLst xmlns:p14="http://schemas.microsoft.com/office/powerpoint/2010/main">
-        <p14:section name="Mở đầu" id="{2a6fcc34-09e9-fbd9-adf6-e0873fc02cf3}">
+        <p14:section name="Mở đầu" id="{7979455f-6809-8233-7528-72119a81b597}">
           <p14:sldIdLst>
             <p14:sldId id="256"/>
             <p14:sldId id="257"/>
             <p14:sldId id="258"/>
           </p14:sldIdLst>
         </p14:section>
-        <p14:section name="01 Tổng quan" id="{a94057ce-cf9f-82d5-41e1-ae983700efe7}">
+        <p14:section name="01 Tổng quan" id="{1c74605e-3c48-0aae-e168-016fb6c7c7e1}">
           <p14:sldIdLst>
             <p14:sldId id="259"/>
             <p14:sldId id="260"/>
@@ -148,39 +148,39 @@
             <p14:sldId id="263"/>
           </p14:sldIdLst>
         </p14:section>
-        <p14:section name="02 Điện nước công trình" id="{ebb49ce2-94bb-c674-e56d-969abe8e94d3}">
+        <p14:section name="02 Điện nước công trình" id="{06664472-a156-6941-4e52-98c0d2926ad7}">
           <p14:sldIdLst>
             <p14:sldId id="264"/>
             <p14:sldId id="265"/>
             <p14:sldId id="266"/>
           </p14:sldIdLst>
         </p14:section>
-        <p14:section name="03 Hút sương dầu nhà xưởng" id="{5cbf009b-7776-e4dc-05ed-687829378866}">
+        <p14:section name="03 Hút sương dầu nhà xưởng" id="{64cfdc03-719d-2b4c-34ef-42a54609c386}">
           <p14:sldIdLst>
             <p14:sldId id="267"/>
             <p14:sldId id="268"/>
             <p14:sldId id="269"/>
           </p14:sldIdLst>
         </p14:section>
-        <p14:section name="04 Bơm &amp; xử lý nước" id="{7d7c5a59-6da3-b0c4-f327-5835da0aac2d}">
+        <p14:section name="04 Bơm &amp; xử lý nước" id="{82f2908f-c7cf-c482-7e3f-b292dfbeaf01}">
           <p14:sldIdLst>
             <p14:sldId id="270"/>
           </p14:sldIdLst>
         </p14:section>
-        <p14:section name="05 Quản trị dự án" id="{1837488a-8219-0349-745b-65401d3e21f9}">
+        <p14:section name="05 Quản trị dự án" id="{9062d297-7bb1-b07d-109c-9b15ebeb20c8}">
           <p14:sldIdLst>
             <p14:sldId id="271"/>
             <p14:sldId id="272"/>
             <p14:sldId id="273"/>
           </p14:sldIdLst>
         </p14:section>
-        <p14:section name="06 Nguồn lực" id="{4adc0c37-94d1-b061-a281-076cd09e726a}">
+        <p14:section name="06 Nguồn lực" id="{9dddf2a3-1206-3baa-1ec9-8626d2b59583}">
           <p14:sldIdLst>
             <p14:sldId id="274"/>
             <p14:sldId id="275"/>
           </p14:sldIdLst>
         </p14:section>
-        <p14:section name="07 Công trình tiêu biểu" id="{7c0c92b7-ab67-24cd-1097-00a7eae29f6d}">
+        <p14:section name="07 Công trình tiêu biểu" id="{08eb6024-a16f-f5ed-23c7-9160f1eecf35}">
           <p14:sldIdLst>
             <p14:sldId id="276"/>
             <p14:sldId id="277"/>
@@ -188,7 +188,7 @@
             <p14:sldId id="279"/>
           </p14:sldIdLst>
         </p14:section>
-        <p14:section name="08 Cam kết &amp; liên hệ" id="{5c1a7078-f4cc-f5ec-31de-3dbfcc6c63c2}">
+        <p14:section name="08 Cam kết &amp; liên hệ" id="{73bb37d9-7a04-cb49-fbc7-bd3e7f975c44}">
           <p14:sldIdLst>
             <p14:sldId id="280"/>
             <p14:sldId id="281"/>
@@ -3801,7 +3801,7 @@
                 <a:ea typeface="Arial" pitchFamily="34" charset="-122"/>
                 <a:cs typeface="Arial" pitchFamily="34" charset="-120"/>
               </a:rPr>
-              <a:t>ĐỘI NGŨ 50 NHÂN SỰ</a:t>
+              <a:t>ĐỘI NGŨ 100 NHÂN SỰ</a:t>
             </a:r>
             <a:endParaRPr lang="en-US" sz="1400" dirty="0"/>
           </a:p>
@@ -14358,7 +14358,7 @@
                 <a:ea typeface="Arial" pitchFamily="34" charset="-122"/>
                 <a:cs typeface="Arial" pitchFamily="34" charset="-120"/>
               </a:rPr>
-              <a:t>50</a:t>
+              <a:t>100</a:t>
             </a:r>
             <a:endParaRPr lang="en-US" sz="4800" dirty="0"/>
           </a:p>
@@ -15890,7 +15890,7 @@
                   <a:schemeClr val="tx1"/>
                 </a:solidFill>
               </a:rPr>
-              <a:t>Đội ngũ 50 người gồm cán bộ kỹ thuật, chỉ huy công trường và công nhân lành nghề, huy động linh hoạt theo tiến độ</a:t>
+              <a:t>Đội ngũ 100 người gồm cán bộ kỹ thuật, chỉ huy công trường và công nhân lành nghề, huy động linh hoạt theo tiến độ</a:t>
             </a:r>
             <a:endParaRPr lang="en-US" sz="950" dirty="0"/>
           </a:p>
@@ -29119,7 +29119,7 @@
                   <a:schemeClr val="tx1"/>
                 </a:solidFill>
               </a:rPr>
-              <a:t>BLT là đơn vị thi công chuyên sâu về hệ thống kỹ thuật công trình: điện, cấp thoát nước, đường ống công nghệ, hệ thống hút sương dầu – lọc khí cho nhà xưởng và hệ thống bơm – xử lý nước. Đội ngũ 50 người của chúng tôi đang trực tiếp thi công tại nhiều công trình ở Nghệ An, Ninh Bình và Thành phố Huế, từ công trình nhiều tầng đến nhà xưởng sản xuất đang vận hành.</a:t>
+              <a:t>BLT là đơn vị thi công chuyên sâu về hệ thống kỹ thuật công trình: điện, cấp thoát nước, đường ống công nghệ, hệ thống hút sương dầu – lọc khí cho nhà xưởng và hệ thống bơm – xử lý nước. Đội ngũ 100 người của chúng tôi đang trực tiếp thi công tại nhiều công trình ở Nghệ An, Ninh Bình và Thành phố Huế, từ công trình nhiều tầng đến nhà xưởng sản xuất đang vận hành.</a:t>
             </a:r>
             <a:endParaRPr lang="en-US" sz="1150" dirty="0"/>
           </a:p>
@@ -29880,7 +29880,7 @@
                 <a:ea typeface="Arial" pitchFamily="34" charset="-122"/>
                 <a:cs typeface="Arial" pitchFamily="34" charset="-120"/>
               </a:rPr>
-              <a:t>50</a:t>
+              <a:t>100</a:t>
             </a:r>
             <a:endParaRPr lang="en-US" sz="3000" dirty="0"/>
           </a:p>

</xml_diff>

<commit_message>
Hồ sơ năng lực BLT: thiết kế lại trang Thư ngỏ
Thêm khung trích dẫn của Giám đốc ở đầu trang, rút gọn thân thư, thu nhỏ
ảnh đội ngũ xuống cuối trang và thêm khối ký tên đầy đủ (địa danh, ngày
tháng, chức danh, chỗ ký và đóng dấu).

Co-Authored-By: Claude Opus 5.5 <noreply@anthropic.com>
Claude-Session: https://claude.ai/code/session_01SkwAuDP5YjDrv41kDvnzWb
</commit_message>
<xml_diff>
--- a/ho-so-nang-luc-BLT/HO_SO_NANG_LUC_BLT.pptx
+++ b/ho-so-nang-luc-BLT/HO_SO_NANG_LUC_BLT.pptx
@@ -132,14 +132,14 @@
   <p:extLst>
     <p:ext uri="{521415D9-36F7-43E2-AB2F-B90AF26B5E84}">
       <p14:sectionLst xmlns:p14="http://schemas.microsoft.com/office/powerpoint/2010/main">
-        <p14:section name="Mở đầu" id="{7979455f-6809-8233-7528-72119a81b597}">
+        <p14:section name="Mở đầu" id="{cd02a01f-bf07-a852-2f30-0b54d8c88614}">
           <p14:sldIdLst>
             <p14:sldId id="256"/>
             <p14:sldId id="257"/>
             <p14:sldId id="258"/>
           </p14:sldIdLst>
         </p14:section>
-        <p14:section name="01 Tổng quan" id="{1c74605e-3c48-0aae-e168-016fb6c7c7e1}">
+        <p14:section name="01 Tổng quan" id="{a1f89e92-6b47-e5bb-da0b-ec4a60e2a01a}">
           <p14:sldIdLst>
             <p14:sldId id="259"/>
             <p14:sldId id="260"/>
@@ -148,39 +148,39 @@
             <p14:sldId id="263"/>
           </p14:sldIdLst>
         </p14:section>
-        <p14:section name="02 Điện nước công trình" id="{06664472-a156-6941-4e52-98c0d2926ad7}">
+        <p14:section name="02 Điện nước công trình" id="{b42a08a1-5499-d2fd-63ad-f536bb1d8645}">
           <p14:sldIdLst>
             <p14:sldId id="264"/>
             <p14:sldId id="265"/>
             <p14:sldId id="266"/>
           </p14:sldIdLst>
         </p14:section>
-        <p14:section name="03 Hút sương dầu nhà xưởng" id="{64cfdc03-719d-2b4c-34ef-42a54609c386}">
+        <p14:section name="03 Hút sương dầu nhà xưởng" id="{1c52ce9e-6f16-1773-b795-ddd67dcc051b}">
           <p14:sldIdLst>
             <p14:sldId id="267"/>
             <p14:sldId id="268"/>
             <p14:sldId id="269"/>
           </p14:sldIdLst>
         </p14:section>
-        <p14:section name="04 Bơm &amp; xử lý nước" id="{82f2908f-c7cf-c482-7e3f-b292dfbeaf01}">
+        <p14:section name="04 Bơm &amp; xử lý nước" id="{620b43d2-c93a-6db5-6c7e-2ad85e2108fd}">
           <p14:sldIdLst>
             <p14:sldId id="270"/>
           </p14:sldIdLst>
         </p14:section>
-        <p14:section name="05 Quản trị dự án" id="{9062d297-7bb1-b07d-109c-9b15ebeb20c8}">
+        <p14:section name="05 Quản trị dự án" id="{6e02fdd8-c2e1-2504-8028-12de403e24de}">
           <p14:sldIdLst>
             <p14:sldId id="271"/>
             <p14:sldId id="272"/>
             <p14:sldId id="273"/>
           </p14:sldIdLst>
         </p14:section>
-        <p14:section name="06 Nguồn lực" id="{9dddf2a3-1206-3baa-1ec9-8626d2b59583}">
+        <p14:section name="06 Nguồn lực" id="{dab69636-f6d3-0be9-ad96-3d6f4b17e0bd}">
           <p14:sldIdLst>
             <p14:sldId id="274"/>
             <p14:sldId id="275"/>
           </p14:sldIdLst>
         </p14:section>
-        <p14:section name="07 Công trình tiêu biểu" id="{08eb6024-a16f-f5ed-23c7-9160f1eecf35}">
+        <p14:section name="07 Công trình tiêu biểu" id="{4ea2d90b-2650-e631-dafd-1877b6656964}">
           <p14:sldIdLst>
             <p14:sldId id="276"/>
             <p14:sldId id="277"/>
@@ -188,7 +188,7 @@
             <p14:sldId id="279"/>
           </p14:sldIdLst>
         </p14:section>
-        <p14:section name="08 Cam kết &amp; liên hệ" id="{73bb37d9-7a04-cb49-fbc7-bd3e7f975c44}">
+        <p14:section name="08 Cam kết &amp; liên hệ" id="{8e016acf-ed49-7c10-040d-7675272d6ef0}">
           <p14:sldIdLst>
             <p14:sldId id="280"/>
             <p14:sldId id="281"/>
@@ -28981,9 +28981,295 @@
           </a:p>
         </p:txBody>
       </p:sp>
+      <p:sp>
+        <p:nvSpPr>
+          <p:cNvPr id="4" name="Shape 2"/>
+          <p:cNvSpPr/>
+          <p:nvPr/>
+        </p:nvSpPr>
+        <p:spPr>
+          <a:xfrm>
+            <a:off x="502920" y="1463040"/>
+            <a:ext cx="6556248" cy="1600200"/>
+          </a:xfrm>
+          <a:prstGeom prst="roundRect">
+            <a:avLst>
+              <a:gd name="adj" fmla="val 4571"/>
+            </a:avLst>
+          </a:prstGeom>
+          <a:solidFill>
+            <a:schemeClr val="tx2"/>
+          </a:solidFill>
+          <a:ln w="12700">
+            <a:solidFill>
+              <a:schemeClr val="tx2"/>
+            </a:solidFill>
+            <a:prstDash val="solid"/>
+          </a:ln>
+        </p:spPr>
+      </p:sp>
+      <p:sp>
+        <p:nvSpPr>
+          <p:cNvPr id="5" name="Text 3"/>
+          <p:cNvSpPr txBox="1"/>
+          <p:nvPr/>
+        </p:nvSpPr>
+        <p:spPr>
+          <a:xfrm>
+            <a:off x="731520" y="1417320"/>
+            <a:ext cx="731520" cy="914400"/>
+          </a:xfrm>
+          <a:prstGeom prst="rect">
+            <a:avLst/>
+          </a:prstGeom>
+          <a:noFill/>
+          <a:ln/>
+        </p:spPr>
+        <p:txBody>
+          <a:bodyPr wrap="square" lIns="0" tIns="0" rIns="0" bIns="0" rtlCol="0" anchor="t"/>
+          <a:lstStyle/>
+          <a:p>
+            <a:pPr indent="0" marL="0">
+              <a:buNone/>
+            </a:pPr>
+            <a:r>
+              <a:rPr lang="en-US" sz="7200" b="1" dirty="0">
+                <a:solidFill>
+                  <a:schemeClr val="accent1"/>
+                </a:solidFill>
+                <a:latin typeface="Arial" pitchFamily="34" charset="0"/>
+                <a:ea typeface="Arial" pitchFamily="34" charset="-122"/>
+                <a:cs typeface="Arial" pitchFamily="34" charset="-120"/>
+              </a:rPr>
+              <a:t>“</a:t>
+            </a:r>
+            <a:endParaRPr lang="en-US" sz="7200" dirty="0"/>
+          </a:p>
+        </p:txBody>
+      </p:sp>
+      <p:sp>
+        <p:nvSpPr>
+          <p:cNvPr id="6" name="Text 4"/>
+          <p:cNvSpPr txBox="1"/>
+          <p:nvPr/>
+        </p:nvSpPr>
+        <p:spPr>
+          <a:xfrm>
+            <a:off x="1463040" y="1645920"/>
+            <a:ext cx="5321808" cy="914400"/>
+          </a:xfrm>
+          <a:prstGeom prst="rect">
+            <a:avLst/>
+          </a:prstGeom>
+          <a:noFill/>
+          <a:ln/>
+        </p:spPr>
+        <p:txBody>
+          <a:bodyPr wrap="square" lIns="0" tIns="0" rIns="0" bIns="0" rtlCol="0" anchor="ctr"/>
+          <a:lstStyle/>
+          <a:p>
+            <a:pPr indent="0" marL="0">
+              <a:lnSpc>
+                <a:spcPct val="110000"/>
+              </a:lnSpc>
+              <a:buNone/>
+            </a:pPr>
+            <a:r>
+              <a:rPr lang="en-US" sz="1500" b="1" dirty="0">
+                <a:solidFill>
+                  <a:schemeClr val="bg1"/>
+                </a:solidFill>
+                <a:latin typeface="Arial" pitchFamily="34" charset="0"/>
+                <a:ea typeface="Arial" pitchFamily="34" charset="-122"/>
+                <a:cs typeface="Arial" pitchFamily="34" charset="-120"/>
+              </a:rPr>
+              <a:t>Hạng mục điện nước nằm khuất sau trần và trong tường, nhưng quyết định sự an toàn và vận hành lâu dài của mỗi công trình.</a:t>
+            </a:r>
+            <a:endParaRPr lang="en-US" sz="1500" dirty="0"/>
+          </a:p>
+        </p:txBody>
+      </p:sp>
+      <p:sp>
+        <p:nvSpPr>
+          <p:cNvPr id="7" name="Text 5"/>
+          <p:cNvSpPr txBox="1"/>
+          <p:nvPr/>
+        </p:nvSpPr>
+        <p:spPr>
+          <a:xfrm>
+            <a:off x="1463040" y="2606040"/>
+            <a:ext cx="5321808" cy="274320"/>
+          </a:xfrm>
+          <a:prstGeom prst="rect">
+            <a:avLst/>
+          </a:prstGeom>
+          <a:noFill/>
+          <a:ln/>
+        </p:spPr>
+        <p:txBody>
+          <a:bodyPr wrap="square" lIns="0" tIns="0" rIns="0" bIns="0" rtlCol="0" anchor="ctr"/>
+          <a:lstStyle/>
+          <a:p>
+            <a:pPr indent="0" marL="0">
+              <a:buNone/>
+            </a:pPr>
+            <a:r>
+              <a:rPr lang="en-US" sz="950" b="1" spc="150" kern="0" dirty="0">
+                <a:solidFill>
+                  <a:schemeClr val="accent1"/>
+                </a:solidFill>
+              </a:rPr>
+              <a:t>— HỒ VĂN BÌNH, GIÁM ĐỐC</a:t>
+            </a:r>
+            <a:endParaRPr lang="en-US" sz="950" dirty="0"/>
+          </a:p>
+        </p:txBody>
+      </p:sp>
+      <p:sp>
+        <p:nvSpPr>
+          <p:cNvPr id="8" name="Text 6"/>
+          <p:cNvSpPr txBox="1"/>
+          <p:nvPr/>
+        </p:nvSpPr>
+        <p:spPr>
+          <a:xfrm>
+            <a:off x="502920" y="3383280"/>
+            <a:ext cx="6556248" cy="3931920"/>
+          </a:xfrm>
+          <a:prstGeom prst="rect">
+            <a:avLst/>
+          </a:prstGeom>
+          <a:noFill/>
+          <a:ln/>
+        </p:spPr>
+        <p:txBody>
+          <a:bodyPr wrap="square" lIns="0" tIns="0" rIns="0" bIns="0" rtlCol="0" anchor="t"/>
+          <a:lstStyle/>
+          <a:p>
+            <a:pPr indent="0" marL="0">
+              <a:lnSpc>
+                <a:spcPct val="120000"/>
+              </a:lnSpc>
+              <a:spcAft>
+                <a:spcPts val="900"/>
+              </a:spcAft>
+              <a:buNone/>
+            </a:pPr>
+            <a:r>
+              <a:rPr lang="en-US" sz="1150" b="1" dirty="0">
+                <a:solidFill>
+                  <a:schemeClr val="tx2"/>
+                </a:solidFill>
+              </a:rPr>
+              <a:t>Kính gửi Quý Khách hàng và Quý Đối tác,</a:t>
+            </a:r>
+            <a:endParaRPr lang="en-US" sz="1150" dirty="0"/>
+          </a:p>
+          <a:p>
+            <a:pPr indent="0" marL="0">
+              <a:lnSpc>
+                <a:spcPct val="120000"/>
+              </a:lnSpc>
+              <a:spcAft>
+                <a:spcPts val="900"/>
+              </a:spcAft>
+              <a:buNone/>
+            </a:pPr>
+            <a:r>
+              <a:rPr lang="en-US" sz="1150" dirty="0">
+                <a:solidFill>
+                  <a:schemeClr val="tx1"/>
+                </a:solidFill>
+              </a:rPr>
+              <a:t>Thay mặt CÔNG TY TNHH KỸ THUẬT CÔNG TRÌNH BLT, tôi trân trọng cảm ơn Quý vị đã quan tâm tìm hiểu năng lực của chúng tôi.</a:t>
+            </a:r>
+            <a:endParaRPr lang="en-US" sz="1150" dirty="0"/>
+          </a:p>
+          <a:p>
+            <a:pPr indent="0" marL="0">
+              <a:lnSpc>
+                <a:spcPct val="120000"/>
+              </a:lnSpc>
+              <a:spcAft>
+                <a:spcPts val="900"/>
+              </a:spcAft>
+              <a:buNone/>
+            </a:pPr>
+            <a:r>
+              <a:rPr lang="en-US" sz="1150" dirty="0">
+                <a:solidFill>
+                  <a:schemeClr val="tx1"/>
+                </a:solidFill>
+              </a:rPr>
+              <a:t>BLT là đơn vị thi công chuyên sâu về hệ thống kỹ thuật công trình: điện, cấp thoát nước, đường ống công nghệ, hút sương dầu – lọc khí nhà xưởng và bơm – xử lý nước. Đội ngũ 100 người của chúng tôi đang trực tiếp thi công tại Nghệ An, Ninh Bình và Thành phố Huế, từ công trình nhiều tầng đến nhà xưởng sản xuất đang vận hành.</a:t>
+            </a:r>
+            <a:endParaRPr lang="en-US" sz="1150" dirty="0"/>
+          </a:p>
+          <a:p>
+            <a:pPr indent="0" marL="0">
+              <a:lnSpc>
+                <a:spcPct val="120000"/>
+              </a:lnSpc>
+              <a:spcAft>
+                <a:spcPts val="900"/>
+              </a:spcAft>
+              <a:buNone/>
+            </a:pPr>
+            <a:r>
+              <a:rPr lang="en-US" sz="1150" dirty="0">
+                <a:solidFill>
+                  <a:schemeClr val="tx1"/>
+                </a:solidFill>
+              </a:rPr>
+              <a:t>Mỗi công việc tại BLT đều đi theo quy trình: khảo sát, lập phương án, chuẩn bị vật tư, thi công, kiểm tra – thử nghiệm, nghiệm thu và bảo hành. Hình ảnh hiện trường được ghi nhận kèm thời gian và vị trí để minh bạch với khách hàng.</a:t>
+            </a:r>
+            <a:endParaRPr lang="en-US" sz="1150" dirty="0"/>
+          </a:p>
+          <a:p>
+            <a:pPr indent="0" marL="0">
+              <a:lnSpc>
+                <a:spcPct val="120000"/>
+              </a:lnSpc>
+              <a:spcAft>
+                <a:spcPts val="900"/>
+              </a:spcAft>
+              <a:buNone/>
+            </a:pPr>
+            <a:r>
+              <a:rPr lang="en-US" sz="1150" dirty="0">
+                <a:solidFill>
+                  <a:schemeClr val="tx1"/>
+                </a:solidFill>
+              </a:rPr>
+              <a:t>Với phương châm “Giải pháp điện nước – Uy tín &amp; Chất lượng”, BLT mong được đồng hành cùng Quý vị trong các dự án sắp tới.</a:t>
+            </a:r>
+            <a:endParaRPr lang="en-US" sz="1150" dirty="0"/>
+          </a:p>
+          <a:p>
+            <a:pPr indent="0" marL="0">
+              <a:lnSpc>
+                <a:spcPct val="120000"/>
+              </a:lnSpc>
+              <a:spcAft>
+                <a:spcPts val="900"/>
+              </a:spcAft>
+              <a:buNone/>
+            </a:pPr>
+            <a:r>
+              <a:rPr lang="en-US" sz="1150" b="1" dirty="0">
+                <a:solidFill>
+                  <a:schemeClr val="tx2"/>
+                </a:solidFill>
+              </a:rPr>
+              <a:t>Trân trọng!</a:t>
+            </a:r>
+            <a:endParaRPr lang="en-US" sz="1150" dirty="0"/>
+          </a:p>
+        </p:txBody>
+      </p:sp>
       <p:pic>
         <p:nvPicPr>
-          <p:cNvPr id="4" name="photo img79.jpg" descr="Đội thi công BLT tại nhà xưởng gia công CNC – Hưng Nguyên, Nghệ An">    </p:cNvPr>
+          <p:cNvPr id="9" name="photo img79.jpg" descr="Đội thi công BLT tại nhà xưởng gia công CNC – Hưng Nguyên, Nghệ An">    </p:cNvPr>
           <p:cNvPicPr>
             <a:picLocks noChangeAspect="1"/>
           </p:cNvPicPr>
@@ -28997,8 +29283,8 @@
         </p:blipFill>
         <p:spPr>
           <a:xfrm>
-            <a:off x="502920" y="1417320"/>
-            <a:ext cx="6556248" cy="2743200"/>
+            <a:off x="502920" y="7040880"/>
+            <a:ext cx="3566160" cy="2606040"/>
           </a:xfrm>
           <a:prstGeom prst="rect">
             <a:avLst/>
@@ -29007,14 +29293,14 @@
       </p:pic>
       <p:sp>
         <p:nvSpPr>
-          <p:cNvPr id="5" name="Text 2"/>
-          <p:cNvSpPr txBox="1"/>
-          <p:nvPr/>
-        </p:nvSpPr>
-        <p:spPr>
-          <a:xfrm>
-            <a:off x="502920" y="4197096"/>
-            <a:ext cx="6556248" cy="201168"/>
+          <p:cNvPr id="10" name="Text 7"/>
+          <p:cNvSpPr txBox="1"/>
+          <p:nvPr/>
+        </p:nvSpPr>
+        <p:spPr>
+          <a:xfrm>
+            <a:off x="502920" y="9683496"/>
+            <a:ext cx="3566160" cy="201168"/>
           </a:xfrm>
           <a:prstGeom prst="rect">
             <a:avLst/>
@@ -29045,156 +29331,14 @@
       </p:sp>
       <p:sp>
         <p:nvSpPr>
-          <p:cNvPr id="6" name="Text 3"/>
-          <p:cNvSpPr txBox="1"/>
-          <p:nvPr/>
-        </p:nvSpPr>
-        <p:spPr>
-          <a:xfrm>
-            <a:off x="502920" y="4526280"/>
-            <a:ext cx="6556248" cy="4480560"/>
-          </a:xfrm>
-          <a:prstGeom prst="rect">
-            <a:avLst/>
-          </a:prstGeom>
-          <a:noFill/>
-          <a:ln/>
-        </p:spPr>
-        <p:txBody>
-          <a:bodyPr wrap="square" lIns="0" tIns="0" rIns="0" bIns="0" rtlCol="0" anchor="t"/>
-          <a:lstStyle/>
-          <a:p>
-            <a:pPr indent="0" marL="0">
-              <a:lnSpc>
-                <a:spcPct val="115000"/>
-              </a:lnSpc>
-              <a:spcAft>
-                <a:spcPts val="800"/>
-              </a:spcAft>
-              <a:buNone/>
-            </a:pPr>
-            <a:r>
-              <a:rPr lang="en-US" sz="1150" b="1" dirty="0">
-                <a:solidFill>
-                  <a:schemeClr val="tx1"/>
-                </a:solidFill>
-              </a:rPr>
-              <a:t>Kính gửi Quý Khách hàng và Quý Đối tác,</a:t>
-            </a:r>
-            <a:endParaRPr lang="en-US" sz="1150" dirty="0"/>
-          </a:p>
-          <a:p>
-            <a:pPr indent="0" marL="0">
-              <a:lnSpc>
-                <a:spcPct val="115000"/>
-              </a:lnSpc>
-              <a:spcAft>
-                <a:spcPts val="800"/>
-              </a:spcAft>
-              <a:buNone/>
-            </a:pPr>
-            <a:r>
-              <a:rPr lang="en-US" sz="1150" dirty="0">
-                <a:solidFill>
-                  <a:schemeClr val="tx1"/>
-                </a:solidFill>
-              </a:rPr>
-              <a:t>Thay mặt CÔNG TY TNHH KỸ THUẬT CÔNG TRÌNH BLT, tôi trân trọng cảm ơn Quý vị đã quan tâm tìm hiểu năng lực của chúng tôi.</a:t>
-            </a:r>
-            <a:endParaRPr lang="en-US" sz="1150" dirty="0"/>
-          </a:p>
-          <a:p>
-            <a:pPr indent="0" marL="0">
-              <a:lnSpc>
-                <a:spcPct val="115000"/>
-              </a:lnSpc>
-              <a:spcAft>
-                <a:spcPts val="800"/>
-              </a:spcAft>
-              <a:buNone/>
-            </a:pPr>
-            <a:r>
-              <a:rPr lang="en-US" sz="1150" dirty="0">
-                <a:solidFill>
-                  <a:schemeClr val="tx1"/>
-                </a:solidFill>
-              </a:rPr>
-              <a:t>BLT là đơn vị thi công chuyên sâu về hệ thống kỹ thuật công trình: điện, cấp thoát nước, đường ống công nghệ, hệ thống hút sương dầu – lọc khí cho nhà xưởng và hệ thống bơm – xử lý nước. Đội ngũ 100 người của chúng tôi đang trực tiếp thi công tại nhiều công trình ở Nghệ An, Ninh Bình và Thành phố Huế, từ công trình nhiều tầng đến nhà xưởng sản xuất đang vận hành.</a:t>
-            </a:r>
-            <a:endParaRPr lang="en-US" sz="1150" dirty="0"/>
-          </a:p>
-          <a:p>
-            <a:pPr indent="0" marL="0">
-              <a:lnSpc>
-                <a:spcPct val="115000"/>
-              </a:lnSpc>
-              <a:spcAft>
-                <a:spcPts val="800"/>
-              </a:spcAft>
-              <a:buNone/>
-            </a:pPr>
-            <a:r>
-              <a:rPr lang="en-US" sz="1150" dirty="0">
-                <a:solidFill>
-                  <a:schemeClr val="tx1"/>
-                </a:solidFill>
-              </a:rPr>
-              <a:t>Chúng tôi hiểu rằng hạng mục kỹ thuật thường nằm khuất sau trần và trong tường, nhưng lại quyết định sự an toàn và khả năng vận hành lâu dài của công trình. Vì vậy, mỗi công việc tại BLT đều được kiểm soát theo quy trình: khảo sát, lập phương án, chuẩn bị vật tư, thi công, kiểm tra – thử nghiệm, nghiệm thu và bảo hành. Mọi hình ảnh hiện trường đều được ghi nhận kèm thời gian và vị trí để minh bạch với khách hàng.</a:t>
-            </a:r>
-            <a:endParaRPr lang="en-US" sz="1150" dirty="0"/>
-          </a:p>
-          <a:p>
-            <a:pPr indent="0" marL="0">
-              <a:lnSpc>
-                <a:spcPct val="115000"/>
-              </a:lnSpc>
-              <a:spcAft>
-                <a:spcPts val="800"/>
-              </a:spcAft>
-              <a:buNone/>
-            </a:pPr>
-            <a:r>
-              <a:rPr lang="en-US" sz="1150" dirty="0">
-                <a:solidFill>
-                  <a:schemeClr val="tx1"/>
-                </a:solidFill>
-              </a:rPr>
-              <a:t>Với phương châm “Giải pháp điện nước – Uy tín &amp; Chất lượng”, BLT mong muốn được đồng hành cùng Quý vị trong các dự án sắp tới.</a:t>
-            </a:r>
-            <a:endParaRPr lang="en-US" sz="1150" dirty="0"/>
-          </a:p>
-          <a:p>
-            <a:pPr indent="0" marL="0">
-              <a:lnSpc>
-                <a:spcPct val="115000"/>
-              </a:lnSpc>
-              <a:spcAft>
-                <a:spcPts val="800"/>
-              </a:spcAft>
-              <a:buNone/>
-            </a:pPr>
-            <a:r>
-              <a:rPr lang="en-US" sz="1150" b="1" dirty="0">
-                <a:solidFill>
-                  <a:schemeClr val="tx1"/>
-                </a:solidFill>
-              </a:rPr>
-              <a:t>Trân trọng!</a:t>
-            </a:r>
-            <a:endParaRPr lang="en-US" sz="1150" dirty="0"/>
-          </a:p>
-        </p:txBody>
-      </p:sp>
-      <p:sp>
-        <p:nvSpPr>
-          <p:cNvPr id="7" name="Text 4"/>
-          <p:cNvSpPr txBox="1"/>
-          <p:nvPr/>
-        </p:nvSpPr>
-        <p:spPr>
-          <a:xfrm>
-            <a:off x="4315968" y="8321040"/>
-            <a:ext cx="2743200" cy="228600"/>
+          <p:cNvPr id="11" name="Text 8"/>
+          <p:cNvSpPr txBox="1"/>
+          <p:nvPr/>
+        </p:nvSpPr>
+        <p:spPr>
+          <a:xfrm>
+            <a:off x="4343400" y="7086600"/>
+            <a:ext cx="2715768" cy="274320"/>
           </a:xfrm>
           <a:prstGeom prst="rect">
             <a:avLst/>
@@ -29210,27 +29354,27 @@
               <a:buNone/>
             </a:pPr>
             <a:r>
-              <a:rPr lang="en-US" sz="900" b="1" spc="200" kern="0" dirty="0">
+              <a:rPr lang="en-US" sz="1050" i="1" dirty="0">
                 <a:solidFill>
                   <a:schemeClr val="accent3"/>
                 </a:solidFill>
               </a:rPr>
-              <a:t>GIÁM ĐỐC</a:t>
-            </a:r>
-            <a:endParaRPr lang="en-US" sz="900" dirty="0"/>
-          </a:p>
-        </p:txBody>
-      </p:sp>
-      <p:sp>
-        <p:nvSpPr>
-          <p:cNvPr id="8" name="Text 5"/>
-          <p:cNvSpPr txBox="1"/>
-          <p:nvPr/>
-        </p:nvSpPr>
-        <p:spPr>
-          <a:xfrm>
-            <a:off x="4315968" y="9006840"/>
-            <a:ext cx="2743200" cy="320040"/>
+              <a:t>Nghệ An, tháng 10 năm 2026</a:t>
+            </a:r>
+            <a:endParaRPr lang="en-US" sz="1050" dirty="0"/>
+          </a:p>
+        </p:txBody>
+      </p:sp>
+      <p:sp>
+        <p:nvSpPr>
+          <p:cNvPr id="12" name="Text 9"/>
+          <p:cNvSpPr txBox="1"/>
+          <p:nvPr/>
+        </p:nvSpPr>
+        <p:spPr>
+          <a:xfrm>
+            <a:off x="4343400" y="7406640"/>
+            <a:ext cx="2715768" cy="274320"/>
           </a:xfrm>
           <a:prstGeom prst="rect">
             <a:avLst/>
@@ -29246,7 +29390,7 @@
               <a:buNone/>
             </a:pPr>
             <a:r>
-              <a:rPr lang="en-US" sz="1400" b="1" dirty="0">
+              <a:rPr lang="en-US" sz="1100" b="1" spc="200" kern="0" dirty="0">
                 <a:solidFill>
                   <a:schemeClr val="tx2"/>
                 </a:solidFill>
@@ -29254,9 +29398,84 @@
                 <a:ea typeface="Arial" pitchFamily="34" charset="-122"/>
                 <a:cs typeface="Arial" pitchFamily="34" charset="-120"/>
               </a:rPr>
+              <a:t>GIÁM ĐỐC</a:t>
+            </a:r>
+            <a:endParaRPr lang="en-US" sz="1100" dirty="0"/>
+          </a:p>
+        </p:txBody>
+      </p:sp>
+      <p:sp>
+        <p:nvSpPr>
+          <p:cNvPr id="13" name="Text 10"/>
+          <p:cNvSpPr txBox="1"/>
+          <p:nvPr/>
+        </p:nvSpPr>
+        <p:spPr>
+          <a:xfrm>
+            <a:off x="4343400" y="7680960"/>
+            <a:ext cx="2715768" cy="228600"/>
+          </a:xfrm>
+          <a:prstGeom prst="rect">
+            <a:avLst/>
+          </a:prstGeom>
+          <a:noFill/>
+          <a:ln/>
+        </p:spPr>
+        <p:txBody>
+          <a:bodyPr wrap="square" lIns="0" tIns="0" rIns="0" bIns="0" rtlCol="0" anchor="ctr"/>
+          <a:lstStyle/>
+          <a:p>
+            <a:pPr algn="ctr" indent="0" marL="0">
+              <a:buNone/>
+            </a:pPr>
+            <a:r>
+              <a:rPr lang="en-US" sz="900" i="1" dirty="0">
+                <a:solidFill>
+                  <a:schemeClr val="accent3"/>
+                </a:solidFill>
+              </a:rPr>
+              <a:t>(Ký tên, đóng dấu)</a:t>
+            </a:r>
+            <a:endParaRPr lang="en-US" sz="900" dirty="0"/>
+          </a:p>
+        </p:txBody>
+      </p:sp>
+      <p:sp>
+        <p:nvSpPr>
+          <p:cNvPr id="14" name="Text 11"/>
+          <p:cNvSpPr txBox="1"/>
+          <p:nvPr/>
+        </p:nvSpPr>
+        <p:spPr>
+          <a:xfrm>
+            <a:off x="4343400" y="9189720"/>
+            <a:ext cx="2715768" cy="365760"/>
+          </a:xfrm>
+          <a:prstGeom prst="rect">
+            <a:avLst/>
+          </a:prstGeom>
+          <a:noFill/>
+          <a:ln/>
+        </p:spPr>
+        <p:txBody>
+          <a:bodyPr wrap="square" lIns="0" tIns="0" rIns="0" bIns="0" rtlCol="0" anchor="ctr"/>
+          <a:lstStyle/>
+          <a:p>
+            <a:pPr algn="ctr" indent="0" marL="0">
+              <a:buNone/>
+            </a:pPr>
+            <a:r>
+              <a:rPr lang="en-US" sz="1600" b="1" dirty="0">
+                <a:solidFill>
+                  <a:schemeClr val="tx2"/>
+                </a:solidFill>
+                <a:latin typeface="Arial" pitchFamily="34" charset="0"/>
+                <a:ea typeface="Arial" pitchFamily="34" charset="-122"/>
+                <a:cs typeface="Arial" pitchFamily="34" charset="-120"/>
+              </a:rPr>
               <a:t>HỒ VĂN BÌNH</a:t>
             </a:r>
-            <a:endParaRPr lang="en-US" sz="1400" dirty="0"/>
+            <a:endParaRPr lang="en-US" sz="1600" dirty="0"/>
           </a:p>
         </p:txBody>
       </p:sp>

</xml_diff>

<commit_message>
Hồ sơ năng lực BLT: câu trích dẫn thư ngỏ mạnh mẽ hơn
Co-Authored-By: Claude Opus 5.5 <noreply@anthropic.com>
Claude-Session: https://claude.ai/code/session_01SkwAuDP5YjDrv41kDvnzWb
</commit_message>
<xml_diff>
--- a/ho-so-nang-luc-BLT/HO_SO_NANG_LUC_BLT.pptx
+++ b/ho-so-nang-luc-BLT/HO_SO_NANG_LUC_BLT.pptx
@@ -132,14 +132,14 @@
   <p:extLst>
     <p:ext uri="{521415D9-36F7-43E2-AB2F-B90AF26B5E84}">
       <p14:sectionLst xmlns:p14="http://schemas.microsoft.com/office/powerpoint/2010/main">
-        <p14:section name="Mở đầu" id="{cd02a01f-bf07-a852-2f30-0b54d8c88614}">
+        <p14:section name="Mở đầu" id="{a8245867-f327-d094-4925-72a31402470b}">
           <p14:sldIdLst>
             <p14:sldId id="256"/>
             <p14:sldId id="257"/>
             <p14:sldId id="258"/>
           </p14:sldIdLst>
         </p14:section>
-        <p14:section name="01 Tổng quan" id="{a1f89e92-6b47-e5bb-da0b-ec4a60e2a01a}">
+        <p14:section name="01 Tổng quan" id="{a723346e-9b2d-de84-affa-8f0fb62f270d}">
           <p14:sldIdLst>
             <p14:sldId id="259"/>
             <p14:sldId id="260"/>
@@ -148,39 +148,39 @@
             <p14:sldId id="263"/>
           </p14:sldIdLst>
         </p14:section>
-        <p14:section name="02 Điện nước công trình" id="{b42a08a1-5499-d2fd-63ad-f536bb1d8645}">
+        <p14:section name="02 Điện nước công trình" id="{542b40e1-1628-373f-7127-2ad5b9b5454f}">
           <p14:sldIdLst>
             <p14:sldId id="264"/>
             <p14:sldId id="265"/>
             <p14:sldId id="266"/>
           </p14:sldIdLst>
         </p14:section>
-        <p14:section name="03 Hút sương dầu nhà xưởng" id="{1c52ce9e-6f16-1773-b795-ddd67dcc051b}">
+        <p14:section name="03 Hút sương dầu nhà xưởng" id="{8df30eb5-65c1-7565-6025-da539dfe8a54}">
           <p14:sldIdLst>
             <p14:sldId id="267"/>
             <p14:sldId id="268"/>
             <p14:sldId id="269"/>
           </p14:sldIdLst>
         </p14:section>
-        <p14:section name="04 Bơm &amp; xử lý nước" id="{620b43d2-c93a-6db5-6c7e-2ad85e2108fd}">
+        <p14:section name="04 Bơm &amp; xử lý nước" id="{53084246-5de0-14ba-b912-138fd5cf9e6f}">
           <p14:sldIdLst>
             <p14:sldId id="270"/>
           </p14:sldIdLst>
         </p14:section>
-        <p14:section name="05 Quản trị dự án" id="{6e02fdd8-c2e1-2504-8028-12de403e24de}">
+        <p14:section name="05 Quản trị dự án" id="{1275f23a-0c58-dbf4-3bdf-9bd840957d66}">
           <p14:sldIdLst>
             <p14:sldId id="271"/>
             <p14:sldId id="272"/>
             <p14:sldId id="273"/>
           </p14:sldIdLst>
         </p14:section>
-        <p14:section name="06 Nguồn lực" id="{dab69636-f6d3-0be9-ad96-3d6f4b17e0bd}">
+        <p14:section name="06 Nguồn lực" id="{3183c4f5-cb69-4078-3686-ffd834faec2b}">
           <p14:sldIdLst>
             <p14:sldId id="274"/>
             <p14:sldId id="275"/>
           </p14:sldIdLst>
         </p14:section>
-        <p14:section name="07 Công trình tiêu biểu" id="{4ea2d90b-2650-e631-dafd-1877b6656964}">
+        <p14:section name="07 Công trình tiêu biểu" id="{d7a2ddc5-3339-b4a3-a539-41ca02422e5e}">
           <p14:sldIdLst>
             <p14:sldId id="276"/>
             <p14:sldId id="277"/>
@@ -188,7 +188,7 @@
             <p14:sldId id="279"/>
           </p14:sldIdLst>
         </p14:section>
-        <p14:section name="08 Cam kết &amp; liên hệ" id="{8e016acf-ed49-7c10-040d-7675272d6ef0}">
+        <p14:section name="08 Cam kết &amp; liên hệ" id="{fa285568-7996-b853-fff9-f1ea3f925ea8}">
           <p14:sldIdLst>
             <p14:sldId id="280"/>
             <p14:sldId id="281"/>
@@ -29075,7 +29075,7 @@
               <a:buNone/>
             </a:pPr>
             <a:r>
-              <a:rPr lang="en-US" sz="1500" b="1" dirty="0">
+              <a:rPr lang="en-US" sz="1700" b="1" dirty="0">
                 <a:solidFill>
                   <a:schemeClr val="bg1"/>
                 </a:solidFill>
@@ -29083,9 +29083,63 @@
                 <a:ea typeface="Arial" pitchFamily="34" charset="-122"/>
                 <a:cs typeface="Arial" pitchFamily="34" charset="-120"/>
               </a:rPr>
-              <a:t>Hạng mục điện nước nằm khuất sau trần và trong tường, nhưng quyết định sự an toàn và vận hành lâu dài của mỗi công trình.</a:t>
-            </a:r>
-            <a:endParaRPr lang="en-US" sz="1500" dirty="0"/>
+              <a:t>Chúng tôi không chỉ lắp đặt điện nước –</a:t>
+            </a:r>
+            <a:endParaRPr lang="en-US" sz="1700" dirty="0"/>
+          </a:p>
+          <a:p>
+            <a:pPr indent="0" marL="0">
+              <a:lnSpc>
+                <a:spcPct val="110000"/>
+              </a:lnSpc>
+              <a:buNone/>
+            </a:pPr>
+            <a:r>
+              <a:rPr lang="en-US" sz="1700" b="1" dirty="0">
+                <a:solidFill>
+                  <a:schemeClr val="bg1"/>
+                </a:solidFill>
+                <a:latin typeface="Arial" pitchFamily="34" charset="0"/>
+                <a:ea typeface="Arial" pitchFamily="34" charset="-122"/>
+                <a:cs typeface="Arial" pitchFamily="34" charset="-120"/>
+              </a:rPr>
+              <a:t>chúng tôi lắp đặt </a:t>
+            </a:r>
+            <a:pPr indent="0" marL="0">
+              <a:lnSpc>
+                <a:spcPct val="110000"/>
+              </a:lnSpc>
+              <a:buNone/>
+            </a:pPr>
+            <a:r>
+              <a:rPr lang="en-US" sz="1700" b="1" dirty="0">
+                <a:solidFill>
+                  <a:schemeClr val="accent1"/>
+                </a:solidFill>
+                <a:latin typeface="Arial" pitchFamily="34" charset="0"/>
+                <a:ea typeface="Arial" pitchFamily="34" charset="-122"/>
+                <a:cs typeface="Arial" pitchFamily="34" charset="-120"/>
+              </a:rPr>
+              <a:t>sự an tâm</a:t>
+            </a:r>
+            <a:pPr indent="0" marL="0">
+              <a:lnSpc>
+                <a:spcPct val="110000"/>
+              </a:lnSpc>
+              <a:buNone/>
+            </a:pPr>
+            <a:r>
+              <a:rPr lang="en-US" sz="1700" b="1" dirty="0">
+                <a:solidFill>
+                  <a:schemeClr val="bg1"/>
+                </a:solidFill>
+                <a:latin typeface="Arial" pitchFamily="34" charset="0"/>
+                <a:ea typeface="Arial" pitchFamily="34" charset="-122"/>
+                <a:cs typeface="Arial" pitchFamily="34" charset="-120"/>
+              </a:rPr>
+              <a:t> cho từng công trình.</a:t>
+            </a:r>
+            <a:endParaRPr lang="en-US" sz="1700" dirty="0"/>
           </a:p>
         </p:txBody>
       </p:sp>

</xml_diff>

<commit_message>
Hồ sơ năng lực BLT: chuyển ảnh đội thi công từ thư ngỏ sang trang liên hệ
Trang 4 để trống chỗ cho ảnh chân dung Giám đốc; trang 26 dùng ảnh làm nền
phía sau logo.

Co-Authored-By: Claude Opus 5.5 <noreply@anthropic.com>
Claude-Session: https://claude.ai/code/session_01SkwAuDP5YjDrv41kDvnzWb
</commit_message>
<xml_diff>
--- a/ho-so-nang-luc-BLT/HO_SO_NANG_LUC_BLT.pptx
+++ b/ho-so-nang-luc-BLT/HO_SO_NANG_LUC_BLT.pptx
@@ -132,14 +132,14 @@
   <p:extLst>
     <p:ext uri="{521415D9-36F7-43E2-AB2F-B90AF26B5E84}">
       <p14:sectionLst xmlns:p14="http://schemas.microsoft.com/office/powerpoint/2010/main">
-        <p14:section name="Mở đầu" id="{a8245867-f327-d094-4925-72a31402470b}">
+        <p14:section name="Mở đầu" id="{35f7de7a-d3aa-5e6d-8abd-e329c8e493a1}">
           <p14:sldIdLst>
             <p14:sldId id="256"/>
             <p14:sldId id="257"/>
             <p14:sldId id="258"/>
           </p14:sldIdLst>
         </p14:section>
-        <p14:section name="01 Tổng quan" id="{a723346e-9b2d-de84-affa-8f0fb62f270d}">
+        <p14:section name="01 Tổng quan" id="{13a775b4-1674-baf5-5b7f-ae24d97a1941}">
           <p14:sldIdLst>
             <p14:sldId id="259"/>
             <p14:sldId id="260"/>
@@ -148,39 +148,39 @@
             <p14:sldId id="263"/>
           </p14:sldIdLst>
         </p14:section>
-        <p14:section name="02 Điện nước công trình" id="{542b40e1-1628-373f-7127-2ad5b9b5454f}">
+        <p14:section name="02 Điện nước công trình" id="{cce7f6e8-fb4b-3740-c336-af423b1c6f82}">
           <p14:sldIdLst>
             <p14:sldId id="264"/>
             <p14:sldId id="265"/>
             <p14:sldId id="266"/>
           </p14:sldIdLst>
         </p14:section>
-        <p14:section name="03 Hút sương dầu nhà xưởng" id="{8df30eb5-65c1-7565-6025-da539dfe8a54}">
+        <p14:section name="03 Hút sương dầu nhà xưởng" id="{5db836f6-58a9-daf7-cde8-76dfe6c80d9f}">
           <p14:sldIdLst>
             <p14:sldId id="267"/>
             <p14:sldId id="268"/>
             <p14:sldId id="269"/>
           </p14:sldIdLst>
         </p14:section>
-        <p14:section name="04 Bơm &amp; xử lý nước" id="{53084246-5de0-14ba-b912-138fd5cf9e6f}">
+        <p14:section name="04 Bơm &amp; xử lý nước" id="{cf4dc152-2715-20fa-fc82-2a60f496fe5e}">
           <p14:sldIdLst>
             <p14:sldId id="270"/>
           </p14:sldIdLst>
         </p14:section>
-        <p14:section name="05 Quản trị dự án" id="{1275f23a-0c58-dbf4-3bdf-9bd840957d66}">
+        <p14:section name="05 Quản trị dự án" id="{d1542d83-5170-6adf-eab6-bb2be8a54644}">
           <p14:sldIdLst>
             <p14:sldId id="271"/>
             <p14:sldId id="272"/>
             <p14:sldId id="273"/>
           </p14:sldIdLst>
         </p14:section>
-        <p14:section name="06 Nguồn lực" id="{3183c4f5-cb69-4078-3686-ffd834faec2b}">
+        <p14:section name="06 Nguồn lực" id="{85cfb580-4c68-26d2-9cc1-e3231d8b5d65}">
           <p14:sldIdLst>
             <p14:sldId id="274"/>
             <p14:sldId id="275"/>
           </p14:sldIdLst>
         </p14:section>
-        <p14:section name="07 Công trình tiêu biểu" id="{d7a2ddc5-3339-b4a3-a539-41ca02422e5e}">
+        <p14:section name="07 Công trình tiêu biểu" id="{7f7b0a70-08df-98c1-1131-92ccdd61571d}">
           <p14:sldIdLst>
             <p14:sldId id="276"/>
             <p14:sldId id="277"/>
@@ -188,7 +188,7 @@
             <p14:sldId id="279"/>
           </p14:sldIdLst>
         </p14:section>
-        <p14:section name="08 Cam kết &amp; liên hệ" id="{fa285568-7996-b853-fff9-f1ea3f925ea8}">
+        <p14:section name="08 Cam kết &amp; liên hệ" id="{51c459eb-398c-fa46-98b9-37c7aad0005e}">
           <p14:sldIdLst>
             <p14:sldId id="280"/>
             <p14:sldId id="281"/>
@@ -26489,7 +26489,7 @@
       </p:grpSpPr>
       <p:pic>
         <p:nvPicPr>
-          <p:cNvPr id="2" name="logo" descr="preencoded.png">    </p:cNvPr>
+          <p:cNvPr id="2" name="photo img79.jpg" descr="Ảnh hiện trường BLT">    </p:cNvPr>
           <p:cNvPicPr>
             <a:picLocks noChangeAspect="1"/>
           </p:cNvPicPr>
@@ -26503,7 +26503,60 @@
         </p:blipFill>
         <p:spPr>
           <a:xfrm>
-            <a:off x="2775204" y="1371600"/>
+            <a:off x="0" y="0"/>
+            <a:ext cx="7562088" cy="4206240"/>
+          </a:xfrm>
+          <a:prstGeom prst="rect">
+            <a:avLst/>
+          </a:prstGeom>
+        </p:spPr>
+      </p:pic>
+      <p:sp>
+        <p:nvSpPr>
+          <p:cNvPr id="3" name="Shape 0"/>
+          <p:cNvSpPr/>
+          <p:nvPr/>
+        </p:nvSpPr>
+        <p:spPr>
+          <a:xfrm>
+            <a:off x="0" y="0"/>
+            <a:ext cx="7562088" cy="4206240"/>
+          </a:xfrm>
+          <a:prstGeom prst="rect">
+            <a:avLst/>
+          </a:prstGeom>
+          <a:solidFill>
+            <a:schemeClr val="tx2">
+              <a:alpha val="60000"/>
+            </a:schemeClr>
+          </a:solidFill>
+          <a:ln w="12700">
+            <a:solidFill>
+              <a:schemeClr val="tx2">
+                <a:alpha val="0"/>
+              </a:schemeClr>
+            </a:solidFill>
+            <a:prstDash val="solid"/>
+          </a:ln>
+        </p:spPr>
+      </p:sp>
+      <p:pic>
+        <p:nvPicPr>
+          <p:cNvPr id="4" name="logo" descr="preencoded.png">    </p:cNvPr>
+          <p:cNvPicPr>
+            <a:picLocks noChangeAspect="1"/>
+          </p:cNvPicPr>
+          <p:nvPr/>
+        </p:nvPicPr>
+        <p:blipFill>
+          <a:blip r:embed="rId2"/>
+          <a:stretch>
+            <a:fillRect/>
+          </a:stretch>
+        </p:blipFill>
+        <p:spPr>
+          <a:xfrm>
+            <a:off x="2775204" y="1097280"/>
             <a:ext cx="2011680" cy="2011680"/>
           </a:xfrm>
           <a:prstGeom prst="rect">
@@ -26513,7 +26566,7 @@
       </p:pic>
       <p:sp>
         <p:nvSpPr>
-          <p:cNvPr id="3" name="Text 0"/>
+          <p:cNvPr id="5" name="Text 1"/>
           <p:cNvSpPr txBox="1"/>
           <p:nvPr/>
         </p:nvSpPr>
@@ -26552,7 +26605,7 @@
       </p:sp>
       <p:sp>
         <p:nvSpPr>
-          <p:cNvPr id="4" name="Text 1"/>
+          <p:cNvPr id="6" name="Text 2"/>
           <p:cNvSpPr txBox="1"/>
           <p:nvPr/>
         </p:nvSpPr>
@@ -26588,7 +26641,7 @@
       </p:sp>
       <p:sp>
         <p:nvSpPr>
-          <p:cNvPr id="5" name="Text 2"/>
+          <p:cNvPr id="7" name="Text 3"/>
           <p:cNvSpPr txBox="1"/>
           <p:nvPr/>
         </p:nvSpPr>
@@ -26624,7 +26677,7 @@
       </p:sp>
       <p:sp>
         <p:nvSpPr>
-          <p:cNvPr id="6" name="Text 3"/>
+          <p:cNvPr id="8" name="Text 4"/>
           <p:cNvSpPr txBox="1"/>
           <p:nvPr/>
         </p:nvSpPr>
@@ -26660,7 +26713,7 @@
       </p:sp>
       <p:sp>
         <p:nvSpPr>
-          <p:cNvPr id="7" name="Text 4"/>
+          <p:cNvPr id="9" name="Text 5"/>
           <p:cNvSpPr txBox="1"/>
           <p:nvPr/>
         </p:nvSpPr>
@@ -26696,7 +26749,7 @@
       </p:sp>
       <p:sp>
         <p:nvSpPr>
-          <p:cNvPr id="8" name="Text 5"/>
+          <p:cNvPr id="10" name="Text 6"/>
           <p:cNvSpPr txBox="1"/>
           <p:nvPr/>
         </p:nvSpPr>
@@ -26732,7 +26785,7 @@
       </p:sp>
       <p:sp>
         <p:nvSpPr>
-          <p:cNvPr id="9" name="Text 6"/>
+          <p:cNvPr id="11" name="Text 7"/>
           <p:cNvSpPr txBox="1"/>
           <p:nvPr/>
         </p:nvSpPr>
@@ -26768,7 +26821,7 @@
       </p:sp>
       <p:sp>
         <p:nvSpPr>
-          <p:cNvPr id="10" name="Text 7"/>
+          <p:cNvPr id="12" name="Text 8"/>
           <p:cNvSpPr txBox="1"/>
           <p:nvPr/>
         </p:nvSpPr>
@@ -26804,7 +26857,7 @@
       </p:sp>
       <p:sp>
         <p:nvSpPr>
-          <p:cNvPr id="11" name="Text 8"/>
+          <p:cNvPr id="13" name="Text 9"/>
           <p:cNvSpPr txBox="1"/>
           <p:nvPr/>
         </p:nvSpPr>
@@ -26840,7 +26893,7 @@
       </p:sp>
       <p:sp>
         <p:nvSpPr>
-          <p:cNvPr id="12" name="Text 9"/>
+          <p:cNvPr id="14" name="Text 10"/>
           <p:cNvSpPr txBox="1"/>
           <p:nvPr/>
         </p:nvSpPr>
@@ -26876,7 +26929,7 @@
       </p:sp>
       <p:sp>
         <p:nvSpPr>
-          <p:cNvPr id="13" name="Text 10"/>
+          <p:cNvPr id="15" name="Text 11"/>
           <p:cNvSpPr txBox="1"/>
           <p:nvPr/>
         </p:nvSpPr>
@@ -26912,7 +26965,7 @@
       </p:sp>
       <p:sp>
         <p:nvSpPr>
-          <p:cNvPr id="14" name="Text 11"/>
+          <p:cNvPr id="16" name="Text 12"/>
           <p:cNvSpPr txBox="1"/>
           <p:nvPr/>
         </p:nvSpPr>
@@ -26948,7 +27001,7 @@
       </p:sp>
       <p:sp>
         <p:nvSpPr>
-          <p:cNvPr id="15" name="Text 12"/>
+          <p:cNvPr id="17" name="Text 13"/>
           <p:cNvSpPr txBox="1"/>
           <p:nvPr/>
         </p:nvSpPr>
@@ -26984,7 +27037,7 @@
       </p:sp>
       <p:sp>
         <p:nvSpPr>
-          <p:cNvPr id="16" name="Text 13"/>
+          <p:cNvPr id="18" name="Text 14"/>
           <p:cNvSpPr txBox="1"/>
           <p:nvPr/>
         </p:nvSpPr>
@@ -27020,7 +27073,7 @@
       </p:sp>
       <p:sp>
         <p:nvSpPr>
-          <p:cNvPr id="17" name="Text 14"/>
+          <p:cNvPr id="19" name="Text 15"/>
           <p:cNvSpPr txBox="1"/>
           <p:nvPr/>
         </p:nvSpPr>
@@ -27056,7 +27109,7 @@
       </p:sp>
       <p:sp>
         <p:nvSpPr>
-          <p:cNvPr id="18" name="Text 15"/>
+          <p:cNvPr id="20" name="Text 16"/>
           <p:cNvSpPr txBox="1"/>
           <p:nvPr/>
         </p:nvSpPr>
@@ -29321,71 +29374,9 @@
           </a:p>
         </p:txBody>
       </p:sp>
-      <p:pic>
-        <p:nvPicPr>
-          <p:cNvPr id="9" name="photo img79.jpg" descr="Đội thi công BLT tại nhà xưởng gia công CNC – Hưng Nguyên, Nghệ An">    </p:cNvPr>
-          <p:cNvPicPr>
-            <a:picLocks noChangeAspect="1"/>
-          </p:cNvPicPr>
-          <p:nvPr/>
-        </p:nvPicPr>
-        <p:blipFill>
-          <a:blip r:embed="rId1"/>
-          <a:stretch>
-            <a:fillRect/>
-          </a:stretch>
-        </p:blipFill>
-        <p:spPr>
-          <a:xfrm>
-            <a:off x="502920" y="7040880"/>
-            <a:ext cx="3566160" cy="2606040"/>
-          </a:xfrm>
-          <a:prstGeom prst="rect">
-            <a:avLst/>
-          </a:prstGeom>
-        </p:spPr>
-      </p:pic>
-      <p:sp>
-        <p:nvSpPr>
-          <p:cNvPr id="10" name="Text 7"/>
-          <p:cNvSpPr txBox="1"/>
-          <p:nvPr/>
-        </p:nvSpPr>
-        <p:spPr>
-          <a:xfrm>
-            <a:off x="502920" y="9683496"/>
-            <a:ext cx="3566160" cy="201168"/>
-          </a:xfrm>
-          <a:prstGeom prst="rect">
-            <a:avLst/>
-          </a:prstGeom>
-          <a:noFill/>
-          <a:ln/>
-        </p:spPr>
-        <p:txBody>
-          <a:bodyPr wrap="square" lIns="0" tIns="0" rIns="0" bIns="0" rtlCol="0" anchor="ctr">
-            <a:normAutofit/>
-          </a:bodyPr>
-          <a:lstStyle/>
-          <a:p>
-            <a:pPr indent="0" marL="0">
-              <a:buNone/>
-            </a:pPr>
-            <a:r>
-              <a:rPr lang="en-US" sz="800" i="1" dirty="0">
-                <a:solidFill>
-                  <a:schemeClr val="accent3"/>
-                </a:solidFill>
-              </a:rPr>
-              <a:t>Đội thi công BLT tại nhà xưởng gia công CNC – Hưng Nguyên, Nghệ An</a:t>
-            </a:r>
-            <a:endParaRPr lang="en-US" sz="800" dirty="0"/>
-          </a:p>
-        </p:txBody>
-      </p:sp>
-      <p:sp>
-        <p:nvSpPr>
-          <p:cNvPr id="11" name="Text 8"/>
+      <p:sp>
+        <p:nvSpPr>
+          <p:cNvPr id="9" name="Text 7"/>
           <p:cNvSpPr txBox="1"/>
           <p:nvPr/>
         </p:nvSpPr>
@@ -29421,7 +29412,7 @@
       </p:sp>
       <p:sp>
         <p:nvSpPr>
-          <p:cNvPr id="12" name="Text 9"/>
+          <p:cNvPr id="10" name="Text 8"/>
           <p:cNvSpPr txBox="1"/>
           <p:nvPr/>
         </p:nvSpPr>
@@ -29460,7 +29451,7 @@
       </p:sp>
       <p:sp>
         <p:nvSpPr>
-          <p:cNvPr id="13" name="Text 10"/>
+          <p:cNvPr id="11" name="Text 9"/>
           <p:cNvSpPr txBox="1"/>
           <p:nvPr/>
         </p:nvSpPr>
@@ -29496,7 +29487,7 @@
       </p:sp>
       <p:sp>
         <p:nvSpPr>
-          <p:cNvPr id="14" name="Text 11"/>
+          <p:cNvPr id="12" name="Text 10"/>
           <p:cNvSpPr txBox="1"/>
           <p:nvPr/>
         </p:nvSpPr>

</xml_diff>

<commit_message>
Hồ sơ năng lực BLT: bỏ thông tin tài khoản ngân hàng
Bỏ bảng tài khoản ở trang pháp lý và dòng tài khoản ở trang liên hệ; giãn
lại trang pháp lý cho cân đối.

Co-Authored-By: Claude Opus 5.5 <noreply@anthropic.com>
Claude-Session: https://claude.ai/code/session_01SkwAuDP5YjDrv41kDvnzWb
</commit_message>
<xml_diff>
--- a/ho-so-nang-luc-BLT/HO_SO_NANG_LUC_BLT.pptx
+++ b/ho-so-nang-luc-BLT/HO_SO_NANG_LUC_BLT.pptx
@@ -132,14 +132,14 @@
   <p:extLst>
     <p:ext uri="{521415D9-36F7-43E2-AB2F-B90AF26B5E84}">
       <p14:sectionLst xmlns:p14="http://schemas.microsoft.com/office/powerpoint/2010/main">
-        <p14:section name="Mở đầu" id="{35f7de7a-d3aa-5e6d-8abd-e329c8e493a1}">
+        <p14:section name="Mở đầu" id="{613efe4e-952f-3095-7e97-1634b52ef755}">
           <p14:sldIdLst>
             <p14:sldId id="256"/>
             <p14:sldId id="257"/>
             <p14:sldId id="258"/>
           </p14:sldIdLst>
         </p14:section>
-        <p14:section name="01 Tổng quan" id="{13a775b4-1674-baf5-5b7f-ae24d97a1941}">
+        <p14:section name="01 Tổng quan" id="{8e56e4c9-61ee-49bc-4beb-dbbc7f943dc0}">
           <p14:sldIdLst>
             <p14:sldId id="259"/>
             <p14:sldId id="260"/>
@@ -148,39 +148,39 @@
             <p14:sldId id="263"/>
           </p14:sldIdLst>
         </p14:section>
-        <p14:section name="02 Điện nước công trình" id="{cce7f6e8-fb4b-3740-c336-af423b1c6f82}">
+        <p14:section name="02 Điện nước công trình" id="{37722329-1041-1cc5-0805-236916ab799a}">
           <p14:sldIdLst>
             <p14:sldId id="264"/>
             <p14:sldId id="265"/>
             <p14:sldId id="266"/>
           </p14:sldIdLst>
         </p14:section>
-        <p14:section name="03 Hút sương dầu nhà xưởng" id="{5db836f6-58a9-daf7-cde8-76dfe6c80d9f}">
+        <p14:section name="03 Hút sương dầu nhà xưởng" id="{015fb9f1-e532-bee4-d21c-4fd07488764a}">
           <p14:sldIdLst>
             <p14:sldId id="267"/>
             <p14:sldId id="268"/>
             <p14:sldId id="269"/>
           </p14:sldIdLst>
         </p14:section>
-        <p14:section name="04 Bơm &amp; xử lý nước" id="{cf4dc152-2715-20fa-fc82-2a60f496fe5e}">
+        <p14:section name="04 Bơm &amp; xử lý nước" id="{c7c0d1fe-ceb6-af1f-f8fe-c1155bb0c9c6}">
           <p14:sldIdLst>
             <p14:sldId id="270"/>
           </p14:sldIdLst>
         </p14:section>
-        <p14:section name="05 Quản trị dự án" id="{d1542d83-5170-6adf-eab6-bb2be8a54644}">
+        <p14:section name="05 Quản trị dự án" id="{d35e3d02-8705-7704-8ed6-3c0d7252a437}">
           <p14:sldIdLst>
             <p14:sldId id="271"/>
             <p14:sldId id="272"/>
             <p14:sldId id="273"/>
           </p14:sldIdLst>
         </p14:section>
-        <p14:section name="06 Nguồn lực" id="{85cfb580-4c68-26d2-9cc1-e3231d8b5d65}">
+        <p14:section name="06 Nguồn lực" id="{c9b8371a-35fa-09ca-2d58-84ecdaefe53d}">
           <p14:sldIdLst>
             <p14:sldId id="274"/>
             <p14:sldId id="275"/>
           </p14:sldIdLst>
         </p14:section>
-        <p14:section name="07 Công trình tiêu biểu" id="{7f7b0a70-08df-98c1-1131-92ccdd61571d}">
+        <p14:section name="07 Công trình tiêu biểu" id="{e053bfed-3ae1-1ffc-b22a-97aefd90ca60}">
           <p14:sldIdLst>
             <p14:sldId id="276"/>
             <p14:sldId id="277"/>
@@ -188,7 +188,7 @@
             <p14:sldId id="279"/>
           </p14:sldIdLst>
         </p14:section>
-        <p14:section name="08 Cam kết &amp; liên hệ" id="{51c459eb-398c-fa46-98b9-37c7aad0005e}">
+        <p14:section name="08 Cam kết &amp; liên hệ" id="{7cf6ea2b-aedc-a59f-f229-fb5fc4930322}">
           <p14:sldIdLst>
             <p14:sldId id="280"/>
             <p14:sldId id="281"/>
@@ -27073,92 +27073,6 @@
       </p:sp>
       <p:sp>
         <p:nvSpPr>
-          <p:cNvPr id="19" name="Text 15"/>
-          <p:cNvSpPr txBox="1"/>
-          <p:nvPr/>
-        </p:nvSpPr>
-        <p:spPr>
-          <a:xfrm>
-            <a:off x="777240" y="8659368"/>
-            <a:ext cx="1463040" cy="548640"/>
-          </a:xfrm>
-          <a:prstGeom prst="rect">
-            <a:avLst/>
-          </a:prstGeom>
-          <a:noFill/>
-          <a:ln/>
-        </p:spPr>
-        <p:txBody>
-          <a:bodyPr wrap="square" lIns="0" tIns="0" rIns="0" bIns="0" rtlCol="0" anchor="t"/>
-          <a:lstStyle/>
-          <a:p>
-            <a:pPr indent="0" marL="0">
-              <a:buNone/>
-            </a:pPr>
-            <a:r>
-              <a:rPr lang="en-US" sz="900" b="1" spc="100" kern="0" dirty="0">
-                <a:solidFill>
-                  <a:schemeClr val="accent1"/>
-                </a:solidFill>
-              </a:rPr>
-              <a:t>TÀI KHOẢN</a:t>
-            </a:r>
-            <a:endParaRPr lang="en-US" sz="900" dirty="0"/>
-          </a:p>
-        </p:txBody>
-      </p:sp>
-      <p:sp>
-        <p:nvSpPr>
-          <p:cNvPr id="20" name="Text 16"/>
-          <p:cNvSpPr txBox="1"/>
-          <p:nvPr/>
-        </p:nvSpPr>
-        <p:spPr>
-          <a:xfrm>
-            <a:off x="2286000" y="8659368"/>
-            <a:ext cx="4498848" cy="548640"/>
-          </a:xfrm>
-          <a:prstGeom prst="rect">
-            <a:avLst/>
-          </a:prstGeom>
-          <a:noFill/>
-          <a:ln/>
-        </p:spPr>
-        <p:txBody>
-          <a:bodyPr wrap="square" lIns="0" tIns="0" rIns="0" bIns="0" rtlCol="0" anchor="t"/>
-          <a:lstStyle/>
-          <a:p>
-            <a:pPr indent="0" marL="0">
-              <a:buNone/>
-            </a:pPr>
-            <a:r>
-              <a:rPr lang="en-US" sz="1050" dirty="0">
-                <a:solidFill>
-                  <a:schemeClr val="bg1"/>
-                </a:solidFill>
-              </a:rPr>
-              <a:t>1066217478 – CT TNHH KY THUAT CONG TRINH BLT</a:t>
-            </a:r>
-            <a:endParaRPr lang="en-US" sz="1050" dirty="0"/>
-          </a:p>
-          <a:p>
-            <a:pPr indent="0" marL="0">
-              <a:buNone/>
-            </a:pPr>
-            <a:r>
-              <a:rPr lang="en-US" sz="1050" dirty="0">
-                <a:solidFill>
-                  <a:schemeClr val="bg1"/>
-                </a:solidFill>
-              </a:rPr>
-              <a:t>Vietcombank – Ngân hàng TMCP Ngoại thương Việt Nam</a:t>
-            </a:r>
-            <a:endParaRPr lang="en-US" sz="1050" dirty="0"/>
-          </a:p>
-        </p:txBody>
-      </p:sp>
-      <p:sp>
-        <p:nvSpPr>
           <p:cNvPr id="25" name="Slide Number Placeholder 0"/>
           <p:cNvSpPr>
             <a:spLocks noGrp="1"/>
@@ -30785,7 +30699,7 @@
                 <a:gridCol w="2194560"/>
                 <a:gridCol w="4361688"/>
               </a:tblGrid>
-              <a:tr h="384048">
+              <a:tr h="548640">
                 <a:tc>
                   <a:txBody>
                     <a:bodyPr/>
@@ -30795,14 +30709,14 @@
                         <a:buNone/>
                       </a:pPr>
                       <a:r>
-                        <a:rPr lang="en-US" sz="1000" b="1" dirty="0">
+                        <a:rPr lang="en-US" sz="1050" b="1" dirty="0">
                           <a:solidFill>
                             <a:schemeClr val="tx2"/>
                           </a:solidFill>
                         </a:rPr>
                         <a:t>Tên doanh nghiệp</a:t>
                       </a:r>
-                      <a:endParaRPr lang="en-US" sz="1000" dirty="0"/>
+                      <a:endParaRPr lang="en-US" sz="1050" dirty="0"/>
                     </a:p>
                   </a:txBody>
                   <a:tcPr marL="109728" marR="109728" marT="64008" marB="64008" anchor="ctr">
@@ -30856,14 +30770,14 @@
                         <a:buNone/>
                       </a:pPr>
                       <a:r>
-                        <a:rPr lang="en-US" sz="1000" dirty="0">
+                        <a:rPr lang="en-US" sz="1050" dirty="0">
                           <a:solidFill>
                             <a:schemeClr val="tx1"/>
                           </a:solidFill>
                         </a:rPr>
                         <a:t>CÔNG TY TNHH KỸ THUẬT CÔNG TRÌNH BLT</a:t>
                       </a:r>
-                      <a:endParaRPr lang="en-US" sz="1000" dirty="0"/>
+                      <a:endParaRPr lang="en-US" sz="1050" dirty="0"/>
                     </a:p>
                   </a:txBody>
                   <a:tcPr marL="109728" marR="109728" marT="64008" marB="64008" anchor="ctr">
@@ -30906,7 +30820,7 @@
                   </a:tcPr>
                 </a:tc>
               </a:tr>
-              <a:tr h="384048">
+              <a:tr h="548640">
                 <a:tc>
                   <a:txBody>
                     <a:bodyPr/>
@@ -30916,14 +30830,14 @@
                         <a:buNone/>
                       </a:pPr>
                       <a:r>
-                        <a:rPr lang="en-US" sz="1000" b="1" dirty="0">
+                        <a:rPr lang="en-US" sz="1050" b="1" dirty="0">
                           <a:solidFill>
                             <a:schemeClr val="tx2"/>
                           </a:solidFill>
                         </a:rPr>
                         <a:t>Tên viết tắt</a:t>
                       </a:r>
-                      <a:endParaRPr lang="en-US" sz="1000" dirty="0"/>
+                      <a:endParaRPr lang="en-US" sz="1050" dirty="0"/>
                     </a:p>
                   </a:txBody>
                   <a:tcPr marL="109728" marR="109728" marT="64008" marB="64008" anchor="ctr">
@@ -30977,14 +30891,14 @@
                         <a:buNone/>
                       </a:pPr>
                       <a:r>
-                        <a:rPr lang="en-US" sz="1000" dirty="0">
+                        <a:rPr lang="en-US" sz="1050" dirty="0">
                           <a:solidFill>
                             <a:schemeClr val="tx1"/>
                           </a:solidFill>
                         </a:rPr>
                         <a:t>BLT  (nhận diện: BLT Điện Nước)</a:t>
                       </a:r>
-                      <a:endParaRPr lang="en-US" sz="1000" dirty="0"/>
+                      <a:endParaRPr lang="en-US" sz="1050" dirty="0"/>
                     </a:p>
                   </a:txBody>
                   <a:tcPr marL="109728" marR="109728" marT="64008" marB="64008" anchor="ctr">
@@ -31027,7 +30941,7 @@
                   </a:tcPr>
                 </a:tc>
               </a:tr>
-              <a:tr h="384048">
+              <a:tr h="548640">
                 <a:tc>
                   <a:txBody>
                     <a:bodyPr/>
@@ -31037,14 +30951,14 @@
                         <a:buNone/>
                       </a:pPr>
                       <a:r>
-                        <a:rPr lang="en-US" sz="1000" b="1" dirty="0">
+                        <a:rPr lang="en-US" sz="1050" b="1" dirty="0">
                           <a:solidFill>
                             <a:schemeClr val="tx2"/>
                           </a:solidFill>
                         </a:rPr>
                         <a:t>Mã số doanh nghiệp / MST</a:t>
                       </a:r>
-                      <a:endParaRPr lang="en-US" sz="1000" dirty="0"/>
+                      <a:endParaRPr lang="en-US" sz="1050" dirty="0"/>
                     </a:p>
                   </a:txBody>
                   <a:tcPr marL="109728" marR="109728" marT="64008" marB="64008" anchor="ctr">
@@ -31098,14 +31012,14 @@
                         <a:buNone/>
                       </a:pPr>
                       <a:r>
-                        <a:rPr lang="en-US" sz="1000" dirty="0">
+                        <a:rPr lang="en-US" sz="1050" dirty="0">
                           <a:solidFill>
                             <a:schemeClr val="tx1"/>
                           </a:solidFill>
                         </a:rPr>
                         <a:t>2902269718</a:t>
                       </a:r>
-                      <a:endParaRPr lang="en-US" sz="1000" dirty="0"/>
+                      <a:endParaRPr lang="en-US" sz="1050" dirty="0"/>
                     </a:p>
                   </a:txBody>
                   <a:tcPr marL="109728" marR="109728" marT="64008" marB="64008" anchor="ctr">
@@ -31148,7 +31062,7 @@
                   </a:tcPr>
                 </a:tc>
               </a:tr>
-              <a:tr h="384048">
+              <a:tr h="548640">
                 <a:tc>
                   <a:txBody>
                     <a:bodyPr/>
@@ -31158,14 +31072,14 @@
                         <a:buNone/>
                       </a:pPr>
                       <a:r>
-                        <a:rPr lang="en-US" sz="1000" b="1" dirty="0">
+                        <a:rPr lang="en-US" sz="1050" b="1" dirty="0">
                           <a:solidFill>
                             <a:schemeClr val="tx2"/>
                           </a:solidFill>
                         </a:rPr>
                         <a:t>Loại hình</a:t>
                       </a:r>
-                      <a:endParaRPr lang="en-US" sz="1000" dirty="0"/>
+                      <a:endParaRPr lang="en-US" sz="1050" dirty="0"/>
                     </a:p>
                   </a:txBody>
                   <a:tcPr marL="109728" marR="109728" marT="64008" marB="64008" anchor="ctr">
@@ -31219,14 +31133,14 @@
                         <a:buNone/>
                       </a:pPr>
                       <a:r>
-                        <a:rPr lang="en-US" sz="1000" dirty="0">
+                        <a:rPr lang="en-US" sz="1050" dirty="0">
                           <a:solidFill>
                             <a:schemeClr val="tx1"/>
                           </a:solidFill>
                         </a:rPr>
                         <a:t>Công ty trách nhiệm hữu hạn</a:t>
                       </a:r>
-                      <a:endParaRPr lang="en-US" sz="1000" dirty="0"/>
+                      <a:endParaRPr lang="en-US" sz="1050" dirty="0"/>
                     </a:p>
                   </a:txBody>
                   <a:tcPr marL="109728" marR="109728" marT="64008" marB="64008" anchor="ctr">
@@ -31269,7 +31183,7 @@
                   </a:tcPr>
                 </a:tc>
               </a:tr>
-              <a:tr h="384048">
+              <a:tr h="548640">
                 <a:tc>
                   <a:txBody>
                     <a:bodyPr/>
@@ -31279,14 +31193,14 @@
                         <a:buNone/>
                       </a:pPr>
                       <a:r>
-                        <a:rPr lang="en-US" sz="1000" b="1" dirty="0">
+                        <a:rPr lang="en-US" sz="1050" b="1" dirty="0">
                           <a:solidFill>
                             <a:schemeClr val="tx2"/>
                           </a:solidFill>
                         </a:rPr>
                         <a:t>Địa chỉ trụ sở</a:t>
                       </a:r>
-                      <a:endParaRPr lang="en-US" sz="1000" dirty="0"/>
+                      <a:endParaRPr lang="en-US" sz="1050" dirty="0"/>
                     </a:p>
                   </a:txBody>
                   <a:tcPr marL="109728" marR="109728" marT="64008" marB="64008" anchor="ctr">
@@ -31340,14 +31254,14 @@
                         <a:buNone/>
                       </a:pPr>
                       <a:r>
-                        <a:rPr lang="en-US" sz="1000" dirty="0">
+                        <a:rPr lang="en-US" sz="1050" dirty="0">
                           <a:solidFill>
                             <a:schemeClr val="tx1"/>
                           </a:solidFill>
                         </a:rPr>
                         <a:t>Số 2A đường Nguyễn Khánh Toàn, khối Trường Phúc, phường Trường Vinh, tỉnh Nghệ An, Việt Nam</a:t>
                       </a:r>
-                      <a:endParaRPr lang="en-US" sz="1000" dirty="0"/>
+                      <a:endParaRPr lang="en-US" sz="1050" dirty="0"/>
                     </a:p>
                   </a:txBody>
                   <a:tcPr marL="109728" marR="109728" marT="64008" marB="64008" anchor="ctr">
@@ -31390,7 +31304,7 @@
                   </a:tcPr>
                 </a:tc>
               </a:tr>
-              <a:tr h="384048">
+              <a:tr h="548640">
                 <a:tc>
                   <a:txBody>
                     <a:bodyPr/>
@@ -31400,14 +31314,14 @@
                         <a:buNone/>
                       </a:pPr>
                       <a:r>
-                        <a:rPr lang="en-US" sz="1000" b="1" dirty="0">
+                        <a:rPr lang="en-US" sz="1050" b="1" dirty="0">
                           <a:solidFill>
                             <a:schemeClr val="tx2"/>
                           </a:solidFill>
                         </a:rPr>
                         <a:t>Chủ sở hữu</a:t>
                       </a:r>
-                      <a:endParaRPr lang="en-US" sz="1000" dirty="0"/>
+                      <a:endParaRPr lang="en-US" sz="1050" dirty="0"/>
                     </a:p>
                   </a:txBody>
                   <a:tcPr marL="109728" marR="109728" marT="64008" marB="64008" anchor="ctr">
@@ -31461,14 +31375,14 @@
                         <a:buNone/>
                       </a:pPr>
                       <a:r>
-                        <a:rPr lang="en-US" sz="1000" dirty="0">
+                        <a:rPr lang="en-US" sz="1050" dirty="0">
                           <a:solidFill>
                             <a:schemeClr val="tx1"/>
                           </a:solidFill>
                         </a:rPr>
                         <a:t>Ông HỒ VĂN BÌNH</a:t>
                       </a:r>
-                      <a:endParaRPr lang="en-US" sz="1000" dirty="0"/>
+                      <a:endParaRPr lang="en-US" sz="1050" dirty="0"/>
                     </a:p>
                   </a:txBody>
                   <a:tcPr marL="109728" marR="109728" marT="64008" marB="64008" anchor="ctr">
@@ -31511,7 +31425,7 @@
                   </a:tcPr>
                 </a:tc>
               </a:tr>
-              <a:tr h="384048">
+              <a:tr h="548640">
                 <a:tc>
                   <a:txBody>
                     <a:bodyPr/>
@@ -31521,14 +31435,14 @@
                         <a:buNone/>
                       </a:pPr>
                       <a:r>
-                        <a:rPr lang="en-US" sz="1000" b="1" dirty="0">
+                        <a:rPr lang="en-US" sz="1050" b="1" dirty="0">
                           <a:solidFill>
                             <a:schemeClr val="tx2"/>
                           </a:solidFill>
                         </a:rPr>
                         <a:t>Người đại diện theo pháp luật</a:t>
                       </a:r>
-                      <a:endParaRPr lang="en-US" sz="1000" dirty="0"/>
+                      <a:endParaRPr lang="en-US" sz="1050" dirty="0"/>
                     </a:p>
                   </a:txBody>
                   <a:tcPr marL="109728" marR="109728" marT="64008" marB="64008" anchor="ctr">
@@ -31582,14 +31496,14 @@
                         <a:buNone/>
                       </a:pPr>
                       <a:r>
-                        <a:rPr lang="en-US" sz="1000" dirty="0">
+                        <a:rPr lang="en-US" sz="1050" dirty="0">
                           <a:solidFill>
                             <a:schemeClr val="tx1"/>
                           </a:solidFill>
                         </a:rPr>
                         <a:t>Ông HỒ VĂN BÌNH – Giám đốc</a:t>
                       </a:r>
-                      <a:endParaRPr lang="en-US" sz="1000" dirty="0"/>
+                      <a:endParaRPr lang="en-US" sz="1050" dirty="0"/>
                     </a:p>
                   </a:txBody>
                   <a:tcPr marL="109728" marR="109728" marT="64008" marB="64008" anchor="ctr">
@@ -31632,7 +31546,7 @@
                   </a:tcPr>
                 </a:tc>
               </a:tr>
-              <a:tr h="384048">
+              <a:tr h="548640">
                 <a:tc>
                   <a:txBody>
                     <a:bodyPr/>
@@ -31642,14 +31556,14 @@
                         <a:buNone/>
                       </a:pPr>
                       <a:r>
-                        <a:rPr lang="en-US" sz="1000" b="1" dirty="0">
+                        <a:rPr lang="en-US" sz="1050" b="1" dirty="0">
                           <a:solidFill>
                             <a:schemeClr val="tx2"/>
                           </a:solidFill>
                         </a:rPr>
                         <a:t>Điện thoại</a:t>
                       </a:r>
-                      <a:endParaRPr lang="en-US" sz="1000" dirty="0"/>
+                      <a:endParaRPr lang="en-US" sz="1050" dirty="0"/>
                     </a:p>
                   </a:txBody>
                   <a:tcPr marL="109728" marR="109728" marT="64008" marB="64008" anchor="ctr">
@@ -31703,14 +31617,14 @@
                         <a:buNone/>
                       </a:pPr>
                       <a:r>
-                        <a:rPr lang="en-US" sz="1000" dirty="0">
+                        <a:rPr lang="en-US" sz="1050" dirty="0">
                           <a:solidFill>
                             <a:schemeClr val="tx1"/>
                           </a:solidFill>
                         </a:rPr>
                         <a:t>0984 586 089</a:t>
                       </a:r>
-                      <a:endParaRPr lang="en-US" sz="1000" dirty="0"/>
+                      <a:endParaRPr lang="en-US" sz="1050" dirty="0"/>
                     </a:p>
                   </a:txBody>
                   <a:tcPr marL="109728" marR="109728" marT="64008" marB="64008" anchor="ctr">
@@ -31753,7 +31667,7 @@
                   </a:tcPr>
                 </a:tc>
               </a:tr>
-              <a:tr h="384048">
+              <a:tr h="548640">
                 <a:tc>
                   <a:txBody>
                     <a:bodyPr/>
@@ -31763,14 +31677,14 @@
                         <a:buNone/>
                       </a:pPr>
                       <a:r>
-                        <a:rPr lang="en-US" sz="1000" b="1" dirty="0">
+                        <a:rPr lang="en-US" sz="1050" b="1" dirty="0">
                           <a:solidFill>
                             <a:schemeClr val="tx2"/>
                           </a:solidFill>
                         </a:rPr>
                         <a:t>Email</a:t>
                       </a:r>
-                      <a:endParaRPr lang="en-US" sz="1000" dirty="0"/>
+                      <a:endParaRPr lang="en-US" sz="1050" dirty="0"/>
                     </a:p>
                   </a:txBody>
                   <a:tcPr marL="109728" marR="109728" marT="64008" marB="64008" anchor="ctr">
@@ -31824,14 +31738,14 @@
                         <a:buNone/>
                       </a:pPr>
                       <a:r>
-                        <a:rPr lang="en-US" sz="1000" dirty="0">
+                        <a:rPr lang="en-US" sz="1050" dirty="0">
                           <a:solidFill>
                             <a:schemeClr val="tx1"/>
                           </a:solidFill>
                         </a:rPr>
                         <a:t>hobinh150589@gmail.com</a:t>
                       </a:r>
-                      <a:endParaRPr lang="en-US" sz="1000" dirty="0"/>
+                      <a:endParaRPr lang="en-US" sz="1050" dirty="0"/>
                     </a:p>
                   </a:txBody>
                   <a:tcPr marL="109728" marR="109728" marT="64008" marB="64008" anchor="ctr">
@@ -31886,7 +31800,7 @@
         </p:nvSpPr>
         <p:spPr>
           <a:xfrm>
-            <a:off x="502920" y="5532120"/>
+            <a:off x="502920" y="6949440"/>
             <a:ext cx="6556248" cy="228600"/>
           </a:xfrm>
           <a:prstGeom prst="rect">
@@ -31911,458 +31825,26 @@
                 <a:ea typeface="Arial" pitchFamily="34" charset="-122"/>
                 <a:cs typeface="Arial" pitchFamily="34" charset="-120"/>
               </a:rPr>
-              <a:t>THÔNG TIN TÀI KHOẢN</a:t>
+              <a:t>LĨNH VỰC HOẠT ĐỘNG CHÍNH</a:t>
             </a:r>
             <a:endParaRPr lang="en-US" sz="900" dirty="0"/>
           </a:p>
         </p:txBody>
       </p:sp>
-      <p:graphicFrame>
-        <p:nvGraphicFramePr>
-          <p:cNvPr id="13" name="Table 1"/>
-          <p:cNvGraphicFramePr>
-            <a:graphicFrameLocks noGrp="1"/>
-          </p:cNvGraphicFramePr>
-          <p:nvPr>
-            <p:extLst>
-              <p:ext uri="{D42A27DB-BD31-4B8C-83A1-F6EECF244321}">
-                <p14:modId xmlns:p14="http://schemas.microsoft.com/office/powerpoint/2010/main" val="1579011935"/>
-              </p:ext>
-            </p:extLst>
-          </p:nvPr>
-        </p:nvGraphicFramePr>
-        <p:xfrm>
-          <a:off x="502920" y="5806440"/>
-          <a:ext cx="6556248" cy="914400"/>
-        </p:xfrm>
-        <a:graphic>
-          <a:graphicData uri="http://schemas.openxmlformats.org/drawingml/2006/table">
-            <a:tbl>
-              <a:tblPr/>
-              <a:tblGrid>
-                <a:gridCol w="2194560"/>
-                <a:gridCol w="4361688"/>
-              </a:tblGrid>
-              <a:tr h="384048">
-                <a:tc>
-                  <a:txBody>
-                    <a:bodyPr/>
-                    <a:lstStyle/>
-                    <a:p>
-                      <a:pPr indent="0" marL="0">
-                        <a:buNone/>
-                      </a:pPr>
-                      <a:r>
-                        <a:rPr lang="en-US" sz="1000" b="1" dirty="0">
-                          <a:solidFill>
-                            <a:schemeClr val="bg1"/>
-                          </a:solidFill>
-                        </a:rPr>
-                        <a:t>Số tài khoản</a:t>
-                      </a:r>
-                      <a:endParaRPr lang="en-US" sz="1000" dirty="0"/>
-                    </a:p>
-                  </a:txBody>
-                  <a:tcPr marL="109728" marR="109728" marT="64008" marB="64008" anchor="ctr">
-                    <a:lnL w="9525" cap="flat" cmpd="sng" algn="ctr">
-                      <a:solidFill>
-                        <a:srgbClr val="C9D5E3"/>
-                      </a:solidFill>
-                      <a:prstDash val="solid"/>
-                      <a:round/>
-                      <a:headEnd type="none" w="med" len="med"/>
-                      <a:tailEnd type="none" w="med" len="med"/>
-                    </a:lnL>
-                    <a:lnR w="9525" cap="flat" cmpd="sng" algn="ctr">
-                      <a:solidFill>
-                        <a:srgbClr val="C9D5E3"/>
-                      </a:solidFill>
-                      <a:prstDash val="solid"/>
-                      <a:round/>
-                      <a:headEnd type="none" w="med" len="med"/>
-                      <a:tailEnd type="none" w="med" len="med"/>
-                    </a:lnR>
-                    <a:lnT w="9525" cap="flat" cmpd="sng" algn="ctr">
-                      <a:solidFill>
-                        <a:srgbClr val="C9D5E3"/>
-                      </a:solidFill>
-                      <a:prstDash val="solid"/>
-                      <a:round/>
-                      <a:headEnd type="none" w="med" len="med"/>
-                      <a:tailEnd type="none" w="med" len="med"/>
-                    </a:lnT>
-                    <a:lnB w="9525" cap="flat" cmpd="sng" algn="ctr">
-                      <a:solidFill>
-                        <a:srgbClr val="C9D5E3"/>
-                      </a:solidFill>
-                      <a:prstDash val="solid"/>
-                      <a:round/>
-                      <a:headEnd type="none" w="med" len="med"/>
-                      <a:tailEnd type="none" w="med" len="med"/>
-                    </a:lnB>
-                    <a:solidFill>
-                      <a:schemeClr val="tx2"/>
-                    </a:solidFill>
-                  </a:tcPr>
-                </a:tc>
-                <a:tc>
-                  <a:txBody>
-                    <a:bodyPr/>
-                    <a:lstStyle/>
-                    <a:p>
-                      <a:pPr indent="0" marL="0">
-                        <a:buNone/>
-                      </a:pPr>
-                      <a:r>
-                        <a:rPr lang="en-US" sz="1000" b="1" dirty="0">
-                          <a:solidFill>
-                            <a:schemeClr val="tx1"/>
-                          </a:solidFill>
-                        </a:rPr>
-                        <a:t>1066217478</a:t>
-                      </a:r>
-                      <a:endParaRPr lang="en-US" sz="1000" dirty="0"/>
-                    </a:p>
-                  </a:txBody>
-                  <a:tcPr marL="109728" marR="109728" marT="64008" marB="64008" anchor="ctr">
-                    <a:lnL w="9525" cap="flat" cmpd="sng" algn="ctr">
-                      <a:solidFill>
-                        <a:srgbClr val="C9D5E3"/>
-                      </a:solidFill>
-                      <a:prstDash val="solid"/>
-                      <a:round/>
-                      <a:headEnd type="none" w="med" len="med"/>
-                      <a:tailEnd type="none" w="med" len="med"/>
-                    </a:lnL>
-                    <a:lnR w="9525" cap="flat" cmpd="sng" algn="ctr">
-                      <a:solidFill>
-                        <a:srgbClr val="C9D5E3"/>
-                      </a:solidFill>
-                      <a:prstDash val="solid"/>
-                      <a:round/>
-                      <a:headEnd type="none" w="med" len="med"/>
-                      <a:tailEnd type="none" w="med" len="med"/>
-                    </a:lnR>
-                    <a:lnT w="9525" cap="flat" cmpd="sng" algn="ctr">
-                      <a:solidFill>
-                        <a:srgbClr val="C9D5E3"/>
-                      </a:solidFill>
-                      <a:prstDash val="solid"/>
-                      <a:round/>
-                      <a:headEnd type="none" w="med" len="med"/>
-                      <a:tailEnd type="none" w="med" len="med"/>
-                    </a:lnT>
-                    <a:lnB w="9525" cap="flat" cmpd="sng" algn="ctr">
-                      <a:solidFill>
-                        <a:srgbClr val="C9D5E3"/>
-                      </a:solidFill>
-                      <a:prstDash val="solid"/>
-                      <a:round/>
-                      <a:headEnd type="none" w="med" len="med"/>
-                      <a:tailEnd type="none" w="med" len="med"/>
-                    </a:lnB>
-                  </a:tcPr>
-                </a:tc>
-              </a:tr>
-              <a:tr h="384048">
-                <a:tc>
-                  <a:txBody>
-                    <a:bodyPr/>
-                    <a:lstStyle/>
-                    <a:p>
-                      <a:pPr indent="0" marL="0">
-                        <a:buNone/>
-                      </a:pPr>
-                      <a:r>
-                        <a:rPr lang="en-US" sz="1000" b="1" dirty="0">
-                          <a:solidFill>
-                            <a:schemeClr val="bg1"/>
-                          </a:solidFill>
-                        </a:rPr>
-                        <a:t>Tên tài khoản</a:t>
-                      </a:r>
-                      <a:endParaRPr lang="en-US" sz="1000" dirty="0"/>
-                    </a:p>
-                  </a:txBody>
-                  <a:tcPr marL="109728" marR="109728" marT="64008" marB="64008" anchor="ctr">
-                    <a:lnL w="9525" cap="flat" cmpd="sng" algn="ctr">
-                      <a:solidFill>
-                        <a:srgbClr val="C9D5E3"/>
-                      </a:solidFill>
-                      <a:prstDash val="solid"/>
-                      <a:round/>
-                      <a:headEnd type="none" w="med" len="med"/>
-                      <a:tailEnd type="none" w="med" len="med"/>
-                    </a:lnL>
-                    <a:lnR w="9525" cap="flat" cmpd="sng" algn="ctr">
-                      <a:solidFill>
-                        <a:srgbClr val="C9D5E3"/>
-                      </a:solidFill>
-                      <a:prstDash val="solid"/>
-                      <a:round/>
-                      <a:headEnd type="none" w="med" len="med"/>
-                      <a:tailEnd type="none" w="med" len="med"/>
-                    </a:lnR>
-                    <a:lnT w="9525" cap="flat" cmpd="sng" algn="ctr">
-                      <a:solidFill>
-                        <a:srgbClr val="C9D5E3"/>
-                      </a:solidFill>
-                      <a:prstDash val="solid"/>
-                      <a:round/>
-                      <a:headEnd type="none" w="med" len="med"/>
-                      <a:tailEnd type="none" w="med" len="med"/>
-                    </a:lnT>
-                    <a:lnB w="9525" cap="flat" cmpd="sng" algn="ctr">
-                      <a:solidFill>
-                        <a:srgbClr val="C9D5E3"/>
-                      </a:solidFill>
-                      <a:prstDash val="solid"/>
-                      <a:round/>
-                      <a:headEnd type="none" w="med" len="med"/>
-                      <a:tailEnd type="none" w="med" len="med"/>
-                    </a:lnB>
-                    <a:solidFill>
-                      <a:schemeClr val="tx2"/>
-                    </a:solidFill>
-                  </a:tcPr>
-                </a:tc>
-                <a:tc>
-                  <a:txBody>
-                    <a:bodyPr/>
-                    <a:lstStyle/>
-                    <a:p>
-                      <a:pPr indent="0" marL="0">
-                        <a:buNone/>
-                      </a:pPr>
-                      <a:r>
-                        <a:rPr lang="en-US" sz="1000" dirty="0">
-                          <a:solidFill>
-                            <a:schemeClr val="tx1"/>
-                          </a:solidFill>
-                        </a:rPr>
-                        <a:t>CT TNHH KY THUAT CONG TRINH BLT</a:t>
-                      </a:r>
-                      <a:endParaRPr lang="en-US" sz="1000" dirty="0"/>
-                    </a:p>
-                  </a:txBody>
-                  <a:tcPr marL="109728" marR="109728" marT="64008" marB="64008" anchor="ctr">
-                    <a:lnL w="9525" cap="flat" cmpd="sng" algn="ctr">
-                      <a:solidFill>
-                        <a:srgbClr val="C9D5E3"/>
-                      </a:solidFill>
-                      <a:prstDash val="solid"/>
-                      <a:round/>
-                      <a:headEnd type="none" w="med" len="med"/>
-                      <a:tailEnd type="none" w="med" len="med"/>
-                    </a:lnL>
-                    <a:lnR w="9525" cap="flat" cmpd="sng" algn="ctr">
-                      <a:solidFill>
-                        <a:srgbClr val="C9D5E3"/>
-                      </a:solidFill>
-                      <a:prstDash val="solid"/>
-                      <a:round/>
-                      <a:headEnd type="none" w="med" len="med"/>
-                      <a:tailEnd type="none" w="med" len="med"/>
-                    </a:lnR>
-                    <a:lnT w="9525" cap="flat" cmpd="sng" algn="ctr">
-                      <a:solidFill>
-                        <a:srgbClr val="C9D5E3"/>
-                      </a:solidFill>
-                      <a:prstDash val="solid"/>
-                      <a:round/>
-                      <a:headEnd type="none" w="med" len="med"/>
-                      <a:tailEnd type="none" w="med" len="med"/>
-                    </a:lnT>
-                    <a:lnB w="9525" cap="flat" cmpd="sng" algn="ctr">
-                      <a:solidFill>
-                        <a:srgbClr val="C9D5E3"/>
-                      </a:solidFill>
-                      <a:prstDash val="solid"/>
-                      <a:round/>
-                      <a:headEnd type="none" w="med" len="med"/>
-                      <a:tailEnd type="none" w="med" len="med"/>
-                    </a:lnB>
-                  </a:tcPr>
-                </a:tc>
-              </a:tr>
-              <a:tr h="384048">
-                <a:tc>
-                  <a:txBody>
-                    <a:bodyPr/>
-                    <a:lstStyle/>
-                    <a:p>
-                      <a:pPr indent="0" marL="0">
-                        <a:buNone/>
-                      </a:pPr>
-                      <a:r>
-                        <a:rPr lang="en-US" sz="1000" b="1" dirty="0">
-                          <a:solidFill>
-                            <a:schemeClr val="bg1"/>
-                          </a:solidFill>
-                        </a:rPr>
-                        <a:t>Ngân hàng</a:t>
-                      </a:r>
-                      <a:endParaRPr lang="en-US" sz="1000" dirty="0"/>
-                    </a:p>
-                  </a:txBody>
-                  <a:tcPr marL="109728" marR="109728" marT="64008" marB="64008" anchor="ctr">
-                    <a:lnL w="9525" cap="flat" cmpd="sng" algn="ctr">
-                      <a:solidFill>
-                        <a:srgbClr val="C9D5E3"/>
-                      </a:solidFill>
-                      <a:prstDash val="solid"/>
-                      <a:round/>
-                      <a:headEnd type="none" w="med" len="med"/>
-                      <a:tailEnd type="none" w="med" len="med"/>
-                    </a:lnL>
-                    <a:lnR w="9525" cap="flat" cmpd="sng" algn="ctr">
-                      <a:solidFill>
-                        <a:srgbClr val="C9D5E3"/>
-                      </a:solidFill>
-                      <a:prstDash val="solid"/>
-                      <a:round/>
-                      <a:headEnd type="none" w="med" len="med"/>
-                      <a:tailEnd type="none" w="med" len="med"/>
-                    </a:lnR>
-                    <a:lnT w="9525" cap="flat" cmpd="sng" algn="ctr">
-                      <a:solidFill>
-                        <a:srgbClr val="C9D5E3"/>
-                      </a:solidFill>
-                      <a:prstDash val="solid"/>
-                      <a:round/>
-                      <a:headEnd type="none" w="med" len="med"/>
-                      <a:tailEnd type="none" w="med" len="med"/>
-                    </a:lnT>
-                    <a:lnB w="9525" cap="flat" cmpd="sng" algn="ctr">
-                      <a:solidFill>
-                        <a:srgbClr val="C9D5E3"/>
-                      </a:solidFill>
-                      <a:prstDash val="solid"/>
-                      <a:round/>
-                      <a:headEnd type="none" w="med" len="med"/>
-                      <a:tailEnd type="none" w="med" len="med"/>
-                    </a:lnB>
-                    <a:solidFill>
-                      <a:schemeClr val="tx2"/>
-                    </a:solidFill>
-                  </a:tcPr>
-                </a:tc>
-                <a:tc>
-                  <a:txBody>
-                    <a:bodyPr/>
-                    <a:lstStyle/>
-                    <a:p>
-                      <a:pPr indent="0" marL="0">
-                        <a:buNone/>
-                      </a:pPr>
-                      <a:r>
-                        <a:rPr lang="en-US" sz="1000" dirty="0">
-                          <a:solidFill>
-                            <a:schemeClr val="tx1"/>
-                          </a:solidFill>
-                        </a:rPr>
-                        <a:t>Ngân hàng TMCP Ngoại thương Việt Nam (Vietcombank)</a:t>
-                      </a:r>
-                      <a:endParaRPr lang="en-US" sz="1000" dirty="0"/>
-                    </a:p>
-                  </a:txBody>
-                  <a:tcPr marL="109728" marR="109728" marT="64008" marB="64008" anchor="ctr">
-                    <a:lnL w="9525" cap="flat" cmpd="sng" algn="ctr">
-                      <a:solidFill>
-                        <a:srgbClr val="C9D5E3"/>
-                      </a:solidFill>
-                      <a:prstDash val="solid"/>
-                      <a:round/>
-                      <a:headEnd type="none" w="med" len="med"/>
-                      <a:tailEnd type="none" w="med" len="med"/>
-                    </a:lnL>
-                    <a:lnR w="9525" cap="flat" cmpd="sng" algn="ctr">
-                      <a:solidFill>
-                        <a:srgbClr val="C9D5E3"/>
-                      </a:solidFill>
-                      <a:prstDash val="solid"/>
-                      <a:round/>
-                      <a:headEnd type="none" w="med" len="med"/>
-                      <a:tailEnd type="none" w="med" len="med"/>
-                    </a:lnR>
-                    <a:lnT w="9525" cap="flat" cmpd="sng" algn="ctr">
-                      <a:solidFill>
-                        <a:srgbClr val="C9D5E3"/>
-                      </a:solidFill>
-                      <a:prstDash val="solid"/>
-                      <a:round/>
-                      <a:headEnd type="none" w="med" len="med"/>
-                      <a:tailEnd type="none" w="med" len="med"/>
-                    </a:lnT>
-                    <a:lnB w="9525" cap="flat" cmpd="sng" algn="ctr">
-                      <a:solidFill>
-                        <a:srgbClr val="C9D5E3"/>
-                      </a:solidFill>
-                      <a:prstDash val="solid"/>
-                      <a:round/>
-                      <a:headEnd type="none" w="med" len="med"/>
-                      <a:tailEnd type="none" w="med" len="med"/>
-                    </a:lnB>
-                  </a:tcPr>
-                </a:tc>
-              </a:tr>
-            </a:tbl>
-          </a:graphicData>
-        </a:graphic>
-      </p:graphicFrame>
-      <p:sp>
-        <p:nvSpPr>
-          <p:cNvPr id="7" name="Text 3"/>
-          <p:cNvSpPr txBox="1"/>
-          <p:nvPr/>
-        </p:nvSpPr>
-        <p:spPr>
-          <a:xfrm>
-            <a:off x="502920" y="7269480"/>
-            <a:ext cx="6556248" cy="228600"/>
-          </a:xfrm>
-          <a:prstGeom prst="rect">
-            <a:avLst/>
-          </a:prstGeom>
-          <a:noFill/>
-          <a:ln/>
-        </p:spPr>
-        <p:txBody>
-          <a:bodyPr wrap="square" lIns="0" tIns="0" rIns="0" bIns="0" rtlCol="0" anchor="ctr"/>
-          <a:lstStyle/>
-          <a:p>
-            <a:pPr indent="0" marL="0">
-              <a:buNone/>
-            </a:pPr>
-            <a:r>
-              <a:rPr lang="en-US" sz="900" b="1" spc="200" kern="0" dirty="0">
-                <a:solidFill>
-                  <a:schemeClr val="accent1"/>
-                </a:solidFill>
-                <a:latin typeface="Arial" pitchFamily="34" charset="0"/>
-                <a:ea typeface="Arial" pitchFamily="34" charset="-122"/>
-                <a:cs typeface="Arial" pitchFamily="34" charset="-120"/>
-              </a:rPr>
-              <a:t>LĨNH VỰC HOẠT ĐỘNG CHÍNH</a:t>
-            </a:r>
-            <a:endParaRPr lang="en-US" sz="900" dirty="0"/>
-          </a:p>
-        </p:txBody>
-      </p:sp>
-      <p:sp>
-        <p:nvSpPr>
-          <p:cNvPr id="8" name="Shape 4"/>
+      <p:sp>
+        <p:nvSpPr>
+          <p:cNvPr id="6" name="Shape 3"/>
           <p:cNvSpPr/>
           <p:nvPr/>
         </p:nvSpPr>
         <p:spPr>
           <a:xfrm>
-            <a:off x="502920" y="7543800"/>
-            <a:ext cx="6556248" cy="2103120"/>
+            <a:off x="502920" y="7223760"/>
+            <a:ext cx="6556248" cy="2377440"/>
           </a:xfrm>
           <a:prstGeom prst="roundRect">
             <a:avLst>
-              <a:gd name="adj" fmla="val 3478"/>
+              <a:gd name="adj" fmla="val 3077"/>
             </a:avLst>
           </a:prstGeom>
           <a:solidFill>
@@ -32378,113 +31860,113 @@
       </p:sp>
       <p:sp>
         <p:nvSpPr>
-          <p:cNvPr id="9" name="Text 5"/>
-          <p:cNvSpPr txBox="1"/>
-          <p:nvPr/>
-        </p:nvSpPr>
-        <p:spPr>
-          <a:xfrm>
-            <a:off x="731520" y="7680960"/>
-            <a:ext cx="6099048" cy="1874520"/>
-          </a:xfrm>
-          <a:prstGeom prst="rect">
-            <a:avLst/>
-          </a:prstGeom>
-          <a:noFill/>
-          <a:ln/>
-        </p:spPr>
-        <p:txBody>
-          <a:bodyPr wrap="square" lIns="0" tIns="0" rIns="0" bIns="0" rtlCol="0" anchor="t"/>
+          <p:cNvPr id="7" name="Text 4"/>
+          <p:cNvSpPr txBox="1"/>
+          <p:nvPr/>
+        </p:nvSpPr>
+        <p:spPr>
+          <a:xfrm>
+            <a:off x="777240" y="7406640"/>
+            <a:ext cx="6007608" cy="2057400"/>
+          </a:xfrm>
+          <a:prstGeom prst="rect">
+            <a:avLst/>
+          </a:prstGeom>
+          <a:noFill/>
+          <a:ln/>
+        </p:spPr>
+        <p:txBody>
+          <a:bodyPr wrap="square" lIns="0" tIns="0" rIns="0" bIns="0" rtlCol="0" anchor="ctr"/>
           <a:lstStyle/>
           <a:p>
             <a:pPr marL="152400" indent="-152400">
               <a:spcAft>
-                <a:spcPts val="500"/>
+                <a:spcPts val="900"/>
               </a:spcAft>
               <a:buSzPct val="100000"/>
               <a:buChar char="•"/>
             </a:pPr>
             <a:r>
-              <a:rPr lang="en-US" sz="1000" dirty="0">
+              <a:rPr lang="en-US" sz="1100" dirty="0">
                 <a:solidFill>
                   <a:schemeClr val="tx1"/>
                 </a:solidFill>
               </a:rPr>
               <a:t>Lắp đặt hệ thống điện động lực, điện chiếu sáng, tủ điện, máng – thang cáp</a:t>
             </a:r>
-            <a:endParaRPr lang="en-US" sz="1000" dirty="0"/>
+            <a:endParaRPr lang="en-US" sz="1100" dirty="0"/>
           </a:p>
           <a:p>
             <a:pPr marL="152400" indent="-152400">
               <a:spcAft>
-                <a:spcPts val="500"/>
+                <a:spcPts val="900"/>
               </a:spcAft>
               <a:buSzPct val="100000"/>
               <a:buChar char="•"/>
             </a:pPr>
             <a:r>
-              <a:rPr lang="en-US" sz="1000" dirty="0">
+              <a:rPr lang="en-US" sz="1100" dirty="0">
                 <a:solidFill>
                   <a:schemeClr val="tx1"/>
                 </a:solidFill>
               </a:rPr>
               <a:t>Lắp đặt hệ thống cấp, thoát nước công trình dân dụng và công nghiệp</a:t>
             </a:r>
-            <a:endParaRPr lang="en-US" sz="1000" dirty="0"/>
+            <a:endParaRPr lang="en-US" sz="1100" dirty="0"/>
           </a:p>
           <a:p>
             <a:pPr marL="152400" indent="-152400">
               <a:spcAft>
-                <a:spcPts val="500"/>
+                <a:spcPts val="900"/>
               </a:spcAft>
               <a:buSzPct val="100000"/>
               <a:buChar char="•"/>
             </a:pPr>
             <a:r>
-              <a:rPr lang="en-US" sz="1000" dirty="0">
+              <a:rPr lang="en-US" sz="1100" dirty="0">
                 <a:solidFill>
                   <a:schemeClr val="tx1"/>
                 </a:solidFill>
               </a:rPr>
               <a:t>Lắp đặt hệ thống đường ống công nghệ, hút sương dầu – lọc khí nhà xưởng</a:t>
             </a:r>
-            <a:endParaRPr lang="en-US" sz="1000" dirty="0"/>
+            <a:endParaRPr lang="en-US" sz="1100" dirty="0"/>
           </a:p>
           <a:p>
             <a:pPr marL="152400" indent="-152400">
               <a:spcAft>
-                <a:spcPts val="500"/>
+                <a:spcPts val="900"/>
               </a:spcAft>
               <a:buSzPct val="100000"/>
               <a:buChar char="•"/>
             </a:pPr>
             <a:r>
-              <a:rPr lang="en-US" sz="1000" dirty="0">
+              <a:rPr lang="en-US" sz="1100" dirty="0">
                 <a:solidFill>
                   <a:schemeClr val="tx1"/>
                 </a:solidFill>
               </a:rPr>
               <a:t>Lắp đặt máy móc, thiết bị công nghiệp: bơm, bồn lọc, thiết bị xử lý nước</a:t>
             </a:r>
-            <a:endParaRPr lang="en-US" sz="1000" dirty="0"/>
+            <a:endParaRPr lang="en-US" sz="1100" dirty="0"/>
           </a:p>
           <a:p>
             <a:pPr marL="152400" indent="-152400">
               <a:spcAft>
-                <a:spcPts val="500"/>
+                <a:spcPts val="900"/>
               </a:spcAft>
               <a:buSzPct val="100000"/>
               <a:buChar char="•"/>
             </a:pPr>
             <a:r>
-              <a:rPr lang="en-US" sz="1000" dirty="0">
+              <a:rPr lang="en-US" sz="1100" dirty="0">
                 <a:solidFill>
                   <a:schemeClr val="tx1"/>
                 </a:solidFill>
               </a:rPr>
               <a:t>Bảo trì, sửa chữa, cải tạo hệ thống kỹ thuật công trình</a:t>
             </a:r>
-            <a:endParaRPr lang="en-US" sz="1000" dirty="0"/>
+            <a:endParaRPr lang="en-US" sz="1100" dirty="0"/>
           </a:p>
         </p:txBody>
       </p:sp>

</xml_diff>

<commit_message>
Hồ sơ năng lực BLT: ghi đủ ngày tháng ở khối ký tên thư ngỏ
Co-Authored-By: Claude Opus 5.5 <noreply@anthropic.com>
Claude-Session: https://claude.ai/code/session_01SkwAuDP5YjDrv41kDvnzWb
</commit_message>
<xml_diff>
--- a/ho-so-nang-luc-BLT/HO_SO_NANG_LUC_BLT.pptx
+++ b/ho-so-nang-luc-BLT/HO_SO_NANG_LUC_BLT.pptx
@@ -132,14 +132,14 @@
   <p:extLst>
     <p:ext uri="{521415D9-36F7-43E2-AB2F-B90AF26B5E84}">
       <p14:sectionLst xmlns:p14="http://schemas.microsoft.com/office/powerpoint/2010/main">
-        <p14:section name="Mở đầu" id="{613efe4e-952f-3095-7e97-1634b52ef755}">
+        <p14:section name="Mở đầu" id="{419ec03f-f260-cf16-5d88-46e41138843f}">
           <p14:sldIdLst>
             <p14:sldId id="256"/>
             <p14:sldId id="257"/>
             <p14:sldId id="258"/>
           </p14:sldIdLst>
         </p14:section>
-        <p14:section name="01 Tổng quan" id="{8e56e4c9-61ee-49bc-4beb-dbbc7f943dc0}">
+        <p14:section name="01 Tổng quan" id="{d002e851-f30f-00dc-24d9-438d18ca9cea}">
           <p14:sldIdLst>
             <p14:sldId id="259"/>
             <p14:sldId id="260"/>
@@ -148,39 +148,39 @@
             <p14:sldId id="263"/>
           </p14:sldIdLst>
         </p14:section>
-        <p14:section name="02 Điện nước công trình" id="{37722329-1041-1cc5-0805-236916ab799a}">
+        <p14:section name="02 Điện nước công trình" id="{99e69f19-c0ca-71f0-f694-47a470348328}">
           <p14:sldIdLst>
             <p14:sldId id="264"/>
             <p14:sldId id="265"/>
             <p14:sldId id="266"/>
           </p14:sldIdLst>
         </p14:section>
-        <p14:section name="03 Hút sương dầu nhà xưởng" id="{015fb9f1-e532-bee4-d21c-4fd07488764a}">
+        <p14:section name="03 Hút sương dầu nhà xưởng" id="{36c424ea-5e63-1ea8-0593-a4f41ea623ea}">
           <p14:sldIdLst>
             <p14:sldId id="267"/>
             <p14:sldId id="268"/>
             <p14:sldId id="269"/>
           </p14:sldIdLst>
         </p14:section>
-        <p14:section name="04 Bơm &amp; xử lý nước" id="{c7c0d1fe-ceb6-af1f-f8fe-c1155bb0c9c6}">
+        <p14:section name="04 Bơm &amp; xử lý nước" id="{9cc694c4-0d90-1247-b717-b70bc2409ef4}">
           <p14:sldIdLst>
             <p14:sldId id="270"/>
           </p14:sldIdLst>
         </p14:section>
-        <p14:section name="05 Quản trị dự án" id="{d35e3d02-8705-7704-8ed6-3c0d7252a437}">
+        <p14:section name="05 Quản trị dự án" id="{f3c0da2a-10d8-1778-b8c6-d84e825d457d}">
           <p14:sldIdLst>
             <p14:sldId id="271"/>
             <p14:sldId id="272"/>
             <p14:sldId id="273"/>
           </p14:sldIdLst>
         </p14:section>
-        <p14:section name="06 Nguồn lực" id="{c9b8371a-35fa-09ca-2d58-84ecdaefe53d}">
+        <p14:section name="06 Nguồn lực" id="{4a67c860-a158-45d6-b6be-eef399dc1dcc}">
           <p14:sldIdLst>
             <p14:sldId id="274"/>
             <p14:sldId id="275"/>
           </p14:sldIdLst>
         </p14:section>
-        <p14:section name="07 Công trình tiêu biểu" id="{e053bfed-3ae1-1ffc-b22a-97aefd90ca60}">
+        <p14:section name="07 Công trình tiêu biểu" id="{4fab3385-d8d9-446d-c207-cbe945f0e5d9}">
           <p14:sldIdLst>
             <p14:sldId id="276"/>
             <p14:sldId id="277"/>
@@ -188,7 +188,7 @@
             <p14:sldId id="279"/>
           </p14:sldIdLst>
         </p14:section>
-        <p14:section name="08 Cam kết &amp; liên hệ" id="{7cf6ea2b-aedc-a59f-f229-fb5fc4930322}">
+        <p14:section name="08 Cam kết &amp; liên hệ" id="{ead55641-63a9-0b1a-0477-e5e0c0cae380}">
           <p14:sldIdLst>
             <p14:sldId id="280"/>
             <p14:sldId id="281"/>
@@ -29318,7 +29318,7 @@
                   <a:schemeClr val="accent3"/>
                 </a:solidFill>
               </a:rPr>
-              <a:t>Nghệ An, tháng 10 năm 2026</a:t>
+              <a:t>Nghệ An, ngày 10 tháng 10 năm 2026</a:t>
             </a:r>
             <a:endParaRPr lang="en-US" sz="1050" dirty="0"/>
           </a:p>

</xml_diff>

<commit_message>
Hồ sơ năng lực BLT: thêm Quảng Trị và 2 nhóm dịch vụ vào số liệu trang 5
Giữ nguyên thiết kế ô số liệu; 6 nhóm dịch vụ (thêm bảo trì, giá đỡ thép),
4 tỉnh thành (thêm Quảng Trị). Thư ngỏ thêm Quảng Trị, trang 8 đổi tiêu đề
thành Các nhóm giải pháp chính.

Co-Authored-By: Claude Opus 5.5 <noreply@anthropic.com>
Claude-Session: https://claude.ai/code/session_01SkwAuDP5YjDrv41kDvnzWb
</commit_message>
<xml_diff>
--- a/ho-so-nang-luc-BLT/HO_SO_NANG_LUC_BLT.pptx
+++ b/ho-so-nang-luc-BLT/HO_SO_NANG_LUC_BLT.pptx
@@ -132,14 +132,14 @@
   <p:extLst>
     <p:ext uri="{521415D9-36F7-43E2-AB2F-B90AF26B5E84}">
       <p14:sectionLst xmlns:p14="http://schemas.microsoft.com/office/powerpoint/2010/main">
-        <p14:section name="Mở đầu" id="{419ec03f-f260-cf16-5d88-46e41138843f}">
+        <p14:section name="Mở đầu" id="{a14ae725-637d-955e-2323-4c04a89fde60}">
           <p14:sldIdLst>
             <p14:sldId id="256"/>
             <p14:sldId id="257"/>
             <p14:sldId id="258"/>
           </p14:sldIdLst>
         </p14:section>
-        <p14:section name="01 Tổng quan" id="{d002e851-f30f-00dc-24d9-438d18ca9cea}">
+        <p14:section name="01 Tổng quan" id="{9d8464c7-83f6-8261-1fdf-d7c0cc37bbf6}">
           <p14:sldIdLst>
             <p14:sldId id="259"/>
             <p14:sldId id="260"/>
@@ -148,39 +148,39 @@
             <p14:sldId id="263"/>
           </p14:sldIdLst>
         </p14:section>
-        <p14:section name="02 Điện nước công trình" id="{99e69f19-c0ca-71f0-f694-47a470348328}">
+        <p14:section name="02 Điện nước công trình" id="{e03eb78f-b98f-55c8-77a5-70375bc8803e}">
           <p14:sldIdLst>
             <p14:sldId id="264"/>
             <p14:sldId id="265"/>
             <p14:sldId id="266"/>
           </p14:sldIdLst>
         </p14:section>
-        <p14:section name="03 Hút sương dầu nhà xưởng" id="{36c424ea-5e63-1ea8-0593-a4f41ea623ea}">
+        <p14:section name="03 Hút sương dầu nhà xưởng" id="{5061edfa-264d-0006-c5cb-f0a94aa36e97}">
           <p14:sldIdLst>
             <p14:sldId id="267"/>
             <p14:sldId id="268"/>
             <p14:sldId id="269"/>
           </p14:sldIdLst>
         </p14:section>
-        <p14:section name="04 Bơm &amp; xử lý nước" id="{9cc694c4-0d90-1247-b717-b70bc2409ef4}">
+        <p14:section name="04 Bơm &amp; xử lý nước" id="{1a4923f0-22fb-91e7-999a-8c8078be4a88}">
           <p14:sldIdLst>
             <p14:sldId id="270"/>
           </p14:sldIdLst>
         </p14:section>
-        <p14:section name="05 Quản trị dự án" id="{f3c0da2a-10d8-1778-b8c6-d84e825d457d}">
+        <p14:section name="05 Quản trị dự án" id="{f4075100-6fd8-f3f4-9ca6-d866e56f6d90}">
           <p14:sldIdLst>
             <p14:sldId id="271"/>
             <p14:sldId id="272"/>
             <p14:sldId id="273"/>
           </p14:sldIdLst>
         </p14:section>
-        <p14:section name="06 Nguồn lực" id="{4a67c860-a158-45d6-b6be-eef399dc1dcc}">
+        <p14:section name="06 Nguồn lực" id="{8dd10e50-6234-280e-4398-4b391869af30}">
           <p14:sldIdLst>
             <p14:sldId id="274"/>
             <p14:sldId id="275"/>
           </p14:sldIdLst>
         </p14:section>
-        <p14:section name="07 Công trình tiêu biểu" id="{4fab3385-d8d9-446d-c207-cbe945f0e5d9}">
+        <p14:section name="07 Công trình tiêu biểu" id="{4294c1b5-96d0-3a70-8007-0e0c9f2cb4ed}">
           <p14:sldIdLst>
             <p14:sldId id="276"/>
             <p14:sldId id="277"/>
@@ -188,7 +188,7 @@
             <p14:sldId id="279"/>
           </p14:sldIdLst>
         </p14:section>
-        <p14:section name="08 Cam kết &amp; liên hệ" id="{ead55641-63a9-0b1a-0477-e5e0c0cae380}">
+        <p14:section name="08 Cam kết &amp; liên hệ" id="{cf9b5c2e-8f32-63eb-e2ed-a6d93c2b7b50}">
           <p14:sldIdLst>
             <p14:sldId id="280"/>
             <p14:sldId id="281"/>
@@ -29222,7 +29222,7 @@
                   <a:schemeClr val="tx1"/>
                 </a:solidFill>
               </a:rPr>
-              <a:t>BLT là đơn vị thi công chuyên sâu về hệ thống kỹ thuật công trình: điện, cấp thoát nước, đường ống công nghệ, hút sương dầu – lọc khí nhà xưởng và bơm – xử lý nước. Đội ngũ 100 người của chúng tôi đang trực tiếp thi công tại Nghệ An, Ninh Bình và Thành phố Huế, từ công trình nhiều tầng đến nhà xưởng sản xuất đang vận hành.</a:t>
+              <a:t>BLT là đơn vị thi công chuyên sâu về hệ thống kỹ thuật công trình: điện, cấp thoát nước, đường ống công nghệ, hút sương dầu – lọc khí nhà xưởng và bơm – xử lý nước. Đội ngũ 100 người của chúng tôi đang trực tiếp thi công tại Nghệ An, Ninh Bình, Quảng Trị và Thành phố Huế, từ công trình nhiều tầng đến nhà xưởng sản xuất đang vận hành.</a:t>
             </a:r>
             <a:endParaRPr lang="en-US" sz="1150" dirty="0"/>
           </a:p>
@@ -29644,7 +29644,7 @@
                 <a:ea typeface="Arial" pitchFamily="34" charset="-122"/>
                 <a:cs typeface="Arial" pitchFamily="34" charset="-120"/>
               </a:rPr>
-              <a:t>4</a:t>
+              <a:t>6</a:t>
             </a:r>
             <a:endParaRPr lang="en-US" sz="3000" dirty="0"/>
           </a:p>
@@ -29716,7 +29716,7 @@
                   <a:schemeClr val="accent4"/>
                 </a:solidFill>
               </a:rPr>
-              <a:t>Điện • Nước • Hút sương dầu • Xử lý nước</a:t>
+              <a:t>Điện • Nước • Hút sương dầu • Xử lý nước • Bảo trì • Giá đỡ thép</a:t>
             </a:r>
             <a:endParaRPr lang="en-US" sz="800" dirty="0"/>
           </a:p>
@@ -29782,7 +29782,7 @@
                 <a:ea typeface="Arial" pitchFamily="34" charset="-122"/>
                 <a:cs typeface="Arial" pitchFamily="34" charset="-120"/>
               </a:rPr>
-              <a:t>3</a:t>
+              <a:t>4</a:t>
             </a:r>
             <a:endParaRPr lang="en-US" sz="3000" dirty="0"/>
           </a:p>
@@ -29854,7 +29854,7 @@
                   <a:schemeClr val="accent4"/>
                 </a:solidFill>
               </a:rPr>
-              <a:t>Nghệ An • Ninh Bình • Huế (2026)</a:t>
+              <a:t>Nghệ An • Ninh Bình • Quảng Trị • Huế</a:t>
             </a:r>
             <a:endParaRPr lang="en-US" sz="800" dirty="0"/>
           </a:p>
@@ -33587,7 +33587,7 @@
                   <a:schemeClr val="tx2"/>
                 </a:solidFill>
               </a:rPr>
-              <a:t>Bốn nhóm giải pháp của BLT</a:t>
+              <a:t>Các nhóm giải pháp chính của BLT</a:t>
             </a:r>
             <a:endParaRPr lang="en-US" sz="2200" dirty="0"/>
           </a:p>

</xml_diff>

<commit_message>
Hồ sơ năng lực BLT: thêm nhân viên văn phòng vào mô tả đội ngũ 100 nhân sự
Co-Authored-By: Claude Opus 5.5 <noreply@anthropic.com>
Claude-Session: https://claude.ai/code/session_01SkwAuDP5YjDrv41kDvnzWb
</commit_message>
<xml_diff>
--- a/ho-so-nang-luc-BLT/HO_SO_NANG_LUC_BLT.pptx
+++ b/ho-so-nang-luc-BLT/HO_SO_NANG_LUC_BLT.pptx
@@ -132,14 +132,14 @@
   <p:extLst>
     <p:ext uri="{521415D9-36F7-43E2-AB2F-B90AF26B5E84}">
       <p14:sectionLst xmlns:p14="http://schemas.microsoft.com/office/powerpoint/2010/main">
-        <p14:section name="Mở đầu" id="{a14ae725-637d-955e-2323-4c04a89fde60}">
+        <p14:section name="Mở đầu" id="{49d3efea-e39f-8db8-b7fb-1fb4f0945ccb}">
           <p14:sldIdLst>
             <p14:sldId id="256"/>
             <p14:sldId id="257"/>
             <p14:sldId id="258"/>
           </p14:sldIdLst>
         </p14:section>
-        <p14:section name="01 Tổng quan" id="{9d8464c7-83f6-8261-1fdf-d7c0cc37bbf6}">
+        <p14:section name="01 Tổng quan" id="{55141d92-9a00-bcde-2d00-510db23e9da0}">
           <p14:sldIdLst>
             <p14:sldId id="259"/>
             <p14:sldId id="260"/>
@@ -148,39 +148,39 @@
             <p14:sldId id="263"/>
           </p14:sldIdLst>
         </p14:section>
-        <p14:section name="02 Điện nước công trình" id="{e03eb78f-b98f-55c8-77a5-70375bc8803e}">
+        <p14:section name="02 Điện nước công trình" id="{48d0fbf7-4b20-aa3c-0a70-aa6c2fb48d5c}">
           <p14:sldIdLst>
             <p14:sldId id="264"/>
             <p14:sldId id="265"/>
             <p14:sldId id="266"/>
           </p14:sldIdLst>
         </p14:section>
-        <p14:section name="03 Hút sương dầu nhà xưởng" id="{5061edfa-264d-0006-c5cb-f0a94aa36e97}">
+        <p14:section name="03 Hút sương dầu nhà xưởng" id="{e37bf8aa-0b61-f4ea-63df-4e08b59c727a}">
           <p14:sldIdLst>
             <p14:sldId id="267"/>
             <p14:sldId id="268"/>
             <p14:sldId id="269"/>
           </p14:sldIdLst>
         </p14:section>
-        <p14:section name="04 Bơm &amp; xử lý nước" id="{1a4923f0-22fb-91e7-999a-8c8078be4a88}">
+        <p14:section name="04 Bơm &amp; xử lý nước" id="{f45ff8bc-c6b8-244c-10e3-6a5d68d938e8}">
           <p14:sldIdLst>
             <p14:sldId id="270"/>
           </p14:sldIdLst>
         </p14:section>
-        <p14:section name="05 Quản trị dự án" id="{f4075100-6fd8-f3f4-9ca6-d866e56f6d90}">
+        <p14:section name="05 Quản trị dự án" id="{f0982bf7-788c-b0f3-666f-ba8c429ea89c}">
           <p14:sldIdLst>
             <p14:sldId id="271"/>
             <p14:sldId id="272"/>
             <p14:sldId id="273"/>
           </p14:sldIdLst>
         </p14:section>
-        <p14:section name="06 Nguồn lực" id="{8dd10e50-6234-280e-4398-4b391869af30}">
+        <p14:section name="06 Nguồn lực" id="{074d94a4-5966-dfa0-9a23-7b142ef996c0}">
           <p14:sldIdLst>
             <p14:sldId id="274"/>
             <p14:sldId id="275"/>
           </p14:sldIdLst>
         </p14:section>
-        <p14:section name="07 Công trình tiêu biểu" id="{4294c1b5-96d0-3a70-8007-0e0c9f2cb4ed}">
+        <p14:section name="07 Công trình tiêu biểu" id="{29065056-0f03-b10e-89d4-d54219fefa3c}">
           <p14:sldIdLst>
             <p14:sldId id="276"/>
             <p14:sldId id="277"/>
@@ -188,7 +188,7 @@
             <p14:sldId id="279"/>
           </p14:sldIdLst>
         </p14:section>
-        <p14:section name="08 Cam kết &amp; liên hệ" id="{cf9b5c2e-8f32-63eb-e2ed-a6d93c2b7b50}">
+        <p14:section name="08 Cam kết &amp; liên hệ" id="{a4e55777-32d7-dd83-27b8-3d1364ee524a}">
           <p14:sldIdLst>
             <p14:sldId id="280"/>
             <p14:sldId id="281"/>
@@ -14433,7 +14433,7 @@
                   <a:schemeClr val="accent4"/>
                 </a:solidFill>
               </a:rPr>
-              <a:t>Cán bộ kỹ thuật, chỉ huy công trường và công nhân lành nghề</a:t>
+              <a:t>Kỹ thuật, văn phòng, chỉ huy công trường và công nhân lành nghề</a:t>
             </a:r>
             <a:endParaRPr lang="en-US" sz="950" dirty="0"/>
           </a:p>
@@ -15890,7 +15890,7 @@
                   <a:schemeClr val="tx1"/>
                 </a:solidFill>
               </a:rPr>
-              <a:t>Đội ngũ 100 người gồm cán bộ kỹ thuật, chỉ huy công trường và công nhân lành nghề, huy động linh hoạt theo tiến độ</a:t>
+              <a:t>Đội ngũ 100 người gồm cán bộ kỹ thuật, nhân viên văn phòng, chỉ huy công trường và công nhân lành nghề, huy động linh hoạt theo tiến độ</a:t>
             </a:r>
             <a:endParaRPr lang="en-US" sz="950" dirty="0"/>
           </a:p>
@@ -30130,7 +30130,7 @@
                   <a:schemeClr val="accent4"/>
                 </a:solidFill>
               </a:rPr>
-              <a:t>kỹ thuật, chỉ huy và công nhân thi công</a:t>
+              <a:t>Kỹ thuật, văn phòng, chỉ huy và công nhân thi công</a:t>
             </a:r>
             <a:endParaRPr lang="en-US" sz="800" dirty="0"/>
           </a:p>

</xml_diff>

<commit_message>
Hồ sơ năng lực BLT: bỏ bảo trì và giá đỡ thép khỏi ô nhóm dịch vụ (trang 5)
Co-Authored-By: Claude Opus 5.5 <noreply@anthropic.com>
Claude-Session: https://claude.ai/code/session_01SkwAuDP5YjDrv41kDvnzWb
</commit_message>
<xml_diff>
--- a/ho-so-nang-luc-BLT/HO_SO_NANG_LUC_BLT.pptx
+++ b/ho-so-nang-luc-BLT/HO_SO_NANG_LUC_BLT.pptx
@@ -132,14 +132,14 @@
   <p:extLst>
     <p:ext uri="{521415D9-36F7-43E2-AB2F-B90AF26B5E84}">
       <p14:sectionLst xmlns:p14="http://schemas.microsoft.com/office/powerpoint/2010/main">
-        <p14:section name="Mở đầu" id="{49d3efea-e39f-8db8-b7fb-1fb4f0945ccb}">
+        <p14:section name="Mở đầu" id="{b024d04c-1001-cf3a-94ba-9ecdfd9d355d}">
           <p14:sldIdLst>
             <p14:sldId id="256"/>
             <p14:sldId id="257"/>
             <p14:sldId id="258"/>
           </p14:sldIdLst>
         </p14:section>
-        <p14:section name="01 Tổng quan" id="{55141d92-9a00-bcde-2d00-510db23e9da0}">
+        <p14:section name="01 Tổng quan" id="{e04048cd-29dc-3872-111a-87449201e386}">
           <p14:sldIdLst>
             <p14:sldId id="259"/>
             <p14:sldId id="260"/>
@@ -148,39 +148,39 @@
             <p14:sldId id="263"/>
           </p14:sldIdLst>
         </p14:section>
-        <p14:section name="02 Điện nước công trình" id="{48d0fbf7-4b20-aa3c-0a70-aa6c2fb48d5c}">
+        <p14:section name="02 Điện nước công trình" id="{cc66ea0f-3a8f-9186-e201-8177935e29bf}">
           <p14:sldIdLst>
             <p14:sldId id="264"/>
             <p14:sldId id="265"/>
             <p14:sldId id="266"/>
           </p14:sldIdLst>
         </p14:section>
-        <p14:section name="03 Hút sương dầu nhà xưởng" id="{e37bf8aa-0b61-f4ea-63df-4e08b59c727a}">
+        <p14:section name="03 Hút sương dầu nhà xưởng" id="{ba469888-62da-063d-6a7f-c4ed23bbebd4}">
           <p14:sldIdLst>
             <p14:sldId id="267"/>
             <p14:sldId id="268"/>
             <p14:sldId id="269"/>
           </p14:sldIdLst>
         </p14:section>
-        <p14:section name="04 Bơm &amp; xử lý nước" id="{f45ff8bc-c6b8-244c-10e3-6a5d68d938e8}">
+        <p14:section name="04 Bơm &amp; xử lý nước" id="{0c72f5e8-a8e7-37ae-9ed2-d2b1555ceec0}">
           <p14:sldIdLst>
             <p14:sldId id="270"/>
           </p14:sldIdLst>
         </p14:section>
-        <p14:section name="05 Quản trị dự án" id="{f0982bf7-788c-b0f3-666f-ba8c429ea89c}">
+        <p14:section name="05 Quản trị dự án" id="{e39c6a82-5bd8-a22b-968a-56479ff8997f}">
           <p14:sldIdLst>
             <p14:sldId id="271"/>
             <p14:sldId id="272"/>
             <p14:sldId id="273"/>
           </p14:sldIdLst>
         </p14:section>
-        <p14:section name="06 Nguồn lực" id="{074d94a4-5966-dfa0-9a23-7b142ef996c0}">
+        <p14:section name="06 Nguồn lực" id="{2fe94f1e-4364-d7d7-cba9-24002a8d658e}">
           <p14:sldIdLst>
             <p14:sldId id="274"/>
             <p14:sldId id="275"/>
           </p14:sldIdLst>
         </p14:section>
-        <p14:section name="07 Công trình tiêu biểu" id="{29065056-0f03-b10e-89d4-d54219fefa3c}">
+        <p14:section name="07 Công trình tiêu biểu" id="{aa3d0dc7-a056-3393-9058-6df9c8d1fa09}">
           <p14:sldIdLst>
             <p14:sldId id="276"/>
             <p14:sldId id="277"/>
@@ -188,7 +188,7 @@
             <p14:sldId id="279"/>
           </p14:sldIdLst>
         </p14:section>
-        <p14:section name="08 Cam kết &amp; liên hệ" id="{a4e55777-32d7-dd83-27b8-3d1364ee524a}">
+        <p14:section name="08 Cam kết &amp; liên hệ" id="{5256fb0e-9f1d-b6e0-4a35-3f3eb7bcd6c0}">
           <p14:sldIdLst>
             <p14:sldId id="280"/>
             <p14:sldId id="281"/>
@@ -29644,7 +29644,7 @@
                 <a:ea typeface="Arial" pitchFamily="34" charset="-122"/>
                 <a:cs typeface="Arial" pitchFamily="34" charset="-120"/>
               </a:rPr>
-              <a:t>6</a:t>
+              <a:t>4</a:t>
             </a:r>
             <a:endParaRPr lang="en-US" sz="3000" dirty="0"/>
           </a:p>
@@ -29716,7 +29716,7 @@
                   <a:schemeClr val="accent4"/>
                 </a:solidFill>
               </a:rPr>
-              <a:t>Điện • Nước • Hút sương dầu • Xử lý nước • Bảo trì • Giá đỡ thép</a:t>
+              <a:t>Điện • Nước • Hút sương dầu • Xử lý nước</a:t>
             </a:r>
             <a:endParaRPr lang="en-US" sz="800" dirty="0"/>
           </a:p>

</xml_diff>

<commit_message>
Hồ sơ năng lực BLT: bỏ dòng tên viết tắt và loại hình ở trang pháp lý
Co-Authored-By: Claude Opus 5.5 <noreply@anthropic.com>
Claude-Session: https://claude.ai/code/session_01SkwAuDP5YjDrv41kDvnzWb
</commit_message>
<xml_diff>
--- a/ho-so-nang-luc-BLT/HO_SO_NANG_LUC_BLT.pptx
+++ b/ho-so-nang-luc-BLT/HO_SO_NANG_LUC_BLT.pptx
@@ -132,14 +132,14 @@
   <p:extLst>
     <p:ext uri="{521415D9-36F7-43E2-AB2F-B90AF26B5E84}">
       <p14:sectionLst xmlns:p14="http://schemas.microsoft.com/office/powerpoint/2010/main">
-        <p14:section name="Mở đầu" id="{b024d04c-1001-cf3a-94ba-9ecdfd9d355d}">
+        <p14:section name="Mở đầu" id="{73e069b9-7186-cedc-00fa-c2c4cf52167f}">
           <p14:sldIdLst>
             <p14:sldId id="256"/>
             <p14:sldId id="257"/>
             <p14:sldId id="258"/>
           </p14:sldIdLst>
         </p14:section>
-        <p14:section name="01 Tổng quan" id="{e04048cd-29dc-3872-111a-87449201e386}">
+        <p14:section name="01 Tổng quan" id="{3dbca801-b882-81d2-05d8-db0120258c1d}">
           <p14:sldIdLst>
             <p14:sldId id="259"/>
             <p14:sldId id="260"/>
@@ -148,39 +148,39 @@
             <p14:sldId id="263"/>
           </p14:sldIdLst>
         </p14:section>
-        <p14:section name="02 Điện nước công trình" id="{cc66ea0f-3a8f-9186-e201-8177935e29bf}">
+        <p14:section name="02 Điện nước công trình" id="{ca14664f-04af-4663-510e-87e493af5436}">
           <p14:sldIdLst>
             <p14:sldId id="264"/>
             <p14:sldId id="265"/>
             <p14:sldId id="266"/>
           </p14:sldIdLst>
         </p14:section>
-        <p14:section name="03 Hút sương dầu nhà xưởng" id="{ba469888-62da-063d-6a7f-c4ed23bbebd4}">
+        <p14:section name="03 Hút sương dầu nhà xưởng" id="{3b69e163-4e76-3124-b2ec-6ad30335e34e}">
           <p14:sldIdLst>
             <p14:sldId id="267"/>
             <p14:sldId id="268"/>
             <p14:sldId id="269"/>
           </p14:sldIdLst>
         </p14:section>
-        <p14:section name="04 Bơm &amp; xử lý nước" id="{0c72f5e8-a8e7-37ae-9ed2-d2b1555ceec0}">
+        <p14:section name="04 Bơm &amp; xử lý nước" id="{ba7d8ca2-922c-9ef4-34e9-1e06e1251d98}">
           <p14:sldIdLst>
             <p14:sldId id="270"/>
           </p14:sldIdLst>
         </p14:section>
-        <p14:section name="05 Quản trị dự án" id="{e39c6a82-5bd8-a22b-968a-56479ff8997f}">
+        <p14:section name="05 Quản trị dự án" id="{03e10926-1504-8d2b-0466-449131ceca12}">
           <p14:sldIdLst>
             <p14:sldId id="271"/>
             <p14:sldId id="272"/>
             <p14:sldId id="273"/>
           </p14:sldIdLst>
         </p14:section>
-        <p14:section name="06 Nguồn lực" id="{2fe94f1e-4364-d7d7-cba9-24002a8d658e}">
+        <p14:section name="06 Nguồn lực" id="{8cc68f40-b78a-d0d4-7915-05151147c1f7}">
           <p14:sldIdLst>
             <p14:sldId id="274"/>
             <p14:sldId id="275"/>
           </p14:sldIdLst>
         </p14:section>
-        <p14:section name="07 Công trình tiêu biểu" id="{aa3d0dc7-a056-3393-9058-6df9c8d1fa09}">
+        <p14:section name="07 Công trình tiêu biểu" id="{c3b1f5d6-8160-209f-34f2-70e9612192b1}">
           <p14:sldIdLst>
             <p14:sldId id="276"/>
             <p14:sldId id="277"/>
@@ -188,7 +188,7 @@
             <p14:sldId id="279"/>
           </p14:sldIdLst>
         </p14:section>
-        <p14:section name="08 Cam kết &amp; liên hệ" id="{5256fb0e-9f1d-b6e0-4a35-3f3eb7bcd6c0}">
+        <p14:section name="08 Cam kết &amp; liên hệ" id="{f0b14318-3242-a4e5-04ce-8917b4bab8b7}">
           <p14:sldIdLst>
             <p14:sldId id="280"/>
             <p14:sldId id="281"/>
@@ -30699,7 +30699,7 @@
                 <a:gridCol w="2194560"/>
                 <a:gridCol w="4361688"/>
               </a:tblGrid>
-              <a:tr h="548640">
+              <a:tr h="640080">
                 <a:tc>
                   <a:txBody>
                     <a:bodyPr/>
@@ -30820,128 +30820,7 @@
                   </a:tcPr>
                 </a:tc>
               </a:tr>
-              <a:tr h="548640">
-                <a:tc>
-                  <a:txBody>
-                    <a:bodyPr/>
-                    <a:lstStyle/>
-                    <a:p>
-                      <a:pPr indent="0" marL="0">
-                        <a:buNone/>
-                      </a:pPr>
-                      <a:r>
-                        <a:rPr lang="en-US" sz="1050" b="1" dirty="0">
-                          <a:solidFill>
-                            <a:schemeClr val="tx2"/>
-                          </a:solidFill>
-                        </a:rPr>
-                        <a:t>Tên viết tắt</a:t>
-                      </a:r>
-                      <a:endParaRPr lang="en-US" sz="1050" dirty="0"/>
-                    </a:p>
-                  </a:txBody>
-                  <a:tcPr marL="109728" marR="109728" marT="64008" marB="64008" anchor="ctr">
-                    <a:lnL w="9525" cap="flat" cmpd="sng" algn="ctr">
-                      <a:solidFill>
-                        <a:srgbClr val="C9D5E3"/>
-                      </a:solidFill>
-                      <a:prstDash val="solid"/>
-                      <a:round/>
-                      <a:headEnd type="none" w="med" len="med"/>
-                      <a:tailEnd type="none" w="med" len="med"/>
-                    </a:lnL>
-                    <a:lnR w="9525" cap="flat" cmpd="sng" algn="ctr">
-                      <a:solidFill>
-                        <a:srgbClr val="C9D5E3"/>
-                      </a:solidFill>
-                      <a:prstDash val="solid"/>
-                      <a:round/>
-                      <a:headEnd type="none" w="med" len="med"/>
-                      <a:tailEnd type="none" w="med" len="med"/>
-                    </a:lnR>
-                    <a:lnT w="9525" cap="flat" cmpd="sng" algn="ctr">
-                      <a:solidFill>
-                        <a:srgbClr val="C9D5E3"/>
-                      </a:solidFill>
-                      <a:prstDash val="solid"/>
-                      <a:round/>
-                      <a:headEnd type="none" w="med" len="med"/>
-                      <a:tailEnd type="none" w="med" len="med"/>
-                    </a:lnT>
-                    <a:lnB w="9525" cap="flat" cmpd="sng" algn="ctr">
-                      <a:solidFill>
-                        <a:srgbClr val="C9D5E3"/>
-                      </a:solidFill>
-                      <a:prstDash val="solid"/>
-                      <a:round/>
-                      <a:headEnd type="none" w="med" len="med"/>
-                      <a:tailEnd type="none" w="med" len="med"/>
-                    </a:lnB>
-                    <a:solidFill>
-                      <a:schemeClr val="bg2"/>
-                    </a:solidFill>
-                  </a:tcPr>
-                </a:tc>
-                <a:tc>
-                  <a:txBody>
-                    <a:bodyPr/>
-                    <a:lstStyle/>
-                    <a:p>
-                      <a:pPr indent="0" marL="0">
-                        <a:buNone/>
-                      </a:pPr>
-                      <a:r>
-                        <a:rPr lang="en-US" sz="1050" dirty="0">
-                          <a:solidFill>
-                            <a:schemeClr val="tx1"/>
-                          </a:solidFill>
-                        </a:rPr>
-                        <a:t>BLT  (nhận diện: BLT Điện Nước)</a:t>
-                      </a:r>
-                      <a:endParaRPr lang="en-US" sz="1050" dirty="0"/>
-                    </a:p>
-                  </a:txBody>
-                  <a:tcPr marL="109728" marR="109728" marT="64008" marB="64008" anchor="ctr">
-                    <a:lnL w="9525" cap="flat" cmpd="sng" algn="ctr">
-                      <a:solidFill>
-                        <a:srgbClr val="C9D5E3"/>
-                      </a:solidFill>
-                      <a:prstDash val="solid"/>
-                      <a:round/>
-                      <a:headEnd type="none" w="med" len="med"/>
-                      <a:tailEnd type="none" w="med" len="med"/>
-                    </a:lnL>
-                    <a:lnR w="9525" cap="flat" cmpd="sng" algn="ctr">
-                      <a:solidFill>
-                        <a:srgbClr val="C9D5E3"/>
-                      </a:solidFill>
-                      <a:prstDash val="solid"/>
-                      <a:round/>
-                      <a:headEnd type="none" w="med" len="med"/>
-                      <a:tailEnd type="none" w="med" len="med"/>
-                    </a:lnR>
-                    <a:lnT w="9525" cap="flat" cmpd="sng" algn="ctr">
-                      <a:solidFill>
-                        <a:srgbClr val="C9D5E3"/>
-                      </a:solidFill>
-                      <a:prstDash val="solid"/>
-                      <a:round/>
-                      <a:headEnd type="none" w="med" len="med"/>
-                      <a:tailEnd type="none" w="med" len="med"/>
-                    </a:lnT>
-                    <a:lnB w="9525" cap="flat" cmpd="sng" algn="ctr">
-                      <a:solidFill>
-                        <a:srgbClr val="C9D5E3"/>
-                      </a:solidFill>
-                      <a:prstDash val="solid"/>
-                      <a:round/>
-                      <a:headEnd type="none" w="med" len="med"/>
-                      <a:tailEnd type="none" w="med" len="med"/>
-                    </a:lnB>
-                  </a:tcPr>
-                </a:tc>
-              </a:tr>
-              <a:tr h="548640">
+              <a:tr h="640080">
                 <a:tc>
                   <a:txBody>
                     <a:bodyPr/>
@@ -31062,128 +30941,7 @@
                   </a:tcPr>
                 </a:tc>
               </a:tr>
-              <a:tr h="548640">
-                <a:tc>
-                  <a:txBody>
-                    <a:bodyPr/>
-                    <a:lstStyle/>
-                    <a:p>
-                      <a:pPr indent="0" marL="0">
-                        <a:buNone/>
-                      </a:pPr>
-                      <a:r>
-                        <a:rPr lang="en-US" sz="1050" b="1" dirty="0">
-                          <a:solidFill>
-                            <a:schemeClr val="tx2"/>
-                          </a:solidFill>
-                        </a:rPr>
-                        <a:t>Loại hình</a:t>
-                      </a:r>
-                      <a:endParaRPr lang="en-US" sz="1050" dirty="0"/>
-                    </a:p>
-                  </a:txBody>
-                  <a:tcPr marL="109728" marR="109728" marT="64008" marB="64008" anchor="ctr">
-                    <a:lnL w="9525" cap="flat" cmpd="sng" algn="ctr">
-                      <a:solidFill>
-                        <a:srgbClr val="C9D5E3"/>
-                      </a:solidFill>
-                      <a:prstDash val="solid"/>
-                      <a:round/>
-                      <a:headEnd type="none" w="med" len="med"/>
-                      <a:tailEnd type="none" w="med" len="med"/>
-                    </a:lnL>
-                    <a:lnR w="9525" cap="flat" cmpd="sng" algn="ctr">
-                      <a:solidFill>
-                        <a:srgbClr val="C9D5E3"/>
-                      </a:solidFill>
-                      <a:prstDash val="solid"/>
-                      <a:round/>
-                      <a:headEnd type="none" w="med" len="med"/>
-                      <a:tailEnd type="none" w="med" len="med"/>
-                    </a:lnR>
-                    <a:lnT w="9525" cap="flat" cmpd="sng" algn="ctr">
-                      <a:solidFill>
-                        <a:srgbClr val="C9D5E3"/>
-                      </a:solidFill>
-                      <a:prstDash val="solid"/>
-                      <a:round/>
-                      <a:headEnd type="none" w="med" len="med"/>
-                      <a:tailEnd type="none" w="med" len="med"/>
-                    </a:lnT>
-                    <a:lnB w="9525" cap="flat" cmpd="sng" algn="ctr">
-                      <a:solidFill>
-                        <a:srgbClr val="C9D5E3"/>
-                      </a:solidFill>
-                      <a:prstDash val="solid"/>
-                      <a:round/>
-                      <a:headEnd type="none" w="med" len="med"/>
-                      <a:tailEnd type="none" w="med" len="med"/>
-                    </a:lnB>
-                    <a:solidFill>
-                      <a:schemeClr val="bg2"/>
-                    </a:solidFill>
-                  </a:tcPr>
-                </a:tc>
-                <a:tc>
-                  <a:txBody>
-                    <a:bodyPr/>
-                    <a:lstStyle/>
-                    <a:p>
-                      <a:pPr indent="0" marL="0">
-                        <a:buNone/>
-                      </a:pPr>
-                      <a:r>
-                        <a:rPr lang="en-US" sz="1050" dirty="0">
-                          <a:solidFill>
-                            <a:schemeClr val="tx1"/>
-                          </a:solidFill>
-                        </a:rPr>
-                        <a:t>Công ty trách nhiệm hữu hạn</a:t>
-                      </a:r>
-                      <a:endParaRPr lang="en-US" sz="1050" dirty="0"/>
-                    </a:p>
-                  </a:txBody>
-                  <a:tcPr marL="109728" marR="109728" marT="64008" marB="64008" anchor="ctr">
-                    <a:lnL w="9525" cap="flat" cmpd="sng" algn="ctr">
-                      <a:solidFill>
-                        <a:srgbClr val="C9D5E3"/>
-                      </a:solidFill>
-                      <a:prstDash val="solid"/>
-                      <a:round/>
-                      <a:headEnd type="none" w="med" len="med"/>
-                      <a:tailEnd type="none" w="med" len="med"/>
-                    </a:lnL>
-                    <a:lnR w="9525" cap="flat" cmpd="sng" algn="ctr">
-                      <a:solidFill>
-                        <a:srgbClr val="C9D5E3"/>
-                      </a:solidFill>
-                      <a:prstDash val="solid"/>
-                      <a:round/>
-                      <a:headEnd type="none" w="med" len="med"/>
-                      <a:tailEnd type="none" w="med" len="med"/>
-                    </a:lnR>
-                    <a:lnT w="9525" cap="flat" cmpd="sng" algn="ctr">
-                      <a:solidFill>
-                        <a:srgbClr val="C9D5E3"/>
-                      </a:solidFill>
-                      <a:prstDash val="solid"/>
-                      <a:round/>
-                      <a:headEnd type="none" w="med" len="med"/>
-                      <a:tailEnd type="none" w="med" len="med"/>
-                    </a:lnT>
-                    <a:lnB w="9525" cap="flat" cmpd="sng" algn="ctr">
-                      <a:solidFill>
-                        <a:srgbClr val="C9D5E3"/>
-                      </a:solidFill>
-                      <a:prstDash val="solid"/>
-                      <a:round/>
-                      <a:headEnd type="none" w="med" len="med"/>
-                      <a:tailEnd type="none" w="med" len="med"/>
-                    </a:lnB>
-                  </a:tcPr>
-                </a:tc>
-              </a:tr>
-              <a:tr h="548640">
+              <a:tr h="640080">
                 <a:tc>
                   <a:txBody>
                     <a:bodyPr/>
@@ -31304,7 +31062,7 @@
                   </a:tcPr>
                 </a:tc>
               </a:tr>
-              <a:tr h="548640">
+              <a:tr h="640080">
                 <a:tc>
                   <a:txBody>
                     <a:bodyPr/>
@@ -31425,7 +31183,7 @@
                   </a:tcPr>
                 </a:tc>
               </a:tr>
-              <a:tr h="548640">
+              <a:tr h="640080">
                 <a:tc>
                   <a:txBody>
                     <a:bodyPr/>
@@ -31546,7 +31304,7 @@
                   </a:tcPr>
                 </a:tc>
               </a:tr>
-              <a:tr h="548640">
+              <a:tr h="640080">
                 <a:tc>
                   <a:txBody>
                     <a:bodyPr/>
@@ -31667,7 +31425,7 @@
                   </a:tcPr>
                 </a:tc>
               </a:tr>
-              <a:tr h="548640">
+              <a:tr h="640080">
                 <a:tc>
                   <a:txBody>
                     <a:bodyPr/>
@@ -31800,7 +31558,7 @@
         </p:nvSpPr>
         <p:spPr>
           <a:xfrm>
-            <a:off x="502920" y="6949440"/>
+            <a:off x="502920" y="6446520"/>
             <a:ext cx="6556248" cy="228600"/>
           </a:xfrm>
           <a:prstGeom prst="rect">
@@ -31839,12 +31597,12 @@
         </p:nvSpPr>
         <p:spPr>
           <a:xfrm>
-            <a:off x="502920" y="7223760"/>
-            <a:ext cx="6556248" cy="2377440"/>
+            <a:off x="502920" y="6720840"/>
+            <a:ext cx="6556248" cy="2880360"/>
           </a:xfrm>
           <a:prstGeom prst="roundRect">
             <a:avLst>
-              <a:gd name="adj" fmla="val 3077"/>
+              <a:gd name="adj" fmla="val 2540"/>
             </a:avLst>
           </a:prstGeom>
           <a:solidFill>
@@ -31866,8 +31624,8 @@
         </p:nvSpPr>
         <p:spPr>
           <a:xfrm>
-            <a:off x="777240" y="7406640"/>
-            <a:ext cx="6007608" cy="2057400"/>
+            <a:off x="777240" y="6903720"/>
+            <a:ext cx="6007608" cy="2514600"/>
           </a:xfrm>
           <a:prstGeom prst="rect">
             <a:avLst/>
@@ -31880,6 +31638,9 @@
           <a:lstStyle/>
           <a:p>
             <a:pPr marL="152400" indent="-152400">
+              <a:lnSpc>
+                <a:spcPct val="170000"/>
+              </a:lnSpc>
               <a:spcAft>
                 <a:spcPts val="900"/>
               </a:spcAft>
@@ -31887,17 +31648,20 @@
               <a:buChar char="•"/>
             </a:pPr>
             <a:r>
-              <a:rPr lang="en-US" sz="1100" dirty="0">
+              <a:rPr lang="en-US" sz="1150" dirty="0">
                 <a:solidFill>
                   <a:schemeClr val="tx1"/>
                 </a:solidFill>
               </a:rPr>
               <a:t>Lắp đặt hệ thống điện động lực, điện chiếu sáng, tủ điện, máng – thang cáp</a:t>
             </a:r>
-            <a:endParaRPr lang="en-US" sz="1100" dirty="0"/>
+            <a:endParaRPr lang="en-US" sz="1150" dirty="0"/>
           </a:p>
           <a:p>
             <a:pPr marL="152400" indent="-152400">
+              <a:lnSpc>
+                <a:spcPct val="170000"/>
+              </a:lnSpc>
               <a:spcAft>
                 <a:spcPts val="900"/>
               </a:spcAft>
@@ -31905,17 +31669,20 @@
               <a:buChar char="•"/>
             </a:pPr>
             <a:r>
-              <a:rPr lang="en-US" sz="1100" dirty="0">
+              <a:rPr lang="en-US" sz="1150" dirty="0">
                 <a:solidFill>
                   <a:schemeClr val="tx1"/>
                 </a:solidFill>
               </a:rPr>
               <a:t>Lắp đặt hệ thống cấp, thoát nước công trình dân dụng và công nghiệp</a:t>
             </a:r>
-            <a:endParaRPr lang="en-US" sz="1100" dirty="0"/>
+            <a:endParaRPr lang="en-US" sz="1150" dirty="0"/>
           </a:p>
           <a:p>
             <a:pPr marL="152400" indent="-152400">
+              <a:lnSpc>
+                <a:spcPct val="170000"/>
+              </a:lnSpc>
               <a:spcAft>
                 <a:spcPts val="900"/>
               </a:spcAft>
@@ -31923,17 +31690,20 @@
               <a:buChar char="•"/>
             </a:pPr>
             <a:r>
-              <a:rPr lang="en-US" sz="1100" dirty="0">
+              <a:rPr lang="en-US" sz="1150" dirty="0">
                 <a:solidFill>
                   <a:schemeClr val="tx1"/>
                 </a:solidFill>
               </a:rPr>
               <a:t>Lắp đặt hệ thống đường ống công nghệ, hút sương dầu – lọc khí nhà xưởng</a:t>
             </a:r>
-            <a:endParaRPr lang="en-US" sz="1100" dirty="0"/>
+            <a:endParaRPr lang="en-US" sz="1150" dirty="0"/>
           </a:p>
           <a:p>
             <a:pPr marL="152400" indent="-152400">
+              <a:lnSpc>
+                <a:spcPct val="170000"/>
+              </a:lnSpc>
               <a:spcAft>
                 <a:spcPts val="900"/>
               </a:spcAft>
@@ -31941,17 +31711,20 @@
               <a:buChar char="•"/>
             </a:pPr>
             <a:r>
-              <a:rPr lang="en-US" sz="1100" dirty="0">
+              <a:rPr lang="en-US" sz="1150" dirty="0">
                 <a:solidFill>
                   <a:schemeClr val="tx1"/>
                 </a:solidFill>
               </a:rPr>
               <a:t>Lắp đặt máy móc, thiết bị công nghiệp: bơm, bồn lọc, thiết bị xử lý nước</a:t>
             </a:r>
-            <a:endParaRPr lang="en-US" sz="1100" dirty="0"/>
+            <a:endParaRPr lang="en-US" sz="1150" dirty="0"/>
           </a:p>
           <a:p>
             <a:pPr marL="152400" indent="-152400">
+              <a:lnSpc>
+                <a:spcPct val="170000"/>
+              </a:lnSpc>
               <a:spcAft>
                 <a:spcPts val="900"/>
               </a:spcAft>
@@ -31959,14 +31732,14 @@
               <a:buChar char="•"/>
             </a:pPr>
             <a:r>
-              <a:rPr lang="en-US" sz="1100" dirty="0">
+              <a:rPr lang="en-US" sz="1150" dirty="0">
                 <a:solidFill>
                   <a:schemeClr val="tx1"/>
                 </a:solidFill>
               </a:rPr>
               <a:t>Bảo trì, sửa chữa, cải tạo hệ thống kỹ thuật công trình</a:t>
             </a:r>
-            <a:endParaRPr lang="en-US" sz="1100" dirty="0"/>
+            <a:endParaRPr lang="en-US" sz="1150" dirty="0"/>
           </a:p>
         </p:txBody>
       </p:sp>

</xml_diff>

<commit_message>
Hồ sơ năng lực BLT: chuyển logo trang liên hệ sang góc trên bên trái
Ảnh đội thi công phía sau hiện rõ hơn (giảm lớp phủ màu).

Co-Authored-By: Claude Opus 5.5 <noreply@anthropic.com>
Claude-Session: https://claude.ai/code/session_01SkwAuDP5YjDrv41kDvnzWb
</commit_message>
<xml_diff>
--- a/ho-so-nang-luc-BLT/HO_SO_NANG_LUC_BLT.pptx
+++ b/ho-so-nang-luc-BLT/HO_SO_NANG_LUC_BLT.pptx
@@ -132,14 +132,14 @@
   <p:extLst>
     <p:ext uri="{521415D9-36F7-43E2-AB2F-B90AF26B5E84}">
       <p14:sectionLst xmlns:p14="http://schemas.microsoft.com/office/powerpoint/2010/main">
-        <p14:section name="Mở đầu" id="{73e069b9-7186-cedc-00fa-c2c4cf52167f}">
+        <p14:section name="Mở đầu" id="{34839d0d-c6cf-26c3-0cf6-7d07be8038b1}">
           <p14:sldIdLst>
             <p14:sldId id="256"/>
             <p14:sldId id="257"/>
             <p14:sldId id="258"/>
           </p14:sldIdLst>
         </p14:section>
-        <p14:section name="01 Tổng quan" id="{3dbca801-b882-81d2-05d8-db0120258c1d}">
+        <p14:section name="01 Tổng quan" id="{96ec9d0a-8ea1-b24c-bd48-0587e9339bc0}">
           <p14:sldIdLst>
             <p14:sldId id="259"/>
             <p14:sldId id="260"/>
@@ -148,39 +148,39 @@
             <p14:sldId id="263"/>
           </p14:sldIdLst>
         </p14:section>
-        <p14:section name="02 Điện nước công trình" id="{ca14664f-04af-4663-510e-87e493af5436}">
+        <p14:section name="02 Điện nước công trình" id="{e5f81399-cf4e-5c99-95ff-ed097f453cd4}">
           <p14:sldIdLst>
             <p14:sldId id="264"/>
             <p14:sldId id="265"/>
             <p14:sldId id="266"/>
           </p14:sldIdLst>
         </p14:section>
-        <p14:section name="03 Hút sương dầu nhà xưởng" id="{3b69e163-4e76-3124-b2ec-6ad30335e34e}">
+        <p14:section name="03 Hút sương dầu nhà xưởng" id="{d5618fc6-635b-5c2e-622f-b942baba916e}">
           <p14:sldIdLst>
             <p14:sldId id="267"/>
             <p14:sldId id="268"/>
             <p14:sldId id="269"/>
           </p14:sldIdLst>
         </p14:section>
-        <p14:section name="04 Bơm &amp; xử lý nước" id="{ba7d8ca2-922c-9ef4-34e9-1e06e1251d98}">
+        <p14:section name="04 Bơm &amp; xử lý nước" id="{c78bf755-77b4-a6e2-f16f-95a605174a31}">
           <p14:sldIdLst>
             <p14:sldId id="270"/>
           </p14:sldIdLst>
         </p14:section>
-        <p14:section name="05 Quản trị dự án" id="{03e10926-1504-8d2b-0466-449131ceca12}">
+        <p14:section name="05 Quản trị dự án" id="{ba79b9b3-4d5c-9412-e8d1-34a590a5f19d}">
           <p14:sldIdLst>
             <p14:sldId id="271"/>
             <p14:sldId id="272"/>
             <p14:sldId id="273"/>
           </p14:sldIdLst>
         </p14:section>
-        <p14:section name="06 Nguồn lực" id="{8cc68f40-b78a-d0d4-7915-05151147c1f7}">
+        <p14:section name="06 Nguồn lực" id="{63c1fc0b-c402-4f50-c844-16ac448c2c03}">
           <p14:sldIdLst>
             <p14:sldId id="274"/>
             <p14:sldId id="275"/>
           </p14:sldIdLst>
         </p14:section>
-        <p14:section name="07 Công trình tiêu biểu" id="{c3b1f5d6-8160-209f-34f2-70e9612192b1}">
+        <p14:section name="07 Công trình tiêu biểu" id="{90020c5c-f2e6-0fcf-af24-239c173347bd}">
           <p14:sldIdLst>
             <p14:sldId id="276"/>
             <p14:sldId id="277"/>
@@ -188,7 +188,7 @@
             <p14:sldId id="279"/>
           </p14:sldIdLst>
         </p14:section>
-        <p14:section name="08 Cam kết &amp; liên hệ" id="{f0b14318-3242-a4e5-04ce-8917b4bab8b7}">
+        <p14:section name="08 Cam kết &amp; liên hệ" id="{338a00be-480a-45c4-acd8-264fe094cda3}">
           <p14:sldIdLst>
             <p14:sldId id="280"/>
             <p14:sldId id="281"/>
@@ -26527,7 +26527,7 @@
           </a:prstGeom>
           <a:solidFill>
             <a:schemeClr val="tx2">
-              <a:alpha val="60000"/>
+              <a:alpha val="30000"/>
             </a:schemeClr>
           </a:solidFill>
           <a:ln w="12700">
@@ -26556,8 +26556,8 @@
         </p:blipFill>
         <p:spPr>
           <a:xfrm>
-            <a:off x="2775204" y="1097280"/>
-            <a:ext cx="2011680" cy="2011680"/>
+            <a:off x="502920" y="411480"/>
+            <a:ext cx="1280160" cy="1280160"/>
           </a:xfrm>
           <a:prstGeom prst="rect">
             <a:avLst/>

</xml_diff>

<commit_message>
Hồ sơ năng lực BLT: chèn chữ ký và con dấu Giám đốc vào thư ngỏ
Co-Authored-By: Claude Opus 5.5 <noreply@anthropic.com>
Claude-Session: https://claude.ai/code/session_01SkwAuDP5YjDrv41kDvnzWb
</commit_message>
<xml_diff>
--- a/ho-so-nang-luc-BLT/HO_SO_NANG_LUC_BLT.pptx
+++ b/ho-so-nang-luc-BLT/HO_SO_NANG_LUC_BLT.pptx
@@ -132,14 +132,14 @@
   <p:extLst>
     <p:ext uri="{521415D9-36F7-43E2-AB2F-B90AF26B5E84}">
       <p14:sectionLst xmlns:p14="http://schemas.microsoft.com/office/powerpoint/2010/main">
-        <p14:section name="Mở đầu" id="{34839d0d-c6cf-26c3-0cf6-7d07be8038b1}">
+        <p14:section name="Mở đầu" id="{479003c4-6f34-bf96-3845-18663b46f229}">
           <p14:sldIdLst>
             <p14:sldId id="256"/>
             <p14:sldId id="257"/>
             <p14:sldId id="258"/>
           </p14:sldIdLst>
         </p14:section>
-        <p14:section name="01 Tổng quan" id="{96ec9d0a-8ea1-b24c-bd48-0587e9339bc0}">
+        <p14:section name="01 Tổng quan" id="{0a1c5c49-7dde-9613-b806-8930a260762e}">
           <p14:sldIdLst>
             <p14:sldId id="259"/>
             <p14:sldId id="260"/>
@@ -148,39 +148,39 @@
             <p14:sldId id="263"/>
           </p14:sldIdLst>
         </p14:section>
-        <p14:section name="02 Điện nước công trình" id="{e5f81399-cf4e-5c99-95ff-ed097f453cd4}">
+        <p14:section name="02 Điện nước công trình" id="{a85db3c8-26cb-56c7-e8b8-42e85fd841fb}">
           <p14:sldIdLst>
             <p14:sldId id="264"/>
             <p14:sldId id="265"/>
             <p14:sldId id="266"/>
           </p14:sldIdLst>
         </p14:section>
-        <p14:section name="03 Hút sương dầu nhà xưởng" id="{d5618fc6-635b-5c2e-622f-b942baba916e}">
+        <p14:section name="03 Hút sương dầu nhà xưởng" id="{9f1c3610-f719-a2f1-7a3a-fa089ccb5997}">
           <p14:sldIdLst>
             <p14:sldId id="267"/>
             <p14:sldId id="268"/>
             <p14:sldId id="269"/>
           </p14:sldIdLst>
         </p14:section>
-        <p14:section name="04 Bơm &amp; xử lý nước" id="{c78bf755-77b4-a6e2-f16f-95a605174a31}">
+        <p14:section name="04 Bơm &amp; xử lý nước" id="{6fdd7731-8046-e20f-c1c0-7a0ee682e0e1}">
           <p14:sldIdLst>
             <p14:sldId id="270"/>
           </p14:sldIdLst>
         </p14:section>
-        <p14:section name="05 Quản trị dự án" id="{ba79b9b3-4d5c-9412-e8d1-34a590a5f19d}">
+        <p14:section name="05 Quản trị dự án" id="{81c09eda-362c-b355-9576-58968cc6a37a}">
           <p14:sldIdLst>
             <p14:sldId id="271"/>
             <p14:sldId id="272"/>
             <p14:sldId id="273"/>
           </p14:sldIdLst>
         </p14:section>
-        <p14:section name="06 Nguồn lực" id="{63c1fc0b-c402-4f50-c844-16ac448c2c03}">
+        <p14:section name="06 Nguồn lực" id="{a94ba674-fa7c-e44d-7be4-d814c5e209d8}">
           <p14:sldIdLst>
             <p14:sldId id="274"/>
             <p14:sldId id="275"/>
           </p14:sldIdLst>
         </p14:section>
-        <p14:section name="07 Công trình tiêu biểu" id="{90020c5c-f2e6-0fcf-af24-239c173347bd}">
+        <p14:section name="07 Công trình tiêu biểu" id="{39804bf8-fbe8-6e3e-b8b8-1b4eea5d317a}">
           <p14:sldIdLst>
             <p14:sldId id="276"/>
             <p14:sldId id="277"/>
@@ -188,7 +188,7 @@
             <p14:sldId id="279"/>
           </p14:sldIdLst>
         </p14:section>
-        <p14:section name="08 Cam kết &amp; liên hệ" id="{338a00be-480a-45c4-acd8-264fe094cda3}">
+        <p14:section name="08 Cam kết &amp; liên hệ" id="{b60fd2f7-9467-d1ac-5324-3c1442fc023c}">
           <p14:sldIdLst>
             <p14:sldId id="280"/>
             <p14:sldId id="281"/>
@@ -29363,51 +29363,39 @@
           </a:p>
         </p:txBody>
       </p:sp>
-      <p:sp>
-        <p:nvSpPr>
-          <p:cNvPr id="11" name="Text 9"/>
-          <p:cNvSpPr txBox="1"/>
-          <p:nvPr/>
-        </p:nvSpPr>
-        <p:spPr>
-          <a:xfrm>
-            <a:off x="4343400" y="7680960"/>
-            <a:ext cx="2715768" cy="228600"/>
-          </a:xfrm>
-          <a:prstGeom prst="rect">
-            <a:avLst/>
-          </a:prstGeom>
-          <a:noFill/>
-          <a:ln/>
-        </p:spPr>
-        <p:txBody>
-          <a:bodyPr wrap="square" lIns="0" tIns="0" rIns="0" bIns="0" rtlCol="0" anchor="ctr"/>
-          <a:lstStyle/>
-          <a:p>
-            <a:pPr algn="ctr" indent="0" marL="0">
-              <a:buNone/>
-            </a:pPr>
-            <a:r>
-              <a:rPr lang="en-US" sz="900" i="1" dirty="0">
-                <a:solidFill>
-                  <a:schemeClr val="accent3"/>
-                </a:solidFill>
-              </a:rPr>
-              <a:t>(Ký tên, đóng dấu)</a:t>
-            </a:r>
-            <a:endParaRPr lang="en-US" sz="900" dirty="0"/>
-          </a:p>
-        </p:txBody>
-      </p:sp>
-      <p:sp>
-        <p:nvSpPr>
-          <p:cNvPr id="12" name="Text 10"/>
-          <p:cNvSpPr txBox="1"/>
-          <p:nvPr/>
-        </p:nvSpPr>
-        <p:spPr>
-          <a:xfrm>
-            <a:off x="4343400" y="9189720"/>
+      <p:pic>
+        <p:nvPicPr>
+          <p:cNvPr id="11" name="chu ky va con dau" descr="Chữ ký và con dấu Giám đốc Hồ Văn Bình">    </p:cNvPr>
+          <p:cNvPicPr>
+            <a:picLocks noChangeAspect="1"/>
+          </p:cNvPicPr>
+          <p:nvPr/>
+        </p:nvPicPr>
+        <p:blipFill>
+          <a:blip r:embed="rId1"/>
+          <a:stretch>
+            <a:fillRect/>
+          </a:stretch>
+        </p:blipFill>
+        <p:spPr>
+          <a:xfrm>
+            <a:off x="4489704" y="7699248"/>
+            <a:ext cx="2423160" cy="1474089"/>
+          </a:xfrm>
+          <a:prstGeom prst="rect">
+            <a:avLst/>
+          </a:prstGeom>
+        </p:spPr>
+      </p:pic>
+      <p:sp>
+        <p:nvSpPr>
+          <p:cNvPr id="12" name="Text 9"/>
+          <p:cNvSpPr txBox="1"/>
+          <p:nvPr/>
+        </p:nvSpPr>
+        <p:spPr>
+          <a:xfrm>
+            <a:off x="4343400" y="9253728"/>
             <a:ext cx="2715768" cy="365760"/>
           </a:xfrm>
           <a:prstGeom prst="rect">

</xml_diff>

<commit_message>
Hồ sơ năng lực BLT: căn con dấu chính giữa dưới chức danh Giám đốc
Co-Authored-By: Claude Opus 5.5 <noreply@anthropic.com>
Claude-Session: https://claude.ai/code/session_01SkwAuDP5YjDrv41kDvnzWb
</commit_message>
<xml_diff>
--- a/ho-so-nang-luc-BLT/HO_SO_NANG_LUC_BLT.pptx
+++ b/ho-so-nang-luc-BLT/HO_SO_NANG_LUC_BLT.pptx
@@ -132,14 +132,14 @@
   <p:extLst>
     <p:ext uri="{521415D9-36F7-43E2-AB2F-B90AF26B5E84}">
       <p14:sectionLst xmlns:p14="http://schemas.microsoft.com/office/powerpoint/2010/main">
-        <p14:section name="Mở đầu" id="{479003c4-6f34-bf96-3845-18663b46f229}">
+        <p14:section name="Mở đầu" id="{64538fb7-0a3f-d64c-79eb-aaaad36e3f3c}">
           <p14:sldIdLst>
             <p14:sldId id="256"/>
             <p14:sldId id="257"/>
             <p14:sldId id="258"/>
           </p14:sldIdLst>
         </p14:section>
-        <p14:section name="01 Tổng quan" id="{0a1c5c49-7dde-9613-b806-8930a260762e}">
+        <p14:section name="01 Tổng quan" id="{6d0893c6-5e3d-7caa-ebcf-ae776fa63da8}">
           <p14:sldIdLst>
             <p14:sldId id="259"/>
             <p14:sldId id="260"/>
@@ -148,39 +148,39 @@
             <p14:sldId id="263"/>
           </p14:sldIdLst>
         </p14:section>
-        <p14:section name="02 Điện nước công trình" id="{a85db3c8-26cb-56c7-e8b8-42e85fd841fb}">
+        <p14:section name="02 Điện nước công trình" id="{8238293b-adcd-cbb5-2aef-12842f56cf9d}">
           <p14:sldIdLst>
             <p14:sldId id="264"/>
             <p14:sldId id="265"/>
             <p14:sldId id="266"/>
           </p14:sldIdLst>
         </p14:section>
-        <p14:section name="03 Hút sương dầu nhà xưởng" id="{9f1c3610-f719-a2f1-7a3a-fa089ccb5997}">
+        <p14:section name="03 Hút sương dầu nhà xưởng" id="{86fe865f-9474-5215-4dea-5d0400c6a036}">
           <p14:sldIdLst>
             <p14:sldId id="267"/>
             <p14:sldId id="268"/>
             <p14:sldId id="269"/>
           </p14:sldIdLst>
         </p14:section>
-        <p14:section name="04 Bơm &amp; xử lý nước" id="{6fdd7731-8046-e20f-c1c0-7a0ee682e0e1}">
+        <p14:section name="04 Bơm &amp; xử lý nước" id="{323fd865-b6ae-7e2c-fce1-1ae88a165718}">
           <p14:sldIdLst>
             <p14:sldId id="270"/>
           </p14:sldIdLst>
         </p14:section>
-        <p14:section name="05 Quản trị dự án" id="{81c09eda-362c-b355-9576-58968cc6a37a}">
+        <p14:section name="05 Quản trị dự án" id="{db4b06bd-85af-9d18-cc3e-1e08a7a7e7fc}">
           <p14:sldIdLst>
             <p14:sldId id="271"/>
             <p14:sldId id="272"/>
             <p14:sldId id="273"/>
           </p14:sldIdLst>
         </p14:section>
-        <p14:section name="06 Nguồn lực" id="{a94ba674-fa7c-e44d-7be4-d814c5e209d8}">
+        <p14:section name="06 Nguồn lực" id="{198ffc21-b3f2-0fae-8468-83561346dc7d}">
           <p14:sldIdLst>
             <p14:sldId id="274"/>
             <p14:sldId id="275"/>
           </p14:sldIdLst>
         </p14:section>
-        <p14:section name="07 Công trình tiêu biểu" id="{39804bf8-fbe8-6e3e-b8b8-1b4eea5d317a}">
+        <p14:section name="07 Công trình tiêu biểu" id="{e491d38a-24a9-98cb-a3ac-a460ff363f23}">
           <p14:sldIdLst>
             <p14:sldId id="276"/>
             <p14:sldId id="277"/>
@@ -188,7 +188,7 @@
             <p14:sldId id="279"/>
           </p14:sldIdLst>
         </p14:section>
-        <p14:section name="08 Cam kết &amp; liên hệ" id="{b60fd2f7-9467-d1ac-5324-3c1442fc023c}">
+        <p14:section name="08 Cam kết &amp; liên hệ" id="{2c6b1f7b-787e-f47d-9cb2-c234e401173f}">
           <p14:sldIdLst>
             <p14:sldId id="280"/>
             <p14:sldId id="281"/>
@@ -29296,8 +29296,8 @@
         </p:nvSpPr>
         <p:spPr>
           <a:xfrm>
-            <a:off x="4343400" y="7086600"/>
-            <a:ext cx="2715768" cy="274320"/>
+            <a:off x="4069080" y="7086600"/>
+            <a:ext cx="2990088" cy="274320"/>
           </a:xfrm>
           <a:prstGeom prst="rect">
             <a:avLst/>
@@ -29332,8 +29332,8 @@
         </p:nvSpPr>
         <p:spPr>
           <a:xfrm>
-            <a:off x="4343400" y="7406640"/>
-            <a:ext cx="2715768" cy="274320"/>
+            <a:off x="4069080" y="7406640"/>
+            <a:ext cx="2990088" cy="274320"/>
           </a:xfrm>
           <a:prstGeom prst="rect">
             <a:avLst/>
@@ -29379,8 +29379,8 @@
         </p:blipFill>
         <p:spPr>
           <a:xfrm>
-            <a:off x="4489704" y="7699248"/>
-            <a:ext cx="2423160" cy="1474089"/>
+            <a:off x="4871466" y="7726680"/>
+            <a:ext cx="2286000" cy="1390650"/>
           </a:xfrm>
           <a:prstGeom prst="rect">
             <a:avLst/>
@@ -29395,8 +29395,8 @@
         </p:nvSpPr>
         <p:spPr>
           <a:xfrm>
-            <a:off x="4343400" y="9253728"/>
-            <a:ext cx="2715768" cy="365760"/>
+            <a:off x="4069080" y="9253728"/>
+            <a:ext cx="2990088" cy="365760"/>
           </a:xfrm>
           <a:prstGeom prst="rect">
             <a:avLst/>

</xml_diff>

<commit_message>
Hồ sơ năng lực BLT: đổi nhãn chương trang thư ngỏ thành Thông điệp từ Giám đốc
Co-Authored-By: Claude Opus 5.5 <noreply@anthropic.com>
Claude-Session: https://claude.ai/code/session_01SkwAuDP5YjDrv41kDvnzWb
</commit_message>
<xml_diff>
--- a/ho-so-nang-luc-BLT/HO_SO_NANG_LUC_BLT.pptx
+++ b/ho-so-nang-luc-BLT/HO_SO_NANG_LUC_BLT.pptx
@@ -132,14 +132,14 @@
   <p:extLst>
     <p:ext uri="{521415D9-36F7-43E2-AB2F-B90AF26B5E84}">
       <p14:sectionLst xmlns:p14="http://schemas.microsoft.com/office/powerpoint/2010/main">
-        <p14:section name="Mở đầu" id="{64538fb7-0a3f-d64c-79eb-aaaad36e3f3c}">
+        <p14:section name="Mở đầu" id="{0bbe6c87-0f18-b580-3dcb-9a0b10d2f8fb}">
           <p14:sldIdLst>
             <p14:sldId id="256"/>
             <p14:sldId id="257"/>
             <p14:sldId id="258"/>
           </p14:sldIdLst>
         </p14:section>
-        <p14:section name="01 Tổng quan" id="{6d0893c6-5e3d-7caa-ebcf-ae776fa63da8}">
+        <p14:section name="01 Tổng quan" id="{ac0cc673-32c5-1565-ccf9-766058a62210}">
           <p14:sldIdLst>
             <p14:sldId id="259"/>
             <p14:sldId id="260"/>
@@ -148,39 +148,39 @@
             <p14:sldId id="263"/>
           </p14:sldIdLst>
         </p14:section>
-        <p14:section name="02 Điện nước công trình" id="{8238293b-adcd-cbb5-2aef-12842f56cf9d}">
+        <p14:section name="02 Điện nước công trình" id="{150747eb-7436-4157-338c-226eeb5c80be}">
           <p14:sldIdLst>
             <p14:sldId id="264"/>
             <p14:sldId id="265"/>
             <p14:sldId id="266"/>
           </p14:sldIdLst>
         </p14:section>
-        <p14:section name="03 Hút sương dầu nhà xưởng" id="{86fe865f-9474-5215-4dea-5d0400c6a036}">
+        <p14:section name="03 Hút sương dầu nhà xưởng" id="{79125877-9383-2eae-4e31-ecab98479aa2}">
           <p14:sldIdLst>
             <p14:sldId id="267"/>
             <p14:sldId id="268"/>
             <p14:sldId id="269"/>
           </p14:sldIdLst>
         </p14:section>
-        <p14:section name="04 Bơm &amp; xử lý nước" id="{323fd865-b6ae-7e2c-fce1-1ae88a165718}">
+        <p14:section name="04 Bơm &amp; xử lý nước" id="{a1d8c0b2-ca32-c826-de49-2fbe784e4031}">
           <p14:sldIdLst>
             <p14:sldId id="270"/>
           </p14:sldIdLst>
         </p14:section>
-        <p14:section name="05 Quản trị dự án" id="{db4b06bd-85af-9d18-cc3e-1e08a7a7e7fc}">
+        <p14:section name="05 Quản trị dự án" id="{4b217288-42b1-2982-4f70-0e96ca683951}">
           <p14:sldIdLst>
             <p14:sldId id="271"/>
             <p14:sldId id="272"/>
             <p14:sldId id="273"/>
           </p14:sldIdLst>
         </p14:section>
-        <p14:section name="06 Nguồn lực" id="{198ffc21-b3f2-0fae-8468-83561346dc7d}">
+        <p14:section name="06 Nguồn lực" id="{9c66aa22-187a-de66-ac88-31471de3d4e5}">
           <p14:sldIdLst>
             <p14:sldId id="274"/>
             <p14:sldId id="275"/>
           </p14:sldIdLst>
         </p14:section>
-        <p14:section name="07 Công trình tiêu biểu" id="{e491d38a-24a9-98cb-a3ac-a460ff363f23}">
+        <p14:section name="07 Công trình tiêu biểu" id="{68f5d6a3-e6b4-297d-7316-1d3d24b88726}">
           <p14:sldIdLst>
             <p14:sldId id="276"/>
             <p14:sldId id="277"/>
@@ -188,7 +188,7 @@
             <p14:sldId id="279"/>
           </p14:sldIdLst>
         </p14:section>
-        <p14:section name="08 Cam kết &amp; liên hệ" id="{2c6b1f7b-787e-f47d-9cb2-c234e401173f}">
+        <p14:section name="08 Cam kết &amp; liên hệ" id="{4c77920e-b937-72b3-8290-83ce20eece88}">
           <p14:sldIdLst>
             <p14:sldId id="280"/>
             <p14:sldId id="281"/>
@@ -28904,7 +28904,7 @@
                   <a:schemeClr val="accent1"/>
                 </a:solidFill>
               </a:rPr>
-              <a:t>TỔNG QUAN DOANH NGHIỆP</a:t>
+              <a:t>THÔNG ĐIỆP TỪ GIÁM ĐỐC</a:t>
             </a:r>
             <a:endParaRPr lang="en-US" sz="900" dirty="0"/>
           </a:p>

</xml_diff>

<commit_message>
Hồ sơ năng lực BLT: chuyển nhãn đội ngũ 100 nhân sự lên góc ảnh lớn trên bìa
Nhãn không còn che hàng ảnh nhỏ.

Co-Authored-By: Claude Opus 5.5 <noreply@anthropic.com>
Claude-Session: https://claude.ai/code/session_01SkwAuDP5YjDrv41kDvnzWb
</commit_message>
<xml_diff>
--- a/ho-so-nang-luc-BLT/HO_SO_NANG_LUC_BLT.pptx
+++ b/ho-so-nang-luc-BLT/HO_SO_NANG_LUC_BLT.pptx
@@ -132,14 +132,14 @@
   <p:extLst>
     <p:ext uri="{521415D9-36F7-43E2-AB2F-B90AF26B5E84}">
       <p14:sectionLst xmlns:p14="http://schemas.microsoft.com/office/powerpoint/2010/main">
-        <p14:section name="Mở đầu" id="{0bbe6c87-0f18-b580-3dcb-9a0b10d2f8fb}">
+        <p14:section name="Mở đầu" id="{5210eb87-2eec-e2b7-0645-4a9a6b3afc3f}">
           <p14:sldIdLst>
             <p14:sldId id="256"/>
             <p14:sldId id="257"/>
             <p14:sldId id="258"/>
           </p14:sldIdLst>
         </p14:section>
-        <p14:section name="01 Tổng quan" id="{ac0cc673-32c5-1565-ccf9-766058a62210}">
+        <p14:section name="01 Tổng quan" id="{e8836b11-c9b5-823c-92a1-685148a11d09}">
           <p14:sldIdLst>
             <p14:sldId id="259"/>
             <p14:sldId id="260"/>
@@ -148,39 +148,39 @@
             <p14:sldId id="263"/>
           </p14:sldIdLst>
         </p14:section>
-        <p14:section name="02 Điện nước công trình" id="{150747eb-7436-4157-338c-226eeb5c80be}">
+        <p14:section name="02 Điện nước công trình" id="{ad650f48-fa47-de60-7f6d-1ebdfa285152}">
           <p14:sldIdLst>
             <p14:sldId id="264"/>
             <p14:sldId id="265"/>
             <p14:sldId id="266"/>
           </p14:sldIdLst>
         </p14:section>
-        <p14:section name="03 Hút sương dầu nhà xưởng" id="{79125877-9383-2eae-4e31-ecab98479aa2}">
+        <p14:section name="03 Hút sương dầu nhà xưởng" id="{aa954143-323b-70a6-42ba-010334ff2c2a}">
           <p14:sldIdLst>
             <p14:sldId id="267"/>
             <p14:sldId id="268"/>
             <p14:sldId id="269"/>
           </p14:sldIdLst>
         </p14:section>
-        <p14:section name="04 Bơm &amp; xử lý nước" id="{a1d8c0b2-ca32-c826-de49-2fbe784e4031}">
+        <p14:section name="04 Bơm &amp; xử lý nước" id="{30d72375-f995-10f6-7aa4-0e32d59d5615}">
           <p14:sldIdLst>
             <p14:sldId id="270"/>
           </p14:sldIdLst>
         </p14:section>
-        <p14:section name="05 Quản trị dự án" id="{4b217288-42b1-2982-4f70-0e96ca683951}">
+        <p14:section name="05 Quản trị dự án" id="{ff1af035-8ac7-0547-8a00-40daa18ed449}">
           <p14:sldIdLst>
             <p14:sldId id="271"/>
             <p14:sldId id="272"/>
             <p14:sldId id="273"/>
           </p14:sldIdLst>
         </p14:section>
-        <p14:section name="06 Nguồn lực" id="{9c66aa22-187a-de66-ac88-31471de3d4e5}">
+        <p14:section name="06 Nguồn lực" id="{7db12cff-9614-0a7f-7e16-5d3d16b7aaf1}">
           <p14:sldIdLst>
             <p14:sldId id="274"/>
             <p14:sldId id="275"/>
           </p14:sldIdLst>
         </p14:section>
-        <p14:section name="07 Công trình tiêu biểu" id="{68f5d6a3-e6b4-297d-7316-1d3d24b88726}">
+        <p14:section name="07 Công trình tiêu biểu" id="{bca997de-3665-3664-f29a-f739d9af7bc8}">
           <p14:sldIdLst>
             <p14:sldId id="276"/>
             <p14:sldId id="277"/>
@@ -188,7 +188,7 @@
             <p14:sldId id="279"/>
           </p14:sldIdLst>
         </p14:section>
-        <p14:section name="08 Cam kết &amp; liên hệ" id="{4c77920e-b937-72b3-8290-83ce20eece88}">
+        <p14:section name="08 Cam kết &amp; liên hệ" id="{84bb1583-8c83-f3a5-e54c-4cd4ab330e43}">
           <p14:sldIdLst>
             <p14:sldId id="280"/>
             <p14:sldId id="281"/>
@@ -3749,7 +3749,7 @@
         </p:nvSpPr>
         <p:spPr>
           <a:xfrm>
-            <a:off x="4544568" y="6355080"/>
+            <a:off x="4773168" y="274320"/>
             <a:ext cx="2514600" cy="457200"/>
           </a:xfrm>
           <a:prstGeom prst="roundRect">
@@ -3776,7 +3776,7 @@
         </p:nvSpPr>
         <p:spPr>
           <a:xfrm>
-            <a:off x="4544568" y="6355080"/>
+            <a:off x="4773168" y="274320"/>
             <a:ext cx="2514600" cy="457200"/>
           </a:xfrm>
           <a:prstGeom prst="rect">

</xml_diff>